<commit_message>
Rebuild case-study slides on the Aiven brand theme, rewrite speaker notes in Jay's voice
</commit_message>
<xml_diff>
--- a/demo/slides/ato-case-study.pptx
+++ b/demo/slides/ato-case-study.pptx
@@ -18,8 +18,8 @@
   <p:notesMasterIdLst>
     <p:notesMasterId r:id="rId11"/>
   </p:notesMasterIdLst>
-  <p:sldSz cx="9144000" cy="5143500"/>
-  <p:notesSz cx="5143500" cy="9144000"/>
+  <p:sldSz cx="12192000" cy="6858000"/>
+  <p:notesSz cx="6858000" cy="12192000"/>
   <p:defaultTextStyle>
     <a:lvl1pPr marL="0" algn="l" defTabSz="914400" rtl="0" eaLnBrk="1" latinLnBrk="0" hangingPunct="1">
       <a:defRPr sz="1800" kern="1200">
@@ -112,28 +112,6 @@
       </a:defRPr>
     </a:lvl9pPr>
   </p:defaultTextStyle>
-  <p:extLst>
-    <p:ext uri="{521415D9-36F7-43E2-AB2F-B90AF26B5E84}">
-      <p14:sectionLst xmlns:p14="http://schemas.microsoft.com/office/powerpoint/2010/main">
-        <p14:section name="Case study: Not Another Pizza" id="{9efaabf6-4d00-c8be-c9e5-1a42042ae2f8}">
-          <p14:sldIdLst>
-            <p14:sldId id="256"/>
-            <p14:sldId id="257"/>
-            <p14:sldId id="258"/>
-            <p14:sldId id="259"/>
-            <p14:sldId id="260"/>
-            <p14:sldId id="261"/>
-            <p14:sldId id="262"/>
-            <p14:sldId id="263"/>
-            <p14:sldId id="264"/>
-          </p14:sldIdLst>
-        </p14:section>
-      </p14:sectionLst>
-    </p:ext>
-    <p:ext uri="{EFAFB233-063F-42B5-8137-9DF3F51BA10A}">
-      <p15:sldGuideLst xmlns:p15="http://schemas.microsoft.com/office/powerpoint/2012/main"/>
-    </p:ext>
-  </p:extLst>
 </p:presentation>
 </file>
 
@@ -165,7 +143,7 @@
           </c:tx>
           <c:spPr>
             <a:solidFill>
-              <a:srgbClr val="1BB2B0"/>
+              <a:srgbClr val="5FFA74"/>
             </a:solidFill>
             <a:effectLst/>
           </c:spPr>
@@ -376,7 +354,7 @@
           <c:showBubbleSize val="0"/>
           <c:showLeaderLines val="0"/>
         </c:dLbls>
-        <c:gapWidth val="150"/>
+        <c:gapWidth val="25"/>
         <c:overlap val="0"/>
         <c:axId val="2094734554"/>
         <c:axId val="2094734552"/>
@@ -389,35 +367,6 @@
         </c:scaling>
         <c:delete val="0"/>
         <c:axPos val="b"/>
-        <c:title>
-          <c:tx>
-            <c:rich>
-              <a:bodyPr/>
-              <a:lstStyle/>
-              <a:p>
-                <a:pPr>
-                  <a:defRPr sz="1200" b="0" i="0" u="none" strike="noStrike">
-                    <a:solidFill>
-                      <a:srgbClr val="B5B5B7"/>
-                    </a:solidFill>
-                    <a:latin typeface="Arial"/>
-                  </a:defRPr>
-                </a:pPr>
-                <a:r>
-                  <a:rPr sz="1200" b="0" i="0" u="none" strike="noStrike">
-                    <a:solidFill>
-                      <a:srgbClr val="B5B5B7"/>
-                    </a:solidFill>
-                    <a:latin typeface="Arial"/>
-                  </a:rPr>
-                  <a:t>hour (UTC), 7 Oct 11:00 to 8 Oct 09:00</a:t>
-                </a:r>
-              </a:p>
-            </c:rich>
-          </c:tx>
-          <c:layout/>
-          <c:overlay val="0"/>
-        </c:title>
         <c:numFmt formatCode="General" sourceLinked="1"/>
         <c:majorTickMark val="out"/>
         <c:minorTickMark val="none"/>
@@ -438,9 +387,9 @@
             <a:pPr>
               <a:defRPr sz="1200" b="0" i="0" u="none" strike="noStrike">
                 <a:solidFill>
-                  <a:srgbClr val="B5B5B7"/>
+                  <a:srgbClr val="8D9098"/>
                 </a:solidFill>
-                <a:latin typeface="+mn-lt"/>
+                <a:latin typeface="Geist Mono"/>
               </a:defRPr>
             </a:pPr>
             <a:endParaRPr lang="en-US"/>
@@ -457,21 +406,22 @@
         <c:scaling>
           <c:orientation val="minMax"/>
           <c:max val="1400"/>
+          <c:min val="0"/>
         </c:scaling>
         <c:delete val="0"/>
         <c:axPos val="l"/>
         <c:majorGridlines>
           <c:spPr>
-            <a:ln w="6350" cap="flat">
+            <a:ln w="9525" cap="flat">
               <a:solidFill>
-                <a:srgbClr val="444547"/>
+                <a:srgbClr val="22252D"/>
               </a:solidFill>
               <a:prstDash val="solid"/>
               <a:round/>
             </a:ln>
           </c:spPr>
         </c:majorGridlines>
-        <c:numFmt formatCode="General" sourceLinked="0"/>
+        <c:numFmt formatCode="#,##0" sourceLinked="0"/>
         <c:majorTickMark val="out"/>
         <c:minorTickMark val="none"/>
         <c:tickLblPos val="nextTo"/>
@@ -491,9 +441,9 @@
             <a:pPr>
               <a:defRPr sz="1200" b="0" i="0" u="none" strike="noStrike">
                 <a:solidFill>
-                  <a:srgbClr val="B5B5B7"/>
+                  <a:srgbClr val="8D9098"/>
                 </a:solidFill>
-                <a:latin typeface="+mn-lt"/>
+                <a:latin typeface="Geist Mono"/>
               </a:defRPr>
             </a:pPr>
             <a:endParaRPr lang="en-US"/>
@@ -923,11 +873,10 @@
           <a:p>
             <a:r>
               <a:rPr lang="en-US" dirty="0"/>
-              <a:t>WHERE THIS FITS: insert as a block of nine slides straight after your "Script" slide (slide 9), before "Why not start with a deployable system" (slide 10). It is one worked example of everything slides 5-11 say in the abstract: prompt -&gt; skill -&gt; script -&gt; deployable system.
-THE POINT IN ONE LINE: we used a script wherever the answer was knowable, and an agent only for the one step that needed judgement, and we measured what that cost.
-BACKGROUND: search.notanother.pizza (the project you credit on slide 13) indexes community meetup groups from Meetup and Luma. Hugh Evans built it. We found that most of the groups it knew about had never actually been scraped.
-TIMING: about 1.5 minutes per slide, so roughly 12-14 minutes for the block. If you are short on time, cut slides 3 and 5 (the two short script videos) and keep 2, 4, 6 and 8.
-IF EMBEDDED VIDEO DOES NOT SURVIVE THE IMPORT into Google Slides: upload the three MP4s (01_backlog, 02_agent_triage, 03_queue) to Drive and use Insert &gt; Video &gt; Google Drive on the slide.</a:t>
+              <a:t>Okay. So far I've told you a lot of rules. Prompt, then skill, then script, then a deployable system. That's all a bit abstract, so here's a real one.
+Hugh built this thing called Not Another Pizza. It's a search index of community meetups, tens of thousands of them. And we used it to try out my whole theory: script the boring bits, and only bring in an agent for the one bit that needs a brain.
+Nine slides, about twelve minutes. If I'm running long, I'll skip the two little script videos.
+[Fits: straight after the Script slide, before "Skip the line". If your running order changes, it works anywhere after the prompt, skill, script idea has landed. If the videos don't play after import, upload the three mp4s to Drive and use Insert, Video, Google Drive.]</a:t>
             </a:r>
             <a:endParaRPr lang="en-US" dirty="0"/>
           </a:p>
@@ -1015,11 +964,10 @@
           <a:p>
             <a:r>
               <a:rPr lang="en-US" dirty="0"/>
-              <a:t>WHERE THIS FITS: this is your "You need data" idea (slide 12) made concrete, so it can also sit directly before slide 12 if you prefer to tell it in two parts.
-WHAT TO SAY: the index lists 43,425 groups, but only 15,442 were actually in it. The rest were found by discovery but never scraped. Nobody noticed because every search still returned something.
-WHY IT MATTERS FOR YOUR TALK: this is the "you don't know what you're missing" point from your Continuous Iteration Trap slide (slide 4). Context is defined by data, and here the data was silently incomplete. A model sitting on top of this would have confidently answered from 36% of the picture.
-THE SCREENSHOT is the live site before the fix: 15,442 groups and 13 results for "kafka".
-CAUTION: this number is as of 7 October 2026. The index has since grown, which slides 7 and 8 show.</a:t>
+              <a:t>Here's the bit nobody noticed. The index thought it knew about forty three thousand groups. It had actually scraped fifteen. Sixty four percent of them had never been looked at.
+And you'd never know. Every search still gives you something back. It looks fine. That's the "you don't know what you're missing" slide from earlier, except now it's real.
+Imagine putting a model on top of that. It would answer you with total confidence from about a third of the picture.
+[Fits: this is the "you'll need a datastore" point in real life. Numbers are from the 7th of October. The screenshot is the live site before the fix: 15,442 groups, and "kafka" finds 13.]</a:t>
             </a:r>
             <a:endParaRPr lang="en-US" dirty="0"/>
           </a:p>
@@ -1107,11 +1055,10 @@
           <a:p>
             <a:r>
               <a:rPr lang="en-US" dirty="0"/>
-              <a:t>WHERE THIS FITS: this is your "Script" slide (slide 9) with a real example, and it answers your slide 8 question, "Is this a problem that AI needs to architect on a daily?" No.
-VIDEO (3 seconds, silent): 01_backlog.mp4. It prints: 43,425 listed, 15,442 in the index, 27,981 never scraped (64%), tokens used 0, wall clock 0.11s.
-WHAT TO SAY: "Yesterday's solution is not always today's best solution. We could have asked a model 'which groups are missing?' and paid for it every time. A set difference between two lists answers it in a tenth of a second, for free, every time, and it is the same answer on the thousandth run."
-LINK TO YOUR ARC: prompt -&gt; skill -&gt; script. This is the script end. The cost of this step does not grow with how often you run it, which matters when you show the cost-by-cadence table on slide 6 of this block.
-IF THE VIDEO DOES NOT PLAY: it is a 3-second terminal recording; read the four numbers out instead.</a:t>
+              <a:t>So how do we find the gap? Do we ask a model? No. It's two lists. You take the groups we know about, you take what's in the index, and you subtract one from the other.
+A tenth of a second. Zero tokens. And it gives you the same answer on the thousandth run.
+Which is the answer to my "why can't I just ask?" slide. You can. You really shouldn't.
+[Video is three seconds and silent. Read the numbers out loud: 43,425 listed, 15,442 in the index, 27,981 never scraped, tokens used zero. Fits right after your "Why can't I just ask" slide, or alongside Script.]</a:t>
             </a:r>
             <a:endParaRPr lang="en-US" dirty="0"/>
           </a:p>
@@ -1199,13 +1146,11 @@
           <a:p>
             <a:r>
               <a:rPr lang="en-US" dirty="0"/>
-              <a:t>WHERE THIS FITS: after "Script", as the one place an agent is justified. It also lands your slide 6 and 7 contrast (prompt engineering vs skill engineering): this agent has a narrow brief and two tools, not an open-ended prompt.
-VIDEO (53 seconds, silent): 02_agent_triage.mp4. For each of 25 never-scraped groups the agent looks at the group's public page and labels it priority 1 (active tech/developer/data community), 2 (normal) or 3 (hobby/social/dormant), with a one-line reason. A running cost counter ticks up on the right. It finishes at 45,860 input and 5,522 output tokens, $0.0735, about $0.003 a group.
-WHAT TO SAY: "This is the only step that needs judgement: is this group worth scraping before the others? Everything around it is a script. The agent can't scrape, write to the database or change the queue. It only recommends."
-LINK TO YOUR SLIDES 3-4: this is how you know what you're spending. The counter is the point, not the labels.
-RESULT: 4 of 25 came out priority 1 (an AI community, a React Native community, a SharePoint developer group, a tech meetup), 4 priority 2, 17 priority 3.
-IMPORTANT, SAY THIS OUT LOUD: we measured cost, not quality. Nobody has checked whether those four picks are right. Treat them as examples, not as a result. (The last slide of this block says it again.)
-MODEL AND GATEWAY: Claude Haiku 4.5, called through the Aiven AI gateway so usage is metered per key.</a:t>
+              <a:t>Now here's where I'd actually pay for an agent. We've got twenty eight thousand missing groups. Which do we scrape first? Is this a React Native community or a book club? That's a judgement call. A script can't make it.
+So we gave an agent exactly two tools. Look at a group. Write down a priority. That's it. It can't scrape, it can't write to the database, it can't touch the queue.
+Watch the counter. That's the stove. Twenty five groups, seven cents. About a third of a cent a group.
+Four of them came out priority one. And I'll be straight with you: nobody has checked whether those picks are right. They're examples, not a result.
+[Video is fifty three seconds, silent. Fits with the "Don't leave the stove on" and "Continuous Iteration Trap" slides. Model is Claude Haiku 4.5 through the Aiven AI gateway, which meters usage per key.]</a:t>
             </a:r>
             <a:endParaRPr lang="en-US" dirty="0"/>
           </a:p>
@@ -1293,11 +1238,9 @@
           <a:p>
             <a:r>
               <a:rPr lang="en-US" dirty="0"/>
-              <a:t>WHERE THIS FITS: still on your "Script" slide (slide 9). It shows the boundary between the agent and the system around it.
-VIDEO (3 seconds, silent): 03_queue.mp4. It reads the agent's output and moves the four priority-1 groups to the front of the 27,981-group queue.
-WHAT TO SAY: "The agent returned a list. A script, not the agent, turned that list into a queue. That is deliberate: the part that has to be reliable is deterministic code, and the part that needs a human-like judgement is the model."
-LINK TO YOUR GOVERNANCE SLIDES (22-26): Access means "enough to do the exact job and no more". The agent has two tools and no write access. If it is wrong, the worst case is a group scraped a little later.
-CAN BE CUT if you are short of time. Slide 3's video already makes the script point.</a:t>
+              <a:t>And then we go straight back to a script. The agent hands over a list. A script turns that list into a queue and moves the good ones to the front.
+The agent decides. Code does the work. If the agent's wrong, the worst thing that happens is a group gets scraped a bit later. That's your "enough access to do the job and no more" slide, just out in the wild.
+[Fits with the Access slide in the governance section. This is the easiest one to cut if you're short on time. The first script video already makes the point.]</a:t>
             </a:r>
             <a:endParaRPr lang="en-US" dirty="0"/>
           </a:p>
@@ -1385,11 +1328,10 @@
           <a:p>
             <a:r>
               <a:rPr lang="en-US" dirty="0"/>
-              <a:t>WHERE THIS FITS: this is the "Cost? Run once, run weekly, 1000 runs" prompt on your Continuous Iteration Trap slide (slide 4). Put it right after or in place of that slide's placeholder.
-THE NUMBERS: measured on a real run of 25 groups, 45,860 input and 5,522 output tokens, $0.0735 at Claude Haiku 4.5 list price. $0.0735 / 25 = $0.00294 a group. 1,000 runs of 25 groups = about $74. Triaging all 27,981 groups once = about $82.
-WHAT TO SAY: "The script costs nothing at any cadence. The agent's cost scales with how often you ask it to think. So the question is not 'agent or script' but 'which step actually needs thinking', and how often do you run it."
-CAVEATS: this is list price and a 25-group sample, extrapolated. The Aiven AI gateway shows the real metered cost per access key; if that differs, use the console figure.
-LINK TO YOUR SLIDE 8: "AI will burn your token budget down". This is the counter-example: a bounded agent with a known cost.</a:t>
+              <a:t>Remember on the iteration trap slide I said: run it once, run it weekly, run it a thousand times? Here's that table.
+The script costs nothing. Every time. The agent is seven cents for twenty five groups. A thousand runs of that is about seventy four dollars. Triaging the whole backlog is about eighty two.
+So it's not really agent versus script. It's: which step actually needs to think, and how often are you going to ask it to?
+[Honest caveats: this is list price, from a twenty five group sample, stretched out. The Aiven AI gateway shows the real metered cost per key, so swap that number in if it's different.]</a:t>
             </a:r>
             <a:endParaRPr lang="en-US" dirty="0"/>
           </a:p>
@@ -1477,11 +1419,10 @@
           <a:p>
             <a:r>
               <a:rPr lang="en-US" dirty="0"/>
-              <a:t>WHERE THIS FITS: your "Why not start with a deployable system instead?" and "Deployable System" slides (10 and 11), and the "Aiven Runtimes" idea. Put it directly after slide 11.
-THE STORY: the scraper runs as an Aiven App writing to Aiven Postgres. It never reached the missing groups: the app was building from a stale branch whose group list predated about 26,000 later-discovered groups, and it worked through that list in file order. The fix was to order by what is already in the database (never-scraped first, then stalest) and to ship the full list. Once deployed it ran at a steady 1,150 groups an hour: the database went from about 17,000 to 42,068 groups in 24 hours.
-WHAT TO SAY: "The thing that fixed it was boring: a script that reads state from the database instead of from a file in the container. That is what a deployable system gives you: state that survives restarts."
-TO ADD BY HAND (not in this file): a screenshot of the Aiven console showing the batch app's logs with '[n/43419]' on slide 10 or 11. It proves the deployment and the scale.
-ACCURACY: the first bar (11:00) is partial because the scraper started around 11:30. The figures are from the production database on 8 October.</a:t>
+              <a:t>Fixing the actual bug was boring. The scraper was working through an old list in file order, and it never got to the new groups. So we changed it to ask the database what it already had, do the unseen ones first, then the stalest.
+We put it on an Aiven App, next to Aiven Postgres, and left it running. Seventeen thousand groups to forty two thousand in a day. About eleven hundred an hour, dead steady.
+That's the whole point of the deployable system slide. The state lives in the database, so a restart doesn't lose your place.
+[Fits with Deployable System and Aiven Runtimes. If you want proof on the slide, add a screenshot of the Aiven console showing the batch app logs, something like "n of 43,419". The first bar is partial because the scraper started halfway through that hour.]</a:t>
             </a:r>
             <a:endParaRPr lang="en-US" dirty="0"/>
           </a:p>
@@ -1569,11 +1510,10 @@
           <a:p>
             <a:r>
               <a:rPr lang="en-US" dirty="0"/>
-              <a:t>WHERE THIS FITS: slide 13, your shout-out to notanother.pizza and Hugh Evans. This slide is the payoff for that credit.
-THE NUMBERS (live site, before 6-7 October, after 8 October): groups 15,442 -&gt; 40,550; events 829,236 -&gt; 2,029,657. The search "data engineering" went from 10 to 33 results; "kafka" from 13 to 20. The site's displayed counts differ slightly from the database (43,414 groups) because it is rendered once a day.
-HONEST NOTE: not every search grew. "python AND london" returned 1 result both before and after. More data does not mean more of every answer.
-WHAT TO SAY: "Same site, same query, same code. The only change was the data behind it. That is your 'you need data' point, and it is why the governance slides matter: structure, visibility, access and context only work if the data is actually there."
-SHOUT-OUT: Hugh Evans built and maintains this project; search.notanother.pizza.</a:t>
+              <a:t>Same site. Same search. Same code. The only thing that changed is the data. "Data engineering" went from ten results to thirty three.
+Not everything grew, mind. "Python and London" gave one result before and one after. More data doesn't mean more of everything. But it's the difference between a search that's guessing and one that actually knows.
+Which is why I keep going on about data.
+[Fits right before the Shoutouts slide, so the thank you to Hugh Evans and search.notanother.pizza lands as the payoff. Figures: groups 15,442 to 40,550, events 829,236 to 2,029,657. The site updates once a day, so it lags the database a little.]</a:t>
             </a:r>
             <a:endParaRPr lang="en-US" dirty="0"/>
           </a:p>
@@ -1661,12 +1601,10 @@
           <a:p>
             <a:r>
               <a:rPr lang="en-US" dirty="0"/>
-              <a:t>WHERE THIS FITS: close the block with this, then continue to your "How can companies leverage AI post-hype?" slide (14). It is also the honest version of your slide 3 ("Are you actually seeing ROI?").
-THE THREE THINGS:
-1. We measured what the agent cost, not whether its priority-1 picks are right. A proper check would compare its labels against a human-labelled sample.
-2. The cost figures are a 25-group run at Claude Haiku 4.5 list price, extrapolated to the full backlog. Use the Aiven gateway's per-key figure for the exact number.
-3. We made a mistake and caught it. The first Luma fix read 'past events' from a page that actually returns upcoming events, so it would have labelled future events as past. The label looked right; the dates were in the future. The corrected version uses Luma's own calendar API and refuses to label an event past unless its start is in the past. 746 of 765 Luma groups now have real past events, 37,233 in total, and none has a future date.
-WHAT TO SAY: "Cost and quality both have to be measured. Cutting cost without measuring quality just buys you retries, and retries are the most expensive tokens."</a:t>
+              <a:t>Last one of the block, and it's the honest one. We measured what the agent cost. We did not measure whether it was right.
+Those four priority one groups are examples, not a result. The cost is a twenty five group sample at list price, stretched out. And our first fix for the Luma scraper was wrong. It read past events from a page that actually shows upcoming ones, so it labelled future events as past. It looked right until we checked the dates.
+So: measure cost, measure quality. Otherwise you pay for retries, and retries are where the money goes.
+[Then straight into the "how can companies leverage AI post-hype" section. Luma facts if asked: 746 of 765 Luma groups now have real past events, 37,233 in total, none with a future date.]</a:t>
             </a:r>
             <a:endParaRPr lang="en-US" dirty="0"/>
           </a:p>
@@ -1738,199 +1676,6 @@
 </p:sldLayout>
 </file>
 
-<file path=ppt/slideLayouts/slideLayout2.xml><?xml version="1.0" encoding="utf-8"?>
-<p:sldLayout xmlns:a="http://schemas.openxmlformats.org/drawingml/2006/main" xmlns:r="http://schemas.openxmlformats.org/officeDocument/2006/relationships" xmlns:p="http://schemas.openxmlformats.org/presentationml/2006/main" preserve="1">
-  <p:cSld name="CONTENT">
-    <p:bg>
-      <p:bgPr>
-        <a:solidFill>
-          <a:schemeClr val="tx1"/>
-        </a:solidFill>
-      </p:bgPr>
-    </p:bg>
-    <p:spTree>
-      <p:nvGrpSpPr>
-        <p:cNvPr id="1" name=""/>
-        <p:cNvGrpSpPr/>
-        <p:nvPr/>
-      </p:nvGrpSpPr>
-      <p:grpSpPr>
-        <a:xfrm>
-          <a:off x="0" y="0"/>
-          <a:ext cx="0" cy="0"/>
-          <a:chOff x="0" y="0"/>
-          <a:chExt cx="0" cy="0"/>
-        </a:xfrm>
-      </p:grpSpPr>
-      <p:sp>
-        <p:nvSpPr>
-          <p:cNvPr id="25" name="Slide Number Placeholder 0"/>
-          <p:cNvSpPr>
-            <a:spLocks noGrp="1"/>
-          </p:cNvSpPr>
-          <p:nvPr>
-            <p:ph type="sldNum" sz="quarter" idx="4294967295"/>
-          </p:nvPr>
-        </p:nvSpPr>
-        <p:spPr>
-          <a:xfrm>
-            <a:off x="8412480" y="4754880"/>
-            <a:ext cx="457200" cy="274320"/>
-          </a:xfrm>
-          <a:prstGeom prst="rect">
-            <a:avLst/>
-          </a:prstGeom>
-          <a:extLst>
-            <a:ext uri="{C572A759-6A51-4108-AA02-DFA0A04FC94B}">
-              <ma14:wrappingTextBoxFlag xmlns:ma14="http://schemas.microsoft.com/office/mac/drawingml/2011/main" val="0"/>
-            </a:ext>
-          </a:extLst>
-        </p:spPr>
-        <p:txBody>
-          <a:bodyPr/>
-          <a:lstStyle>
-            <a:lvl1pPr>
-              <a:defRPr sz="1000">
-                <a:solidFill>
-                  <a:schemeClr val="accent6"/>
-                </a:solidFill>
-              </a:defRPr>
-            </a:lvl1pPr>
-          </a:lstStyle>
-          <a:p>
-            <a:pPr algn="l"/>
-            <a:fld id="{F7021451-1387-4CA6-816F-3879F97B5CBC}" type="slidenum">
-              <a:rPr b="0" lang="en-US"/>
-              <a:t>1002</a:t>
-            </a:fld>
-            <a:endParaRPr lang="en-US"/>
-          </a:p>
-        </p:txBody>
-      </p:sp>
-    </p:spTree>
-  </p:cSld>
-  <p:clrMapOvr>
-    <a:masterClrMapping/>
-  </p:clrMapOvr>
-</p:sldLayout>
-</file>
-
-<file path=ppt/slideLayouts/slideLayout3.xml><?xml version="1.0" encoding="utf-8"?>
-<p:sldLayout xmlns:a="http://schemas.openxmlformats.org/drawingml/2006/main" xmlns:r="http://schemas.openxmlformats.org/officeDocument/2006/relationships" xmlns:p="http://schemas.openxmlformats.org/presentationml/2006/main" preserve="1">
-  <p:cSld name="CONTENT_TITLE">
-    <p:bg>
-      <p:bgPr>
-        <a:solidFill>
-          <a:schemeClr val="tx1"/>
-        </a:solidFill>
-      </p:bgPr>
-    </p:bg>
-    <p:spTree>
-      <p:nvGrpSpPr>
-        <p:cNvPr id="1" name=""/>
-        <p:cNvGrpSpPr/>
-        <p:nvPr/>
-      </p:nvGrpSpPr>
-      <p:grpSpPr>
-        <a:xfrm>
-          <a:off x="0" y="0"/>
-          <a:ext cx="0" cy="0"/>
-          <a:chOff x="0" y="0"/>
-          <a:chExt cx="0" cy="0"/>
-        </a:xfrm>
-      </p:grpSpPr>
-      <p:sp>
-        <p:nvSpPr>
-          <p:cNvPr id="2" name="Text 0"/>
-          <p:cNvSpPr/>
-          <p:nvPr>
-            <p:ph idx="100" type="title" hasCustomPrompt="1"/>
-          </p:nvPr>
-        </p:nvSpPr>
-        <p:spPr>
-          <a:xfrm>
-            <a:off x="457200" y="274320"/>
-            <a:ext cx="8229600" cy="822960"/>
-          </a:xfrm>
-          <a:prstGeom prst="rect">
-            <a:avLst/>
-          </a:prstGeom>
-          <a:noFill/>
-          <a:ln/>
-        </p:spPr>
-        <p:txBody>
-          <a:bodyPr wrap="square" rtlCol="0"/>
-          <a:lstStyle>
-            <a:lvl1pPr indent="0" marL="0">
-              <a:buNone/>
-              <a:defRPr lang="en-US" sz="3000" b="1" dirty="0">
-                <a:solidFill>
-                  <a:schemeClr val="bg1"/>
-                </a:solidFill>
-              </a:defRPr>
-            </a:lvl1pPr>
-          </a:lstStyle>
-          <a:p>
-            <a:pPr indent="0" marL="0">
-              <a:buNone/>
-            </a:pPr>
-            <a:endParaRPr lang="en-US" sz="3000" dirty="0"/>
-          </a:p>
-        </p:txBody>
-      </p:sp>
-      <p:sp>
-        <p:nvSpPr>
-          <p:cNvPr id="25" name="Slide Number Placeholder 0"/>
-          <p:cNvSpPr>
-            <a:spLocks noGrp="1"/>
-          </p:cNvSpPr>
-          <p:nvPr>
-            <p:ph type="sldNum" sz="quarter" idx="4294967295"/>
-          </p:nvPr>
-        </p:nvSpPr>
-        <p:spPr>
-          <a:xfrm>
-            <a:off x="8412480" y="4754880"/>
-            <a:ext cx="457200" cy="274320"/>
-          </a:xfrm>
-          <a:prstGeom prst="rect">
-            <a:avLst/>
-          </a:prstGeom>
-          <a:extLst>
-            <a:ext uri="{C572A759-6A51-4108-AA02-DFA0A04FC94B}">
-              <ma14:wrappingTextBoxFlag xmlns:ma14="http://schemas.microsoft.com/office/mac/drawingml/2011/main" val="0"/>
-            </a:ext>
-          </a:extLst>
-        </p:spPr>
-        <p:txBody>
-          <a:bodyPr/>
-          <a:lstStyle>
-            <a:lvl1pPr>
-              <a:defRPr sz="1000">
-                <a:solidFill>
-                  <a:schemeClr val="accent6"/>
-                </a:solidFill>
-              </a:defRPr>
-            </a:lvl1pPr>
-          </a:lstStyle>
-          <a:p>
-            <a:pPr algn="l"/>
-            <a:fld id="{F7021451-1387-4CA6-816F-3879F97B5CBC}" type="slidenum">
-              <a:rPr b="0" lang="en-US"/>
-              <a:t>1003</a:t>
-            </a:fld>
-            <a:endParaRPr lang="en-US"/>
-          </a:p>
-        </p:txBody>
-      </p:sp>
-    </p:spTree>
-  </p:cSld>
-  <p:clrMapOvr>
-    <a:masterClrMapping/>
-  </p:clrMapOvr>
-</p:sldLayout>
-</file>
-
 <file path=ppt/slideMasters/slideMaster1.xml><?xml version="1.0" encoding="utf-8"?>
 <p:sldMaster xmlns:a="http://schemas.openxmlformats.org/drawingml/2006/main" xmlns:r="http://schemas.openxmlformats.org/officeDocument/2006/relationships" xmlns:p="http://schemas.openxmlformats.org/presentationml/2006/main">
   <p:cSld>
@@ -1948,58 +1693,11 @@
           <a:chExt cx="0" cy="0"/>
         </a:xfrm>
       </p:grpSpPr>
-      <p:sp>
-        <p:nvSpPr>
-          <p:cNvPr id="25" name="Slide Number Placeholder 0"/>
-          <p:cNvSpPr>
-            <a:spLocks noGrp="1"/>
-          </p:cNvSpPr>
-          <p:nvPr>
-            <p:ph type="sldNum" sz="quarter" idx="4294967295"/>
-          </p:nvPr>
-        </p:nvSpPr>
-        <p:spPr>
-          <a:xfrm>
-            <a:off x="8412480" y="4754880"/>
-            <a:ext cx="457200" cy="274320"/>
-          </a:xfrm>
-          <a:prstGeom prst="rect">
-            <a:avLst/>
-          </a:prstGeom>
-          <a:extLst>
-            <a:ext uri="{C572A759-6A51-4108-AA02-DFA0A04FC94B}">
-              <ma14:wrappingTextBoxFlag xmlns:ma14="http://schemas.microsoft.com/office/mac/drawingml/2011/main" val="0"/>
-            </a:ext>
-          </a:extLst>
-        </p:spPr>
-        <p:txBody>
-          <a:bodyPr/>
-          <a:lstStyle>
-            <a:lvl1pPr>
-              <a:defRPr sz="1000">
-                <a:solidFill>
-                  <a:schemeClr val="accent6"/>
-                </a:solidFill>
-              </a:defRPr>
-            </a:lvl1pPr>
-          </a:lstStyle>
-          <a:p>
-            <a:pPr algn="l"/>
-            <a:fld id="{F7021451-1387-4CA6-816F-3879F97B5CBC}" type="slidenum">
-              <a:rPr b="0" lang="en-US"/>
-              <a:t>null</a:t>
-            </a:fld>
-            <a:endParaRPr lang="en-US"/>
-          </a:p>
-        </p:txBody>
-      </p:sp>
     </p:spTree>
   </p:cSld>
   <p:clrMap bg1="lt1" tx1="dk1" bg2="lt2" tx2="dk2" accent1="accent1" accent2="accent2" accent3="accent3" accent4="accent4" accent5="accent5" accent6="accent6" hlink="hlink" folHlink="folHlink"/>
   <p:sldLayoutIdLst>
     <p:sldLayoutId id="2147483649" r:id="rId1"/>
-    <p:sldLayoutId id="2147483650" r:id="rId2"/>
-    <p:sldLayoutId id="2147483651" r:id="rId3"/>
   </p:sldLayoutIdLst>
   <p:hf sldNum="0" hdr="0" ftr="0" dt="0"/>
   <p:txStyles>
@@ -2258,6 +1956,13 @@
 <file path=ppt/slides/slide1.xml><?xml version="1.0" encoding="utf-8"?>
 <p:sld xmlns:a="http://schemas.openxmlformats.org/drawingml/2006/main" xmlns:r="http://schemas.openxmlformats.org/officeDocument/2006/relationships" xmlns:p="http://schemas.openxmlformats.org/presentationml/2006/main">
   <p:cSld name="Slide 1">
+    <p:bg>
+      <p:bgPr>
+        <a:solidFill>
+          <a:srgbClr val="05080F"/>
+        </a:solidFill>
+      </p:bgPr>
+    </p:bg>
     <p:spTree>
       <p:nvGrpSpPr>
         <p:cNvPr id="1" name=""/>
@@ -2272,16 +1977,64 @@
           <a:chExt cx="0" cy="0"/>
         </a:xfrm>
       </p:grpSpPr>
-      <p:sp>
-        <p:nvSpPr>
-          <p:cNvPr id="2" name="Text 0"/>
+      <p:pic>
+        <p:nvPicPr>
+          <p:cNvPr id="2" name="Image 0" descr="preencoded.png">    </p:cNvPr>
+          <p:cNvPicPr>
+            <a:picLocks noChangeAspect="1"/>
+          </p:cNvPicPr>
+          <p:nvPr/>
+        </p:nvPicPr>
+        <p:blipFill>
+          <a:blip r:embed="rId1"/>
+          <a:stretch>
+            <a:fillRect/>
+          </a:stretch>
+        </p:blipFill>
+        <p:spPr>
+          <a:xfrm>
+            <a:off x="9544050" y="-254000"/>
+            <a:ext cx="3282950" cy="7366000"/>
+          </a:xfrm>
+          <a:prstGeom prst="rect">
+            <a:avLst/>
+          </a:prstGeom>
+        </p:spPr>
+      </p:pic>
+      <p:pic>
+        <p:nvPicPr>
+          <p:cNvPr id="3" name="Image 1" descr="preencoded.png">    </p:cNvPr>
+          <p:cNvPicPr>
+            <a:picLocks noChangeAspect="1"/>
+          </p:cNvPicPr>
+          <p:nvPr/>
+        </p:nvPicPr>
+        <p:blipFill>
+          <a:blip r:embed="rId2"/>
+          <a:stretch>
+            <a:fillRect/>
+          </a:stretch>
+        </p:blipFill>
+        <p:spPr>
+          <a:xfrm>
+            <a:off x="1270000" y="4572000"/>
+            <a:ext cx="1333500" cy="2794000"/>
+          </a:xfrm>
+          <a:prstGeom prst="rect">
+            <a:avLst/>
+          </a:prstGeom>
+        </p:spPr>
+      </p:pic>
+      <p:sp>
+        <p:nvSpPr>
+          <p:cNvPr id="4" name="Text 0"/>
           <p:cNvSpPr txBox="1"/>
           <p:nvPr/>
         </p:nvSpPr>
         <p:spPr>
           <a:xfrm>
-            <a:off x="457200" y="182880"/>
-            <a:ext cx="8229600" cy="274320"/>
+            <a:off x="635000" y="2406650"/>
+            <a:ext cx="10922000" cy="165100"/>
           </a:xfrm>
           <a:prstGeom prst="rect">
             <a:avLst/>
@@ -2290,34 +2043,99 @@
           <a:ln/>
         </p:spPr>
         <p:txBody>
-          <a:bodyPr wrap="square" lIns="0" tIns="0" rIns="0" bIns="0" rtlCol="0" anchor="ctr"/>
+          <a:bodyPr wrap="square" lIns="0" tIns="0" rIns="0" bIns="0" rtlCol="0" anchor="t"/>
           <a:lstStyle/>
           <a:p>
             <a:pPr indent="0" marL="0">
               <a:buNone/>
             </a:pPr>
             <a:r>
-              <a:rPr lang="en-US" sz="1200" b="1" spc="300" kern="0" dirty="0">
+              <a:rPr lang="en-US" sz="1350" spc="200" kern="0" dirty="0">
                 <a:solidFill>
-                  <a:schemeClr val="accent1"/>
+                  <a:srgbClr val="5FFA74"/>
                 </a:solidFill>
+                <a:latin typeface="Geist Mono" pitchFamily="34" charset="0"/>
+                <a:ea typeface="Geist Mono" pitchFamily="34" charset="-122"/>
+                <a:cs typeface="Geist Mono" pitchFamily="34" charset="-120"/>
               </a:rPr>
-              <a:t>CASE STUDY</a:t>
-            </a:r>
-            <a:endParaRPr lang="en-US" sz="1200" dirty="0"/>
-          </a:p>
-        </p:txBody>
-      </p:sp>
-      <p:sp>
-        <p:nvSpPr>
-          <p:cNvPr id="3" name="Text 1"/>
+              <a:t>// CASE STUDY</a:t>
+            </a:r>
+            <a:endParaRPr lang="en-US" sz="1350" dirty="0"/>
+          </a:p>
+        </p:txBody>
+      </p:sp>
+      <p:sp>
+        <p:nvSpPr>
+          <p:cNvPr id="5" name="Text 1"/>
           <p:cNvSpPr txBox="1"/>
           <p:nvPr/>
         </p:nvSpPr>
         <p:spPr>
           <a:xfrm>
-            <a:off x="457200" y="1188720"/>
-            <a:ext cx="7863840" cy="1737360"/>
+            <a:off x="635000" y="2698750"/>
+            <a:ext cx="6985000" cy="1016000"/>
+          </a:xfrm>
+          <a:prstGeom prst="rect">
+            <a:avLst/>
+          </a:prstGeom>
+          <a:noFill/>
+          <a:ln/>
+        </p:spPr>
+        <p:txBody>
+          <a:bodyPr wrap="square" lIns="0" tIns="0" rIns="0" bIns="0" rtlCol="0" anchor="t"/>
+          <a:lstStyle/>
+          <a:p>
+            <a:pPr indent="0" marL="0">
+              <a:lnSpc>
+                <a:spcPct val="100000"/>
+              </a:lnSpc>
+              <a:buNone/>
+            </a:pPr>
+            <a:r>
+              <a:rPr lang="en-US" sz="6000" dirty="0">
+                <a:solidFill>
+                  <a:srgbClr val="FFFFFF"/>
+                </a:solidFill>
+                <a:latin typeface="Funnel Display ExtraBold" pitchFamily="34" charset="0"/>
+                <a:ea typeface="Funnel Display ExtraBold" pitchFamily="34" charset="-122"/>
+                <a:cs typeface="Funnel Display ExtraBold" pitchFamily="34" charset="-120"/>
+              </a:rPr>
+              <a:t>NOT ANOTHER</a:t>
+            </a:r>
+            <a:endParaRPr lang="en-US" sz="6000" dirty="0"/>
+          </a:p>
+          <a:p>
+            <a:pPr indent="0" marL="0">
+              <a:lnSpc>
+                <a:spcPct val="100000"/>
+              </a:lnSpc>
+              <a:buNone/>
+            </a:pPr>
+            <a:r>
+              <a:rPr lang="en-US" sz="6000" dirty="0">
+                <a:solidFill>
+                  <a:srgbClr val="FFFFFF"/>
+                </a:solidFill>
+                <a:latin typeface="Funnel Display ExtraBold" pitchFamily="34" charset="0"/>
+                <a:ea typeface="Funnel Display ExtraBold" pitchFamily="34" charset="-122"/>
+                <a:cs typeface="Funnel Display ExtraBold" pitchFamily="34" charset="-120"/>
+              </a:rPr>
+              <a:t>PIZZA</a:t>
+            </a:r>
+            <a:endParaRPr lang="en-US" sz="6000" dirty="0"/>
+          </a:p>
+        </p:txBody>
+      </p:sp>
+      <p:sp>
+        <p:nvSpPr>
+          <p:cNvPr id="6" name="Text 2"/>
+          <p:cNvSpPr txBox="1"/>
+          <p:nvPr/>
+        </p:nvSpPr>
+        <p:spPr>
+          <a:xfrm>
+            <a:off x="635000" y="3917950"/>
+            <a:ext cx="6350000" cy="571500"/>
           </a:xfrm>
           <a:prstGeom prst="rect">
             <a:avLst/>
@@ -2333,95 +2151,34 @@
               <a:buNone/>
             </a:pPr>
             <a:r>
-              <a:rPr lang="en-US" sz="3400" b="1" dirty="0">
+              <a:rPr lang="en-US" sz="2250" dirty="0">
                 <a:solidFill>
-                  <a:schemeClr val="bg1"/>
+                  <a:srgbClr val="FFFFFF"/>
                 </a:solidFill>
+                <a:latin typeface="Inter" pitchFamily="34" charset="0"/>
+                <a:ea typeface="Inter" pitchFamily="34" charset="-122"/>
+                <a:cs typeface="Inter" pitchFamily="34" charset="-120"/>
               </a:rPr>
-              <a:t>Not Another Pizza: a script for the boring parts, an agent for the judgement</a:t>
-            </a:r>
-            <a:endParaRPr lang="en-US" sz="3400" dirty="0"/>
-          </a:p>
-        </p:txBody>
-      </p:sp>
-      <p:sp>
-        <p:nvSpPr>
-          <p:cNvPr id="4" name="Text 2"/>
-          <p:cNvSpPr txBox="1"/>
-          <p:nvPr/>
-        </p:nvSpPr>
-        <p:spPr>
-          <a:xfrm>
-            <a:off x="457200" y="3200400"/>
-            <a:ext cx="7863840" cy="731520"/>
-          </a:xfrm>
-          <a:prstGeom prst="rect">
-            <a:avLst/>
-          </a:prstGeom>
-          <a:noFill/>
-          <a:ln/>
-        </p:spPr>
-        <p:txBody>
-          <a:bodyPr wrap="square" lIns="0" tIns="0" rIns="0" bIns="0" rtlCol="0" anchor="t"/>
-          <a:lstStyle/>
+              <a:t>A script for the boring parts.</a:t>
+            </a:r>
+            <a:endParaRPr lang="en-US" sz="2250" dirty="0"/>
+          </a:p>
           <a:p>
             <a:pPr indent="0" marL="0">
               <a:buNone/>
             </a:pPr>
             <a:r>
-              <a:rPr lang="en-US" sz="2000" dirty="0">
+              <a:rPr lang="en-US" sz="2250" dirty="0">
                 <a:solidFill>
-                  <a:schemeClr val="bg2"/>
+                  <a:srgbClr val="FFFFFF"/>
                 </a:solidFill>
+                <a:latin typeface="Inter" pitchFamily="34" charset="0"/>
+                <a:ea typeface="Inter" pitchFamily="34" charset="-122"/>
+                <a:cs typeface="Inter" pitchFamily="34" charset="-120"/>
               </a:rPr>
-              <a:t>A real index of 43,000 community meetup groups, and what it took to fix it</a:t>
-            </a:r>
-            <a:endParaRPr lang="en-US" sz="2000" dirty="0"/>
-          </a:p>
-        </p:txBody>
-      </p:sp>
-      <p:sp>
-        <p:nvSpPr>
-          <p:cNvPr id="25" name="Slide Number Placeholder 0"/>
-          <p:cNvSpPr>
-            <a:spLocks noGrp="1"/>
-          </p:cNvSpPr>
-          <p:nvPr>
-            <p:ph type="sldNum" sz="quarter" idx="4294967295"/>
-          </p:nvPr>
-        </p:nvSpPr>
-        <p:spPr>
-          <a:xfrm>
-            <a:off x="8412480" y="4754880"/>
-            <a:ext cx="457200" cy="274320"/>
-          </a:xfrm>
-          <a:prstGeom prst="rect">
-            <a:avLst/>
-          </a:prstGeom>
-          <a:extLst>
-            <a:ext uri="{C572A759-6A51-4108-AA02-DFA0A04FC94B}">
-              <ma14:wrappingTextBoxFlag xmlns:ma14="http://schemas.microsoft.com/office/mac/drawingml/2011/main" val="0"/>
-            </a:ext>
-          </a:extLst>
-        </p:spPr>
-        <p:txBody>
-          <a:bodyPr/>
-          <a:lstStyle>
-            <a:lvl1pPr>
-              <a:defRPr sz="1000">
-                <a:solidFill>
-                  <a:schemeClr val="accent6"/>
-                </a:solidFill>
-              </a:defRPr>
-            </a:lvl1pPr>
-          </a:lstStyle>
-          <a:p>
-            <a:pPr algn="l"/>
-            <a:fld id="{F7021451-1387-4CA6-816F-3879F97B5CBC}" type="slidenum">
-              <a:rPr b="0" lang="en-US"/>
-              <a:t>1</a:t>
-            </a:fld>
-            <a:endParaRPr lang="en-US"/>
+              <a:t>An agent for the judgement.</a:t>
+            </a:r>
+            <a:endParaRPr lang="en-US" sz="2250" dirty="0"/>
           </a:p>
         </p:txBody>
       </p:sp>
@@ -2436,6 +2193,20 @@
 <file path=ppt/slides/slide2.xml><?xml version="1.0" encoding="utf-8"?>
 <p:sld xmlns:a="http://schemas.openxmlformats.org/drawingml/2006/main" xmlns:r="http://schemas.openxmlformats.org/officeDocument/2006/relationships" xmlns:p="http://schemas.openxmlformats.org/presentationml/2006/main">
   <p:cSld name="Slide 2">
+    <p:bg>
+      <p:bgPr>
+        <a:blipFill dpi="0" rotWithShape="1">
+          <a:blip r:embed="rId1">
+            <a:lum/>
+          </a:blip>
+          <a:srcRect/>
+          <a:stretch>
+            <a:fillRect/>
+          </a:stretch>
+        </a:blipFill>
+        <a:effectLst/>
+      </p:bgPr>
+    </p:bg>
     <p:spTree>
       <p:nvGrpSpPr>
         <p:cNvPr id="1" name=""/>
@@ -2453,15 +2224,13 @@
       <p:sp>
         <p:nvSpPr>
           <p:cNvPr id="2" name="Text 0"/>
-          <p:cNvSpPr/>
-          <p:nvPr>
-            <p:ph idx="100" type="title" hasCustomPrompt="1"/>
-          </p:nvPr>
-        </p:nvSpPr>
-        <p:spPr>
-          <a:xfrm>
-            <a:off x="457200" y="274320"/>
-            <a:ext cx="8229600" cy="822960"/>
+          <p:cNvSpPr txBox="1"/>
+          <p:nvPr/>
+        </p:nvSpPr>
+        <p:spPr>
+          <a:xfrm>
+            <a:off x="635000" y="635000"/>
+            <a:ext cx="10922000" cy="165100"/>
           </a:xfrm>
           <a:prstGeom prst="rect">
             <a:avLst/>
@@ -2477,14 +2246,17 @@
               <a:buNone/>
             </a:pPr>
             <a:r>
-              <a:rPr lang="en-US" sz="3000" b="1" dirty="0">
+              <a:rPr lang="en-US" sz="1350" spc="200" kern="0" dirty="0">
                 <a:solidFill>
-                  <a:schemeClr val="bg1"/>
+                  <a:srgbClr val="5FFA74"/>
                 </a:solidFill>
+                <a:latin typeface="Geist Mono" pitchFamily="34" charset="0"/>
+                <a:ea typeface="Geist Mono" pitchFamily="34" charset="-122"/>
+                <a:cs typeface="Geist Mono" pitchFamily="34" charset="-120"/>
               </a:rPr>
-              <a:t>64% of the index was missing</a:t>
-            </a:r>
-            <a:endParaRPr lang="en-US" sz="3000" dirty="0"/>
+              <a:t>// THE PROBLEM</a:t>
+            </a:r>
+            <a:endParaRPr lang="en-US" sz="1350" dirty="0"/>
           </a:p>
         </p:txBody>
       </p:sp>
@@ -2496,8 +2268,8 @@
         </p:nvSpPr>
         <p:spPr>
           <a:xfrm>
-            <a:off x="457200" y="1280160"/>
-            <a:ext cx="3840480" cy="1371600"/>
+            <a:off x="635000" y="927100"/>
+            <a:ext cx="10922000" cy="391160"/>
           </a:xfrm>
           <a:prstGeom prst="rect">
             <a:avLst/>
@@ -2506,21 +2278,24 @@
           <a:ln/>
         </p:spPr>
         <p:txBody>
-          <a:bodyPr wrap="square" lIns="0" tIns="0" rIns="0" bIns="0" rtlCol="0" anchor="ctr"/>
+          <a:bodyPr wrap="square" lIns="0" tIns="0" rIns="0" bIns="0" rtlCol="0" anchor="t"/>
           <a:lstStyle/>
           <a:p>
             <a:pPr indent="0" marL="0">
               <a:buNone/>
             </a:pPr>
             <a:r>
-              <a:rPr lang="en-US" sz="9600" b="1" dirty="0">
+              <a:rPr lang="en-US" sz="4200" dirty="0">
                 <a:solidFill>
-                  <a:schemeClr val="accent1"/>
+                  <a:srgbClr val="FFFFFF"/>
                 </a:solidFill>
+                <a:latin typeface="Funnel Display ExtraBold" pitchFamily="34" charset="0"/>
+                <a:ea typeface="Funnel Display ExtraBold" pitchFamily="34" charset="-122"/>
+                <a:cs typeface="Funnel Display ExtraBold" pitchFamily="34" charset="-120"/>
               </a:rPr>
-              <a:t>64%</a:t>
-            </a:r>
-            <a:endParaRPr lang="en-US" sz="9600" dirty="0"/>
+              <a:t>64% OF THE INDEX WAS MISSING</a:t>
+            </a:r>
+            <a:endParaRPr lang="en-US" sz="4200" dirty="0"/>
           </a:p>
         </p:txBody>
       </p:sp>
@@ -2532,8 +2307,8 @@
         </p:nvSpPr>
         <p:spPr>
           <a:xfrm>
-            <a:off x="457200" y="2743200"/>
-            <a:ext cx="3840480" cy="1188720"/>
+            <a:off x="635000" y="1587500"/>
+            <a:ext cx="4445000" cy="1371600"/>
           </a:xfrm>
           <a:prstGeom prst="rect">
             <a:avLst/>
@@ -2549,58 +2324,93 @@
               <a:buNone/>
             </a:pPr>
             <a:r>
-              <a:rPr lang="en-US" sz="1800" dirty="0">
+              <a:rPr lang="en-US" sz="18000" dirty="0">
                 <a:solidFill>
-                  <a:schemeClr val="bg1"/>
+                  <a:srgbClr val="5FFA74"/>
                 </a:solidFill>
+                <a:latin typeface="Funnel Display ExtraBold" pitchFamily="34" charset="0"/>
+                <a:ea typeface="Funnel Display ExtraBold" pitchFamily="34" charset="-122"/>
+                <a:cs typeface="Funnel Display ExtraBold" pitchFamily="34" charset="-120"/>
+              </a:rPr>
+              <a:t>64%</a:t>
+            </a:r>
+            <a:endParaRPr lang="en-US" sz="18000" dirty="0"/>
+          </a:p>
+        </p:txBody>
+      </p:sp>
+      <p:sp>
+        <p:nvSpPr>
+          <p:cNvPr id="5" name="Text 3"/>
+          <p:cNvSpPr txBox="1"/>
+          <p:nvPr/>
+        </p:nvSpPr>
+        <p:spPr>
+          <a:xfrm>
+            <a:off x="635000" y="3162300"/>
+            <a:ext cx="4445000" cy="952500"/>
+          </a:xfrm>
+          <a:prstGeom prst="rect">
+            <a:avLst/>
+          </a:prstGeom>
+          <a:noFill/>
+          <a:ln/>
+        </p:spPr>
+        <p:txBody>
+          <a:bodyPr wrap="square" lIns="0" tIns="0" rIns="0" bIns="0" rtlCol="0" anchor="t"/>
+          <a:lstStyle/>
+          <a:p>
+            <a:pPr indent="0" marL="0">
+              <a:buNone/>
+            </a:pPr>
+            <a:r>
+              <a:rPr lang="en-US" sz="2250" dirty="0">
+                <a:solidFill>
+                  <a:srgbClr val="FFFFFF"/>
+                </a:solidFill>
+                <a:latin typeface="Inter" pitchFamily="34" charset="0"/>
+                <a:ea typeface="Inter" pitchFamily="34" charset="-122"/>
+                <a:cs typeface="Inter" pitchFamily="34" charset="-120"/>
               </a:rPr>
               <a:t>27,981 of 43,425 listed groups had never been scraped, so searches could not find them.</a:t>
             </a:r>
-            <a:endParaRPr lang="en-US" sz="1800" dirty="0"/>
+            <a:endParaRPr lang="en-US" sz="2250" dirty="0"/>
           </a:p>
         </p:txBody>
       </p:sp>
       <p:pic>
         <p:nvPicPr>
-          <p:cNvPr id="5" name="Image 0" descr="/Users/hugh/repos/meetup-map/demo/out/before-search-1.png">    </p:cNvPr>
+          <p:cNvPr id="6" name="Image 0" descr="/Users/hugh/repos/meetup-map/demo/out/before-search-1.png">    </p:cNvPr>
           <p:cNvPicPr>
             <a:picLocks noChangeAspect="1"/>
           </p:cNvPicPr>
           <p:nvPr/>
         </p:nvPicPr>
         <p:blipFill>
-          <a:blip r:embed="rId1"/>
+          <a:blip r:embed="rId2"/>
           <a:stretch>
             <a:fillRect/>
           </a:stretch>
         </p:blipFill>
         <p:spPr>
           <a:xfrm>
-            <a:off x="4572000" y="1325880"/>
-            <a:ext cx="4114800" cy="2569464"/>
-          </a:xfrm>
-          <a:prstGeom prst="rect">
-            <a:avLst/>
-          </a:prstGeom>
-          <a:effectLst>
-            <a:outerShdw sx="100000" sy="100000" kx="0" ky="0" algn="bl" rotWithShape="0" blurRad="101600" dist="38100" dir="5400000">
-              <a:srgbClr val="000000">
-                <a:alpha val="40000"/>
-              </a:srgbClr>
-            </a:outerShdw>
-          </a:effectLst>
+            <a:off x="5588000" y="1587500"/>
+            <a:ext cx="5715000" cy="3568700"/>
+          </a:xfrm>
+          <a:prstGeom prst="rect">
+            <a:avLst/>
+          </a:prstGeom>
         </p:spPr>
       </p:pic>
       <p:sp>
         <p:nvSpPr>
-          <p:cNvPr id="6" name="Text 3"/>
+          <p:cNvPr id="7" name="Text 4"/>
           <p:cNvSpPr txBox="1"/>
           <p:nvPr/>
         </p:nvSpPr>
         <p:spPr>
           <a:xfrm>
-            <a:off x="4572000" y="4023360"/>
-            <a:ext cx="4114800" cy="457200"/>
+            <a:off x="5588000" y="5283200"/>
+            <a:ext cx="5715000" cy="228600"/>
           </a:xfrm>
           <a:prstGeom prst="rect">
             <a:avLst/>
@@ -2609,66 +2419,38 @@
           <a:ln/>
         </p:spPr>
         <p:txBody>
-          <a:bodyPr wrap="square" lIns="0" tIns="0" rIns="0" bIns="0" rtlCol="0" anchor="ctr"/>
+          <a:bodyPr wrap="square" lIns="0" tIns="0" rIns="0" bIns="0" rtlCol="0" anchor="t"/>
           <a:lstStyle/>
           <a:p>
             <a:pPr indent="0" marL="0">
               <a:buNone/>
             </a:pPr>
             <a:r>
-              <a:rPr lang="en-US" sz="1400" dirty="0">
+              <a:rPr lang="en-US" sz="1650" b="1" dirty="0">
                 <a:solidFill>
-                  <a:schemeClr val="bg2"/>
+                  <a:srgbClr val="FFFFFF"/>
                 </a:solidFill>
+                <a:latin typeface="Inter" pitchFamily="34" charset="0"/>
+                <a:ea typeface="Inter" pitchFamily="34" charset="-122"/>
+                <a:cs typeface="Inter" pitchFamily="34" charset="-120"/>
               </a:rPr>
-              <a:t>Before: 15,442 groups indexed. 'kafka' found 13.</a:t>
-            </a:r>
-            <a:endParaRPr lang="en-US" sz="1400" dirty="0"/>
-          </a:p>
-        </p:txBody>
-      </p:sp>
-      <p:sp>
-        <p:nvSpPr>
-          <p:cNvPr id="25" name="Slide Number Placeholder 0"/>
-          <p:cNvSpPr>
-            <a:spLocks noGrp="1"/>
-          </p:cNvSpPr>
-          <p:nvPr>
-            <p:ph type="sldNum" sz="quarter" idx="4294967295"/>
-          </p:nvPr>
-        </p:nvSpPr>
-        <p:spPr>
-          <a:xfrm>
-            <a:off x="8412480" y="4754880"/>
-            <a:ext cx="457200" cy="274320"/>
-          </a:xfrm>
-          <a:prstGeom prst="rect">
-            <a:avLst/>
-          </a:prstGeom>
-          <a:extLst>
-            <a:ext uri="{C572A759-6A51-4108-AA02-DFA0A04FC94B}">
-              <ma14:wrappingTextBoxFlag xmlns:ma14="http://schemas.microsoft.com/office/mac/drawingml/2011/main" val="0"/>
-            </a:ext>
-          </a:extLst>
-        </p:spPr>
-        <p:txBody>
-          <a:bodyPr/>
-          <a:lstStyle>
-            <a:lvl1pPr>
-              <a:defRPr sz="1000">
+              <a:t>Before: </a:t>
+            </a:r>
+            <a:pPr indent="0" marL="0">
+              <a:buNone/>
+            </a:pPr>
+            <a:r>
+              <a:rPr lang="en-US" sz="1650" dirty="0">
                 <a:solidFill>
-                  <a:schemeClr val="accent6"/>
+                  <a:srgbClr val="8D9098"/>
                 </a:solidFill>
-              </a:defRPr>
-            </a:lvl1pPr>
-          </a:lstStyle>
-          <a:p>
-            <a:pPr algn="l"/>
-            <a:fld id="{F7021451-1387-4CA6-816F-3879F97B5CBC}" type="slidenum">
-              <a:rPr b="0" lang="en-US"/>
-              <a:t>2</a:t>
-            </a:fld>
-            <a:endParaRPr lang="en-US"/>
+                <a:latin typeface="Inter" pitchFamily="34" charset="0"/>
+                <a:ea typeface="Inter" pitchFamily="34" charset="-122"/>
+                <a:cs typeface="Inter" pitchFamily="34" charset="-120"/>
+              </a:rPr>
+              <a:t>15,442 groups indexed. "kafka" found 13.</a:t>
+            </a:r>
+            <a:endParaRPr lang="en-US" sz="1650" dirty="0"/>
           </a:p>
         </p:txBody>
       </p:sp>
@@ -2683,6 +2465,20 @@
 <file path=ppt/slides/slide3.xml><?xml version="1.0" encoding="utf-8"?>
 <p:sld xmlns:a="http://schemas.openxmlformats.org/drawingml/2006/main" xmlns:r="http://schemas.openxmlformats.org/officeDocument/2006/relationships" xmlns:p="http://schemas.openxmlformats.org/presentationml/2006/main">
   <p:cSld name="Slide 3">
+    <p:bg>
+      <p:bgPr>
+        <a:blipFill dpi="0" rotWithShape="1">
+          <a:blip r:embed="rId1">
+            <a:lum/>
+          </a:blip>
+          <a:srcRect/>
+          <a:stretch>
+            <a:fillRect/>
+          </a:stretch>
+        </a:blipFill>
+        <a:effectLst/>
+      </p:bgPr>
+    </p:bg>
     <p:spTree>
       <p:nvGrpSpPr>
         <p:cNvPr id="1" name=""/>
@@ -2700,15 +2496,13 @@
       <p:sp>
         <p:nvSpPr>
           <p:cNvPr id="2" name="Text 0"/>
-          <p:cNvSpPr/>
-          <p:nvPr>
-            <p:ph idx="100" type="title" hasCustomPrompt="1"/>
-          </p:nvPr>
-        </p:nvSpPr>
-        <p:spPr>
-          <a:xfrm>
-            <a:off x="457200" y="274320"/>
-            <a:ext cx="8229600" cy="822960"/>
+          <p:cNvSpPr txBox="1"/>
+          <p:nvPr/>
+        </p:nvSpPr>
+        <p:spPr>
+          <a:xfrm>
+            <a:off x="635000" y="635000"/>
+            <a:ext cx="10922000" cy="165100"/>
           </a:xfrm>
           <a:prstGeom prst="rect">
             <a:avLst/>
@@ -2724,44 +2518,86 @@
               <a:buNone/>
             </a:pPr>
             <a:r>
-              <a:rPr lang="en-US" sz="3000" b="1" dirty="0">
+              <a:rPr lang="en-US" sz="1350" spc="200" kern="0" dirty="0">
                 <a:solidFill>
-                  <a:schemeClr val="bg1"/>
+                  <a:srgbClr val="5FFA74"/>
                 </a:solidFill>
+                <a:latin typeface="Geist Mono" pitchFamily="34" charset="0"/>
+                <a:ea typeface="Geist Mono" pitchFamily="34" charset="-122"/>
+                <a:cs typeface="Geist Mono" pitchFamily="34" charset="-120"/>
               </a:rPr>
-              <a:t>A script found the gap: 0.1s, 0 tokens</a:t>
-            </a:r>
-            <a:endParaRPr lang="en-US" sz="3000" dirty="0"/>
+              <a:t>// THE SCRIPT</a:t>
+            </a:r>
+            <a:endParaRPr lang="en-US" sz="1350" dirty="0"/>
+          </a:p>
+        </p:txBody>
+      </p:sp>
+      <p:sp>
+        <p:nvSpPr>
+          <p:cNvPr id="3" name="Text 1"/>
+          <p:cNvSpPr txBox="1"/>
+          <p:nvPr/>
+        </p:nvSpPr>
+        <p:spPr>
+          <a:xfrm>
+            <a:off x="635000" y="927100"/>
+            <a:ext cx="10922000" cy="391160"/>
+          </a:xfrm>
+          <a:prstGeom prst="rect">
+            <a:avLst/>
+          </a:prstGeom>
+          <a:noFill/>
+          <a:ln/>
+        </p:spPr>
+        <p:txBody>
+          <a:bodyPr wrap="square" lIns="0" tIns="0" rIns="0" bIns="0" rtlCol="0" anchor="t"/>
+          <a:lstStyle/>
+          <a:p>
+            <a:pPr indent="0" marL="0">
+              <a:buNone/>
+            </a:pPr>
+            <a:r>
+              <a:rPr lang="en-US" sz="4200" dirty="0">
+                <a:solidFill>
+                  <a:srgbClr val="FFFFFF"/>
+                </a:solidFill>
+                <a:latin typeface="Funnel Display ExtraBold" pitchFamily="34" charset="0"/>
+                <a:ea typeface="Funnel Display ExtraBold" pitchFamily="34" charset="-122"/>
+                <a:cs typeface="Funnel Display ExtraBold" pitchFamily="34" charset="-120"/>
+              </a:rPr>
+              <a:t>A SCRIPT FOUND THE GAP</a:t>
+            </a:r>
+            <a:endParaRPr lang="en-US" sz="4200" dirty="0"/>
           </a:p>
         </p:txBody>
       </p:sp>
       <p:pic>
         <p:nvPicPr>
-          <p:cNvPr id="3" name="Media 0">
+          <p:cNvPr id="4" name="Media 0">
             <a:hlinkClick r:id="" action="ppaction://media"/>
           </p:cNvPr>
           <p:cNvPicPr>
             <a:picLocks noChangeAspect="1"/>
           </p:cNvPicPr>
           <p:nvPr>
-            <a:videoFile r:link="rId1"/>
+            <a:videoFile r:link="rId2"/>
             <p:extLst>
               <p:ext uri="{DAA4B4D4-6D71-4841-9C94-3DE7FCFB9230}">
-                <p14:media xmlns:p14="http://schemas.microsoft.com/office/powerpoint/2010/main" r:embed="rId2"/>
+                <p14:media xmlns:p14="http://schemas.microsoft.com/office/powerpoint/2010/main" r:embed="rId3"/>
               </p:ext>
             </p:extLst>
           </p:nvPr>
         </p:nvPicPr>
         <p:blipFill>
-          <a:blip r:embed="rId3"/>
+          <a:blip r:embed="rId4"/>
           <a:stretch>
             <a:fillRect/>
           </a:stretch>
         </p:blipFill>
         <p:spPr>
           <a:xfrm>
-            <a:off x="1371600" y="1234440"/>
-            <a:ext cx="6400800" cy="2834640"/>
+            <a:off x="635000" y="1587500"/>
+            <a:ext cx="6604000" cy="3714750"/>
           </a:xfrm>
           <a:prstGeom prst="rect">
             <a:avLst/>
@@ -2770,14 +2606,14 @@
       </p:pic>
       <p:sp>
         <p:nvSpPr>
-          <p:cNvPr id="4" name="Text 1"/>
+          <p:cNvPr id="5" name="Text 2"/>
           <p:cNvSpPr txBox="1"/>
           <p:nvPr/>
         </p:nvSpPr>
         <p:spPr>
           <a:xfrm>
-            <a:off x="457200" y="4434840"/>
-            <a:ext cx="8229600" cy="457200"/>
+            <a:off x="635000" y="5429250"/>
+            <a:ext cx="6604000" cy="228600"/>
           </a:xfrm>
           <a:prstGeom prst="rect">
             <a:avLst/>
@@ -2786,66 +2622,102 @@
           <a:ln/>
         </p:spPr>
         <p:txBody>
-          <a:bodyPr wrap="square" lIns="0" tIns="0" rIns="0" bIns="0" rtlCol="0" anchor="ctr"/>
+          <a:bodyPr wrap="square" lIns="0" tIns="0" rIns="0" bIns="0" rtlCol="0" anchor="t"/>
           <a:lstStyle/>
           <a:p>
             <a:pPr indent="0" marL="0">
               <a:buNone/>
             </a:pPr>
             <a:r>
-              <a:rPr lang="en-US" sz="1400" dirty="0">
+              <a:rPr lang="en-US" sz="1650" dirty="0">
                 <a:solidFill>
-                  <a:schemeClr val="bg2"/>
+                  <a:srgbClr val="8D9098"/>
                 </a:solidFill>
+                <a:latin typeface="Inter" pitchFamily="34" charset="0"/>
+                <a:ea typeface="Inter" pitchFamily="34" charset="-122"/>
+                <a:cs typeface="Inter" pitchFamily="34" charset="-120"/>
               </a:rPr>
               <a:t>Compare the group list with the index. No model needed.</a:t>
             </a:r>
-            <a:endParaRPr lang="en-US" sz="1400" dirty="0"/>
-          </a:p>
-        </p:txBody>
-      </p:sp>
-      <p:sp>
-        <p:nvSpPr>
-          <p:cNvPr id="25" name="Slide Number Placeholder 0"/>
-          <p:cNvSpPr>
-            <a:spLocks noGrp="1"/>
-          </p:cNvSpPr>
-          <p:nvPr>
-            <p:ph type="sldNum" sz="quarter" idx="4294967295"/>
-          </p:nvPr>
-        </p:nvSpPr>
-        <p:spPr>
-          <a:xfrm>
-            <a:off x="8412480" y="4754880"/>
-            <a:ext cx="457200" cy="274320"/>
-          </a:xfrm>
-          <a:prstGeom prst="rect">
-            <a:avLst/>
-          </a:prstGeom>
-          <a:extLst>
-            <a:ext uri="{C572A759-6A51-4108-AA02-DFA0A04FC94B}">
-              <ma14:wrappingTextBoxFlag xmlns:ma14="http://schemas.microsoft.com/office/mac/drawingml/2011/main" val="0"/>
-            </a:ext>
-          </a:extLst>
-        </p:spPr>
-        <p:txBody>
-          <a:bodyPr/>
-          <a:lstStyle>
-            <a:lvl1pPr>
-              <a:defRPr sz="1000">
+            <a:endParaRPr lang="en-US" sz="1650" dirty="0"/>
+          </a:p>
+        </p:txBody>
+      </p:sp>
+      <p:sp>
+        <p:nvSpPr>
+          <p:cNvPr id="6" name="Text 3"/>
+          <p:cNvSpPr txBox="1"/>
+          <p:nvPr/>
+        </p:nvSpPr>
+        <p:spPr>
+          <a:xfrm>
+            <a:off x="7747000" y="1587500"/>
+            <a:ext cx="3810000" cy="904875"/>
+          </a:xfrm>
+          <a:prstGeom prst="rect">
+            <a:avLst/>
+          </a:prstGeom>
+          <a:noFill/>
+          <a:ln/>
+        </p:spPr>
+        <p:txBody>
+          <a:bodyPr wrap="square" lIns="0" tIns="0" rIns="0" bIns="0" rtlCol="0" anchor="t"/>
+          <a:lstStyle/>
+          <a:p>
+            <a:pPr indent="0" marL="0">
+              <a:buNone/>
+            </a:pPr>
+            <a:r>
+              <a:rPr lang="en-US" sz="11250" dirty="0">
                 <a:solidFill>
-                  <a:schemeClr val="accent6"/>
+                  <a:srgbClr val="5FFA74"/>
                 </a:solidFill>
-              </a:defRPr>
-            </a:lvl1pPr>
-          </a:lstStyle>
-          <a:p>
-            <a:pPr algn="l"/>
-            <a:fld id="{F7021451-1387-4CA6-816F-3879F97B5CBC}" type="slidenum">
-              <a:rPr b="0" lang="en-US"/>
-              <a:t>3</a:t>
-            </a:fld>
-            <a:endParaRPr lang="en-US"/>
+                <a:latin typeface="Funnel Display ExtraBold" pitchFamily="34" charset="0"/>
+                <a:ea typeface="Funnel Display ExtraBold" pitchFamily="34" charset="-122"/>
+                <a:cs typeface="Funnel Display ExtraBold" pitchFamily="34" charset="-120"/>
+              </a:rPr>
+              <a:t>0.1S</a:t>
+            </a:r>
+            <a:endParaRPr lang="en-US" sz="11250" dirty="0"/>
+          </a:p>
+        </p:txBody>
+      </p:sp>
+      <p:sp>
+        <p:nvSpPr>
+          <p:cNvPr id="7" name="Text 4"/>
+          <p:cNvSpPr txBox="1"/>
+          <p:nvPr/>
+        </p:nvSpPr>
+        <p:spPr>
+          <a:xfrm>
+            <a:off x="7747000" y="2647950"/>
+            <a:ext cx="3810000" cy="1270000"/>
+          </a:xfrm>
+          <a:prstGeom prst="rect">
+            <a:avLst/>
+          </a:prstGeom>
+          <a:noFill/>
+          <a:ln/>
+        </p:spPr>
+        <p:txBody>
+          <a:bodyPr wrap="square" lIns="0" tIns="0" rIns="0" bIns="0" rtlCol="0" anchor="t"/>
+          <a:lstStyle/>
+          <a:p>
+            <a:pPr indent="0" marL="0">
+              <a:buNone/>
+            </a:pPr>
+            <a:r>
+              <a:rPr lang="en-US" sz="2100" dirty="0">
+                <a:solidFill>
+                  <a:srgbClr val="FFFFFF"/>
+                </a:solidFill>
+                <a:latin typeface="Inter" pitchFamily="34" charset="0"/>
+                <a:ea typeface="Inter" pitchFamily="34" charset="-122"/>
+                <a:cs typeface="Inter" pitchFamily="34" charset="-120"/>
+              </a:rPr>
+              <a:t>0 tokens. Same answer on the thousandth run.</a:t>
+            </a:r>
+            <a:endParaRPr lang="en-US" sz="2100" dirty="0"/>
           </a:p>
         </p:txBody>
       </p:sp>
@@ -2860,6 +2732,20 @@
 <file path=ppt/slides/slide4.xml><?xml version="1.0" encoding="utf-8"?>
 <p:sld xmlns:a="http://schemas.openxmlformats.org/drawingml/2006/main" xmlns:r="http://schemas.openxmlformats.org/officeDocument/2006/relationships" xmlns:p="http://schemas.openxmlformats.org/presentationml/2006/main">
   <p:cSld name="Slide 4">
+    <p:bg>
+      <p:bgPr>
+        <a:blipFill dpi="0" rotWithShape="1">
+          <a:blip r:embed="rId1">
+            <a:lum/>
+          </a:blip>
+          <a:srcRect/>
+          <a:stretch>
+            <a:fillRect/>
+          </a:stretch>
+        </a:blipFill>
+        <a:effectLst/>
+      </p:bgPr>
+    </p:bg>
     <p:spTree>
       <p:nvGrpSpPr>
         <p:cNvPr id="1" name=""/>
@@ -2877,15 +2763,13 @@
       <p:sp>
         <p:nvSpPr>
           <p:cNvPr id="2" name="Text 0"/>
-          <p:cNvSpPr/>
-          <p:nvPr>
-            <p:ph idx="100" type="title" hasCustomPrompt="1"/>
-          </p:nvPr>
-        </p:nvSpPr>
-        <p:spPr>
-          <a:xfrm>
-            <a:off x="457200" y="274320"/>
-            <a:ext cx="8229600" cy="822960"/>
+          <p:cNvSpPr txBox="1"/>
+          <p:nvPr/>
+        </p:nvSpPr>
+        <p:spPr>
+          <a:xfrm>
+            <a:off x="635000" y="635000"/>
+            <a:ext cx="10922000" cy="165100"/>
           </a:xfrm>
           <a:prstGeom prst="rect">
             <a:avLst/>
@@ -2901,44 +2785,86 @@
               <a:buNone/>
             </a:pPr>
             <a:r>
-              <a:rPr lang="en-US" sz="3000" b="1" dirty="0">
+              <a:rPr lang="en-US" sz="1350" spc="200" kern="0" dirty="0">
                 <a:solidFill>
-                  <a:schemeClr val="bg1"/>
+                  <a:srgbClr val="5FFA74"/>
                 </a:solidFill>
+                <a:latin typeface="Geist Mono" pitchFamily="34" charset="0"/>
+                <a:ea typeface="Geist Mono" pitchFamily="34" charset="-122"/>
+                <a:cs typeface="Geist Mono" pitchFamily="34" charset="-120"/>
               </a:rPr>
-              <a:t>Where an agent earns its keep</a:t>
-            </a:r>
-            <a:endParaRPr lang="en-US" sz="3000" dirty="0"/>
+              <a:t>// THE AGENT</a:t>
+            </a:r>
+            <a:endParaRPr lang="en-US" sz="1350" dirty="0"/>
+          </a:p>
+        </p:txBody>
+      </p:sp>
+      <p:sp>
+        <p:nvSpPr>
+          <p:cNvPr id="3" name="Text 1"/>
+          <p:cNvSpPr txBox="1"/>
+          <p:nvPr/>
+        </p:nvSpPr>
+        <p:spPr>
+          <a:xfrm>
+            <a:off x="635000" y="927100"/>
+            <a:ext cx="10922000" cy="391160"/>
+          </a:xfrm>
+          <a:prstGeom prst="rect">
+            <a:avLst/>
+          </a:prstGeom>
+          <a:noFill/>
+          <a:ln/>
+        </p:spPr>
+        <p:txBody>
+          <a:bodyPr wrap="square" lIns="0" tIns="0" rIns="0" bIns="0" rtlCol="0" anchor="t"/>
+          <a:lstStyle/>
+          <a:p>
+            <a:pPr indent="0" marL="0">
+              <a:buNone/>
+            </a:pPr>
+            <a:r>
+              <a:rPr lang="en-US" sz="4200" dirty="0">
+                <a:solidFill>
+                  <a:srgbClr val="FFFFFF"/>
+                </a:solidFill>
+                <a:latin typeface="Funnel Display ExtraBold" pitchFamily="34" charset="0"/>
+                <a:ea typeface="Funnel Display ExtraBold" pitchFamily="34" charset="-122"/>
+                <a:cs typeface="Funnel Display ExtraBold" pitchFamily="34" charset="-120"/>
+              </a:rPr>
+              <a:t>WHERE AN AGENT EARNS ITS KEEP</a:t>
+            </a:r>
+            <a:endParaRPr lang="en-US" sz="4200" dirty="0"/>
           </a:p>
         </p:txBody>
       </p:sp>
       <p:pic>
         <p:nvPicPr>
-          <p:cNvPr id="3" name="Media 0">
+          <p:cNvPr id="4" name="Media 0">
             <a:hlinkClick r:id="" action="ppaction://media"/>
           </p:cNvPr>
           <p:cNvPicPr>
             <a:picLocks noChangeAspect="1"/>
           </p:cNvPicPr>
           <p:nvPr>
-            <a:videoFile r:link="rId1"/>
+            <a:videoFile r:link="rId2"/>
             <p:extLst>
               <p:ext uri="{DAA4B4D4-6D71-4841-9C94-3DE7FCFB9230}">
-                <p14:media xmlns:p14="http://schemas.microsoft.com/office/powerpoint/2010/main" r:embed="rId2"/>
+                <p14:media xmlns:p14="http://schemas.microsoft.com/office/powerpoint/2010/main" r:embed="rId3"/>
               </p:ext>
             </p:extLst>
           </p:nvPr>
         </p:nvPicPr>
         <p:blipFill>
-          <a:blip r:embed="rId3"/>
+          <a:blip r:embed="rId4"/>
           <a:stretch>
             <a:fillRect/>
           </a:stretch>
         </p:blipFill>
         <p:spPr>
           <a:xfrm>
-            <a:off x="1371600" y="1234440"/>
-            <a:ext cx="6400800" cy="2834640"/>
+            <a:off x="635000" y="1587500"/>
+            <a:ext cx="6604000" cy="3714750"/>
           </a:xfrm>
           <a:prstGeom prst="rect">
             <a:avLst/>
@@ -2947,14 +2873,14 @@
       </p:pic>
       <p:sp>
         <p:nvSpPr>
-          <p:cNvPr id="4" name="Text 1"/>
+          <p:cNvPr id="5" name="Text 2"/>
           <p:cNvSpPr txBox="1"/>
           <p:nvPr/>
         </p:nvSpPr>
         <p:spPr>
           <a:xfrm>
-            <a:off x="457200" y="4434840"/>
-            <a:ext cx="8229600" cy="457200"/>
+            <a:off x="635000" y="5429250"/>
+            <a:ext cx="6604000" cy="228600"/>
           </a:xfrm>
           <a:prstGeom prst="rect">
             <a:avLst/>
@@ -2963,66 +2889,102 @@
           <a:ln/>
         </p:spPr>
         <p:txBody>
-          <a:bodyPr wrap="square" lIns="0" tIns="0" rIns="0" bIns="0" rtlCol="0" anchor="ctr"/>
+          <a:bodyPr wrap="square" lIns="0" tIns="0" rIns="0" bIns="0" rtlCol="0" anchor="t"/>
           <a:lstStyle/>
           <a:p>
             <a:pPr indent="0" marL="0">
               <a:buNone/>
             </a:pPr>
             <a:r>
-              <a:rPr lang="en-US" sz="1400" dirty="0">
+              <a:rPr lang="en-US" sz="1650" dirty="0">
                 <a:solidFill>
-                  <a:schemeClr val="bg2"/>
+                  <a:srgbClr val="8D9098"/>
                 </a:solidFill>
+                <a:latin typeface="Inter" pitchFamily="34" charset="0"/>
+                <a:ea typeface="Inter" pitchFamily="34" charset="-122"/>
+                <a:cs typeface="Inter" pitchFamily="34" charset="-120"/>
               </a:rPr>
-              <a:t>25 groups triaged for $0.07. Two tools, one job, read-only.</a:t>
-            </a:r>
-            <a:endParaRPr lang="en-US" sz="1400" dirty="0"/>
-          </a:p>
-        </p:txBody>
-      </p:sp>
-      <p:sp>
-        <p:nvSpPr>
-          <p:cNvPr id="25" name="Slide Number Placeholder 0"/>
-          <p:cNvSpPr>
-            <a:spLocks noGrp="1"/>
-          </p:cNvSpPr>
-          <p:nvPr>
-            <p:ph type="sldNum" sz="quarter" idx="4294967295"/>
-          </p:nvPr>
-        </p:nvSpPr>
-        <p:spPr>
-          <a:xfrm>
-            <a:off x="8412480" y="4754880"/>
-            <a:ext cx="457200" cy="274320"/>
-          </a:xfrm>
-          <a:prstGeom prst="rect">
-            <a:avLst/>
-          </a:prstGeom>
-          <a:extLst>
-            <a:ext uri="{C572A759-6A51-4108-AA02-DFA0A04FC94B}">
-              <ma14:wrappingTextBoxFlag xmlns:ma14="http://schemas.microsoft.com/office/mac/drawingml/2011/main" val="0"/>
-            </a:ext>
-          </a:extLst>
-        </p:spPr>
-        <p:txBody>
-          <a:bodyPr/>
-          <a:lstStyle>
-            <a:lvl1pPr>
-              <a:defRPr sz="1000">
+              <a:t>The one step that needs judgement: which groups first?</a:t>
+            </a:r>
+            <a:endParaRPr lang="en-US" sz="1650" dirty="0"/>
+          </a:p>
+        </p:txBody>
+      </p:sp>
+      <p:sp>
+        <p:nvSpPr>
+          <p:cNvPr id="6" name="Text 3"/>
+          <p:cNvSpPr txBox="1"/>
+          <p:nvPr/>
+        </p:nvSpPr>
+        <p:spPr>
+          <a:xfrm>
+            <a:off x="7747000" y="1587500"/>
+            <a:ext cx="3810000" cy="904875"/>
+          </a:xfrm>
+          <a:prstGeom prst="rect">
+            <a:avLst/>
+          </a:prstGeom>
+          <a:noFill/>
+          <a:ln/>
+        </p:spPr>
+        <p:txBody>
+          <a:bodyPr wrap="square" lIns="0" tIns="0" rIns="0" bIns="0" rtlCol="0" anchor="t"/>
+          <a:lstStyle/>
+          <a:p>
+            <a:pPr indent="0" marL="0">
+              <a:buNone/>
+            </a:pPr>
+            <a:r>
+              <a:rPr lang="en-US" sz="11250" dirty="0">
                 <a:solidFill>
-                  <a:schemeClr val="accent6"/>
+                  <a:srgbClr val="5FFA74"/>
                 </a:solidFill>
-              </a:defRPr>
-            </a:lvl1pPr>
-          </a:lstStyle>
-          <a:p>
-            <a:pPr algn="l"/>
-            <a:fld id="{F7021451-1387-4CA6-816F-3879F97B5CBC}" type="slidenum">
-              <a:rPr b="0" lang="en-US"/>
-              <a:t>4</a:t>
-            </a:fld>
-            <a:endParaRPr lang="en-US"/>
+                <a:latin typeface="Funnel Display ExtraBold" pitchFamily="34" charset="0"/>
+                <a:ea typeface="Funnel Display ExtraBold" pitchFamily="34" charset="-122"/>
+                <a:cs typeface="Funnel Display ExtraBold" pitchFamily="34" charset="-120"/>
+              </a:rPr>
+              <a:t>$0.07</a:t>
+            </a:r>
+            <a:endParaRPr lang="en-US" sz="11250" dirty="0"/>
+          </a:p>
+        </p:txBody>
+      </p:sp>
+      <p:sp>
+        <p:nvSpPr>
+          <p:cNvPr id="7" name="Text 4"/>
+          <p:cNvSpPr txBox="1"/>
+          <p:nvPr/>
+        </p:nvSpPr>
+        <p:spPr>
+          <a:xfrm>
+            <a:off x="7747000" y="2647950"/>
+            <a:ext cx="3810000" cy="1270000"/>
+          </a:xfrm>
+          <a:prstGeom prst="rect">
+            <a:avLst/>
+          </a:prstGeom>
+          <a:noFill/>
+          <a:ln/>
+        </p:spPr>
+        <p:txBody>
+          <a:bodyPr wrap="square" lIns="0" tIns="0" rIns="0" bIns="0" rtlCol="0" anchor="t"/>
+          <a:lstStyle/>
+          <a:p>
+            <a:pPr indent="0" marL="0">
+              <a:buNone/>
+            </a:pPr>
+            <a:r>
+              <a:rPr lang="en-US" sz="2100" dirty="0">
+                <a:solidFill>
+                  <a:srgbClr val="FFFFFF"/>
+                </a:solidFill>
+                <a:latin typeface="Inter" pitchFamily="34" charset="0"/>
+                <a:ea typeface="Inter" pitchFamily="34" charset="-122"/>
+                <a:cs typeface="Inter" pitchFamily="34" charset="-120"/>
+              </a:rPr>
+              <a:t>25 groups triaged. Two tools, one job, read-only.</a:t>
+            </a:r>
+            <a:endParaRPr lang="en-US" sz="2100" dirty="0"/>
           </a:p>
         </p:txBody>
       </p:sp>
@@ -3037,6 +2999,20 @@
 <file path=ppt/slides/slide5.xml><?xml version="1.0" encoding="utf-8"?>
 <p:sld xmlns:a="http://schemas.openxmlformats.org/drawingml/2006/main" xmlns:r="http://schemas.openxmlformats.org/officeDocument/2006/relationships" xmlns:p="http://schemas.openxmlformats.org/presentationml/2006/main">
   <p:cSld name="Slide 5">
+    <p:bg>
+      <p:bgPr>
+        <a:blipFill dpi="0" rotWithShape="1">
+          <a:blip r:embed="rId1">
+            <a:lum/>
+          </a:blip>
+          <a:srcRect/>
+          <a:stretch>
+            <a:fillRect/>
+          </a:stretch>
+        </a:blipFill>
+        <a:effectLst/>
+      </p:bgPr>
+    </p:bg>
     <p:spTree>
       <p:nvGrpSpPr>
         <p:cNvPr id="1" name=""/>
@@ -3054,15 +3030,13 @@
       <p:sp>
         <p:nvSpPr>
           <p:cNvPr id="2" name="Text 0"/>
-          <p:cNvSpPr/>
-          <p:nvPr>
-            <p:ph idx="100" type="title" hasCustomPrompt="1"/>
-          </p:nvPr>
-        </p:nvSpPr>
-        <p:spPr>
-          <a:xfrm>
-            <a:off x="457200" y="274320"/>
-            <a:ext cx="8229600" cy="822960"/>
+          <p:cNvSpPr txBox="1"/>
+          <p:nvPr/>
+        </p:nvSpPr>
+        <p:spPr>
+          <a:xfrm>
+            <a:off x="635000" y="635000"/>
+            <a:ext cx="10922000" cy="165100"/>
           </a:xfrm>
           <a:prstGeom prst="rect">
             <a:avLst/>
@@ -3078,44 +3052,86 @@
               <a:buNone/>
             </a:pPr>
             <a:r>
-              <a:rPr lang="en-US" sz="3000" b="1" dirty="0">
+              <a:rPr lang="en-US" sz="1350" spc="200" kern="0" dirty="0">
                 <a:solidFill>
-                  <a:schemeClr val="bg1"/>
+                  <a:srgbClr val="5FFA74"/>
                 </a:solidFill>
+                <a:latin typeface="Geist Mono" pitchFamily="34" charset="0"/>
+                <a:ea typeface="Geist Mono" pitchFamily="34" charset="-122"/>
+                <a:cs typeface="Geist Mono" pitchFamily="34" charset="-120"/>
               </a:rPr>
-              <a:t>Then a script acts on the answer</a:t>
-            </a:r>
-            <a:endParaRPr lang="en-US" sz="3000" dirty="0"/>
+              <a:t>// THE HAND-OFF</a:t>
+            </a:r>
+            <a:endParaRPr lang="en-US" sz="1350" dirty="0"/>
+          </a:p>
+        </p:txBody>
+      </p:sp>
+      <p:sp>
+        <p:nvSpPr>
+          <p:cNvPr id="3" name="Text 1"/>
+          <p:cNvSpPr txBox="1"/>
+          <p:nvPr/>
+        </p:nvSpPr>
+        <p:spPr>
+          <a:xfrm>
+            <a:off x="635000" y="927100"/>
+            <a:ext cx="10922000" cy="391160"/>
+          </a:xfrm>
+          <a:prstGeom prst="rect">
+            <a:avLst/>
+          </a:prstGeom>
+          <a:noFill/>
+          <a:ln/>
+        </p:spPr>
+        <p:txBody>
+          <a:bodyPr wrap="square" lIns="0" tIns="0" rIns="0" bIns="0" rtlCol="0" anchor="t"/>
+          <a:lstStyle/>
+          <a:p>
+            <a:pPr indent="0" marL="0">
+              <a:buNone/>
+            </a:pPr>
+            <a:r>
+              <a:rPr lang="en-US" sz="4200" dirty="0">
+                <a:solidFill>
+                  <a:srgbClr val="FFFFFF"/>
+                </a:solidFill>
+                <a:latin typeface="Funnel Display ExtraBold" pitchFamily="34" charset="0"/>
+                <a:ea typeface="Funnel Display ExtraBold" pitchFamily="34" charset="-122"/>
+                <a:cs typeface="Funnel Display ExtraBold" pitchFamily="34" charset="-120"/>
+              </a:rPr>
+              <a:t>THEN A SCRIPT ACTS ON THE ANSWER</a:t>
+            </a:r>
+            <a:endParaRPr lang="en-US" sz="4200" dirty="0"/>
           </a:p>
         </p:txBody>
       </p:sp>
       <p:pic>
         <p:nvPicPr>
-          <p:cNvPr id="3" name="Media 0">
+          <p:cNvPr id="4" name="Media 0">
             <a:hlinkClick r:id="" action="ppaction://media"/>
           </p:cNvPr>
           <p:cNvPicPr>
             <a:picLocks noChangeAspect="1"/>
           </p:cNvPicPr>
           <p:nvPr>
-            <a:videoFile r:link="rId1"/>
+            <a:videoFile r:link="rId2"/>
             <p:extLst>
               <p:ext uri="{DAA4B4D4-6D71-4841-9C94-3DE7FCFB9230}">
-                <p14:media xmlns:p14="http://schemas.microsoft.com/office/powerpoint/2010/main" r:embed="rId2"/>
+                <p14:media xmlns:p14="http://schemas.microsoft.com/office/powerpoint/2010/main" r:embed="rId3"/>
               </p:ext>
             </p:extLst>
           </p:nvPr>
         </p:nvPicPr>
         <p:blipFill>
-          <a:blip r:embed="rId3"/>
+          <a:blip r:embed="rId4"/>
           <a:stretch>
             <a:fillRect/>
           </a:stretch>
         </p:blipFill>
         <p:spPr>
           <a:xfrm>
-            <a:off x="1371600" y="1234440"/>
-            <a:ext cx="6400800" cy="2834640"/>
+            <a:off x="635000" y="1587500"/>
+            <a:ext cx="6604000" cy="3714750"/>
           </a:xfrm>
           <a:prstGeom prst="rect">
             <a:avLst/>
@@ -3124,14 +3140,14 @@
       </p:pic>
       <p:sp>
         <p:nvSpPr>
-          <p:cNvPr id="4" name="Text 1"/>
+          <p:cNvPr id="5" name="Text 2"/>
           <p:cNvSpPr txBox="1"/>
           <p:nvPr/>
         </p:nvSpPr>
         <p:spPr>
           <a:xfrm>
-            <a:off x="457200" y="4434840"/>
-            <a:ext cx="8229600" cy="457200"/>
+            <a:off x="635000" y="5429250"/>
+            <a:ext cx="6604000" cy="228600"/>
           </a:xfrm>
           <a:prstGeom prst="rect">
             <a:avLst/>
@@ -3140,66 +3156,102 @@
           <a:ln/>
         </p:spPr>
         <p:txBody>
-          <a:bodyPr wrap="square" lIns="0" tIns="0" rIns="0" bIns="0" rtlCol="0" anchor="ctr"/>
+          <a:bodyPr wrap="square" lIns="0" tIns="0" rIns="0" bIns="0" rtlCol="0" anchor="t"/>
           <a:lstStyle/>
           <a:p>
             <a:pPr indent="0" marL="0">
               <a:buNone/>
             </a:pPr>
             <a:r>
-              <a:rPr lang="en-US" sz="1400" dirty="0">
+              <a:rPr lang="en-US" sz="1650" dirty="0">
                 <a:solidFill>
-                  <a:schemeClr val="bg2"/>
+                  <a:srgbClr val="8D9098"/>
                 </a:solidFill>
+                <a:latin typeface="Inter" pitchFamily="34" charset="0"/>
+                <a:ea typeface="Inter" pitchFamily="34" charset="-122"/>
+                <a:cs typeface="Inter" pitchFamily="34" charset="-120"/>
               </a:rPr>
-              <a:t>The agent decides. Code does the work. 4 of 25 moved to the front.</a:t>
-            </a:r>
-            <a:endParaRPr lang="en-US" sz="1400" dirty="0"/>
-          </a:p>
-        </p:txBody>
-      </p:sp>
-      <p:sp>
-        <p:nvSpPr>
-          <p:cNvPr id="25" name="Slide Number Placeholder 0"/>
-          <p:cNvSpPr>
-            <a:spLocks noGrp="1"/>
-          </p:cNvSpPr>
-          <p:nvPr>
-            <p:ph type="sldNum" sz="quarter" idx="4294967295"/>
-          </p:nvPr>
-        </p:nvSpPr>
-        <p:spPr>
-          <a:xfrm>
-            <a:off x="8412480" y="4754880"/>
-            <a:ext cx="457200" cy="274320"/>
-          </a:xfrm>
-          <a:prstGeom prst="rect">
-            <a:avLst/>
-          </a:prstGeom>
-          <a:extLst>
-            <a:ext uri="{C572A759-6A51-4108-AA02-DFA0A04FC94B}">
-              <ma14:wrappingTextBoxFlag xmlns:ma14="http://schemas.microsoft.com/office/mac/drawingml/2011/main" val="0"/>
-            </a:ext>
-          </a:extLst>
-        </p:spPr>
-        <p:txBody>
-          <a:bodyPr/>
-          <a:lstStyle>
-            <a:lvl1pPr>
-              <a:defRPr sz="1000">
+              <a:t>The agent returns a list. A script builds the queue.</a:t>
+            </a:r>
+            <a:endParaRPr lang="en-US" sz="1650" dirty="0"/>
+          </a:p>
+        </p:txBody>
+      </p:sp>
+      <p:sp>
+        <p:nvSpPr>
+          <p:cNvPr id="6" name="Text 3"/>
+          <p:cNvSpPr txBox="1"/>
+          <p:nvPr/>
+        </p:nvSpPr>
+        <p:spPr>
+          <a:xfrm>
+            <a:off x="7747000" y="1587500"/>
+            <a:ext cx="3810000" cy="663575"/>
+          </a:xfrm>
+          <a:prstGeom prst="rect">
+            <a:avLst/>
+          </a:prstGeom>
+          <a:noFill/>
+          <a:ln/>
+        </p:spPr>
+        <p:txBody>
+          <a:bodyPr wrap="square" lIns="0" tIns="0" rIns="0" bIns="0" rtlCol="0" anchor="t"/>
+          <a:lstStyle/>
+          <a:p>
+            <a:pPr indent="0" marL="0">
+              <a:buNone/>
+            </a:pPr>
+            <a:r>
+              <a:rPr lang="en-US" sz="8250" dirty="0">
                 <a:solidFill>
-                  <a:schemeClr val="accent6"/>
+                  <a:srgbClr val="5FFA74"/>
                 </a:solidFill>
-              </a:defRPr>
-            </a:lvl1pPr>
-          </a:lstStyle>
-          <a:p>
-            <a:pPr algn="l"/>
-            <a:fld id="{F7021451-1387-4CA6-816F-3879F97B5CBC}" type="slidenum">
-              <a:rPr b="0" lang="en-US"/>
-              <a:t>5</a:t>
-            </a:fld>
-            <a:endParaRPr lang="en-US"/>
+                <a:latin typeface="Funnel Display ExtraBold" pitchFamily="34" charset="0"/>
+                <a:ea typeface="Funnel Display ExtraBold" pitchFamily="34" charset="-122"/>
+                <a:cs typeface="Funnel Display ExtraBold" pitchFamily="34" charset="-120"/>
+              </a:rPr>
+              <a:t>4 OF 25</a:t>
+            </a:r>
+            <a:endParaRPr lang="en-US" sz="8250" dirty="0"/>
+          </a:p>
+        </p:txBody>
+      </p:sp>
+      <p:sp>
+        <p:nvSpPr>
+          <p:cNvPr id="7" name="Text 4"/>
+          <p:cNvSpPr txBox="1"/>
+          <p:nvPr/>
+        </p:nvSpPr>
+        <p:spPr>
+          <a:xfrm>
+            <a:off x="7747000" y="2419350"/>
+            <a:ext cx="3810000" cy="1270000"/>
+          </a:xfrm>
+          <a:prstGeom prst="rect">
+            <a:avLst/>
+          </a:prstGeom>
+          <a:noFill/>
+          <a:ln/>
+        </p:spPr>
+        <p:txBody>
+          <a:bodyPr wrap="square" lIns="0" tIns="0" rIns="0" bIns="0" rtlCol="0" anchor="t"/>
+          <a:lstStyle/>
+          <a:p>
+            <a:pPr indent="0" marL="0">
+              <a:buNone/>
+            </a:pPr>
+            <a:r>
+              <a:rPr lang="en-US" sz="2100" dirty="0">
+                <a:solidFill>
+                  <a:srgbClr val="FFFFFF"/>
+                </a:solidFill>
+                <a:latin typeface="Inter" pitchFamily="34" charset="0"/>
+                <a:ea typeface="Inter" pitchFamily="34" charset="-122"/>
+                <a:cs typeface="Inter" pitchFamily="34" charset="-120"/>
+              </a:rPr>
+              <a:t>moved to the front of the queue. The agent decides. Code does the work.</a:t>
+            </a:r>
+            <a:endParaRPr lang="en-US" sz="2100" dirty="0"/>
           </a:p>
         </p:txBody>
       </p:sp>
@@ -3214,6 +3266,20 @@
 <file path=ppt/slides/slide6.xml><?xml version="1.0" encoding="utf-8"?>
 <p:sld xmlns:a="http://schemas.openxmlformats.org/drawingml/2006/main" xmlns:r="http://schemas.openxmlformats.org/officeDocument/2006/relationships" xmlns:p="http://schemas.openxmlformats.org/presentationml/2006/main">
   <p:cSld name="Slide 6">
+    <p:bg>
+      <p:bgPr>
+        <a:blipFill dpi="0" rotWithShape="1">
+          <a:blip r:embed="rId1">
+            <a:lum/>
+          </a:blip>
+          <a:srcRect/>
+          <a:stretch>
+            <a:fillRect/>
+          </a:stretch>
+        </a:blipFill>
+        <a:effectLst/>
+      </p:bgPr>
+    </p:bg>
     <p:spTree>
       <p:nvGrpSpPr>
         <p:cNvPr id="1" name=""/>
@@ -3231,15 +3297,13 @@
       <p:sp>
         <p:nvSpPr>
           <p:cNvPr id="2" name="Text 0"/>
-          <p:cNvSpPr/>
-          <p:nvPr>
-            <p:ph idx="100" type="title" hasCustomPrompt="1"/>
-          </p:nvPr>
-        </p:nvSpPr>
-        <p:spPr>
-          <a:xfrm>
-            <a:off x="457200" y="274320"/>
-            <a:ext cx="8229600" cy="822960"/>
+          <p:cNvSpPr txBox="1"/>
+          <p:nvPr/>
+        </p:nvSpPr>
+        <p:spPr>
+          <a:xfrm>
+            <a:off x="635000" y="635000"/>
+            <a:ext cx="10922000" cy="165100"/>
           </a:xfrm>
           <a:prstGeom prst="rect">
             <a:avLst/>
@@ -3255,14 +3319,56 @@
               <a:buNone/>
             </a:pPr>
             <a:r>
-              <a:rPr lang="en-US" sz="3000" b="1" dirty="0">
+              <a:rPr lang="en-US" sz="1350" spc="200" kern="0" dirty="0">
                 <a:solidFill>
-                  <a:schemeClr val="bg1"/>
+                  <a:srgbClr val="5FFA74"/>
                 </a:solidFill>
+                <a:latin typeface="Geist Mono" pitchFamily="34" charset="0"/>
+                <a:ea typeface="Geist Mono" pitchFamily="34" charset="-122"/>
+                <a:cs typeface="Geist Mono" pitchFamily="34" charset="-120"/>
               </a:rPr>
-              <a:t>What it costs, by how often you ask</a:t>
-            </a:r>
-            <a:endParaRPr lang="en-US" sz="3000" dirty="0"/>
+              <a:t>// THE COST</a:t>
+            </a:r>
+            <a:endParaRPr lang="en-US" sz="1350" dirty="0"/>
+          </a:p>
+        </p:txBody>
+      </p:sp>
+      <p:sp>
+        <p:nvSpPr>
+          <p:cNvPr id="3" name="Text 1"/>
+          <p:cNvSpPr txBox="1"/>
+          <p:nvPr/>
+        </p:nvSpPr>
+        <p:spPr>
+          <a:xfrm>
+            <a:off x="635000" y="927100"/>
+            <a:ext cx="10922000" cy="391160"/>
+          </a:xfrm>
+          <a:prstGeom prst="rect">
+            <a:avLst/>
+          </a:prstGeom>
+          <a:noFill/>
+          <a:ln/>
+        </p:spPr>
+        <p:txBody>
+          <a:bodyPr wrap="square" lIns="0" tIns="0" rIns="0" bIns="0" rtlCol="0" anchor="t"/>
+          <a:lstStyle/>
+          <a:p>
+            <a:pPr indent="0" marL="0">
+              <a:buNone/>
+            </a:pPr>
+            <a:r>
+              <a:rPr lang="en-US" sz="4200" dirty="0">
+                <a:solidFill>
+                  <a:srgbClr val="FFFFFF"/>
+                </a:solidFill>
+                <a:latin typeface="Funnel Display ExtraBold" pitchFamily="34" charset="0"/>
+                <a:ea typeface="Funnel Display ExtraBold" pitchFamily="34" charset="-122"/>
+                <a:cs typeface="Funnel Display ExtraBold" pitchFamily="34" charset="-120"/>
+              </a:rPr>
+              <a:t>WHAT IT COSTS, BY HOW OFTEN YOU ASK</a:t>
+            </a:r>
+            <a:endParaRPr lang="en-US" sz="4200" dirty="0"/>
           </a:p>
         </p:txBody>
       </p:sp>
@@ -3281,19 +3387,19 @@
           </p:nvPr>
         </p:nvGraphicFramePr>
         <p:xfrm>
-          <a:off x="457200" y="1371600"/>
-          <a:ext cx="8229600" cy="914400"/>
+          <a:off x="635000" y="1587500"/>
+          <a:ext cx="10922000" cy="914400"/>
         </p:xfrm>
         <a:graphic>
           <a:graphicData uri="http://schemas.openxmlformats.org/drawingml/2006/table">
             <a:tbl>
               <a:tblPr/>
               <a:tblGrid>
-                <a:gridCol w="4023360"/>
-                <a:gridCol w="2103120"/>
-                <a:gridCol w="2103120"/>
+                <a:gridCol w="5461000"/>
+                <a:gridCol w="2730500"/>
+                <a:gridCol w="2730500"/>
               </a:tblGrid>
-              <a:tr h="502920">
+              <a:tr h="444500">
                 <a:tc>
                   <a:txBody>
                     <a:bodyPr/>
@@ -3303,47 +3409,54 @@
                         <a:buNone/>
                       </a:pPr>
                       <a:r>
-                        <a:rPr lang="en-US" sz="1600" b="1" dirty="0">
+                        <a:rPr lang="en-US" sz="1350" dirty="0">
                           <a:solidFill>
-                            <a:schemeClr val="bg1"/>
+                            <a:srgbClr val="5FFA74"/>
                           </a:solidFill>
+                          <a:latin typeface="Geist Mono" pitchFamily="34" charset="0"/>
+                          <a:ea typeface="Geist Mono" pitchFamily="34" charset="-122"/>
+                          <a:cs typeface="Geist Mono" pitchFamily="34" charset="-120"/>
                         </a:rPr>
-                        <a:t>Cadence</a:t>
+                        <a:t>CADENCE</a:t>
                       </a:r>
-                      <a:endParaRPr lang="en-US" sz="1600" dirty="0"/>
+                      <a:endParaRPr lang="en-US" sz="1350" dirty="0">
+                        <a:latin typeface="Geist Mono" charset="0"/>
+                        <a:ea typeface="Geist Mono" charset="0"/>
+                        <a:cs typeface="Geist Mono" charset="0"/>
+                      </a:endParaRPr>
                     </a:p>
                   </a:txBody>
-                  <a:tcPr marL="91440" marR="91440" marT="45720" marB="45720" anchor="ctr">
-                    <a:lnL w="12700" cap="flat" cmpd="sng" algn="ctr">
+                  <a:tcPr marL="155448" marR="155448" marT="128016" marB="128016" anchor="ctr">
+                    <a:lnL w="9525" cap="flat" cmpd="sng" algn="ctr">
                       <a:solidFill>
-                        <a:schemeClr val="accent6"/>
+                        <a:srgbClr val="22252D"/>
                       </a:solidFill>
                       <a:prstDash val="solid"/>
                       <a:round/>
                       <a:headEnd type="none" w="med" len="med"/>
                       <a:tailEnd type="none" w="med" len="med"/>
                     </a:lnL>
-                    <a:lnR w="12700" cap="flat" cmpd="sng" algn="ctr">
+                    <a:lnR w="9525" cap="flat" cmpd="sng" algn="ctr">
                       <a:solidFill>
-                        <a:schemeClr val="accent6"/>
+                        <a:srgbClr val="22252D"/>
                       </a:solidFill>
                       <a:prstDash val="solid"/>
                       <a:round/>
                       <a:headEnd type="none" w="med" len="med"/>
                       <a:tailEnd type="none" w="med" len="med"/>
                     </a:lnR>
-                    <a:lnT w="12700" cap="flat" cmpd="sng" algn="ctr">
+                    <a:lnT w="9525" cap="flat" cmpd="sng" algn="ctr">
                       <a:solidFill>
-                        <a:schemeClr val="accent6"/>
+                        <a:srgbClr val="22252D"/>
                       </a:solidFill>
                       <a:prstDash val="solid"/>
                       <a:round/>
                       <a:headEnd type="none" w="med" len="med"/>
                       <a:tailEnd type="none" w="med" len="med"/>
                     </a:lnT>
-                    <a:lnB w="12700" cap="flat" cmpd="sng" algn="ctr">
+                    <a:lnB w="9525" cap="flat" cmpd="sng" algn="ctr">
                       <a:solidFill>
-                        <a:schemeClr val="accent6"/>
+                        <a:srgbClr val="22252D"/>
                       </a:solidFill>
                       <a:prstDash val="solid"/>
                       <a:round/>
@@ -3351,7 +3464,7 @@
                       <a:tailEnd type="none" w="med" len="med"/>
                     </a:lnB>
                     <a:solidFill>
-                      <a:schemeClr val="accent6"/>
+                      <a:srgbClr val="1D1D1F"/>
                     </a:solidFill>
                   </a:tcPr>
                 </a:tc>
@@ -3364,47 +3477,54 @@
                         <a:buNone/>
                       </a:pPr>
                       <a:r>
-                        <a:rPr lang="en-US" sz="1600" b="1" dirty="0">
+                        <a:rPr lang="en-US" sz="1350" dirty="0">
                           <a:solidFill>
-                            <a:schemeClr val="bg1"/>
+                            <a:srgbClr val="5FFA74"/>
                           </a:solidFill>
+                          <a:latin typeface="Geist Mono" pitchFamily="34" charset="0"/>
+                          <a:ea typeface="Geist Mono" pitchFamily="34" charset="-122"/>
+                          <a:cs typeface="Geist Mono" pitchFamily="34" charset="-120"/>
                         </a:rPr>
-                        <a:t>Agent triage</a:t>
+                        <a:t>AGENT TRIAGE</a:t>
                       </a:r>
-                      <a:endParaRPr lang="en-US" sz="1600" dirty="0"/>
+                      <a:endParaRPr lang="en-US" sz="1350" dirty="0">
+                        <a:latin typeface="Geist Mono" charset="0"/>
+                        <a:ea typeface="Geist Mono" charset="0"/>
+                        <a:cs typeface="Geist Mono" charset="0"/>
+                      </a:endParaRPr>
                     </a:p>
                   </a:txBody>
-                  <a:tcPr marL="91440" marR="91440" marT="45720" marB="45720" anchor="ctr">
-                    <a:lnL w="12700" cap="flat" cmpd="sng" algn="ctr">
+                  <a:tcPr marL="155448" marR="155448" marT="128016" marB="128016" anchor="ctr">
+                    <a:lnL w="9525" cap="flat" cmpd="sng" algn="ctr">
                       <a:solidFill>
-                        <a:schemeClr val="accent6"/>
+                        <a:srgbClr val="22252D"/>
                       </a:solidFill>
                       <a:prstDash val="solid"/>
                       <a:round/>
                       <a:headEnd type="none" w="med" len="med"/>
                       <a:tailEnd type="none" w="med" len="med"/>
                     </a:lnL>
-                    <a:lnR w="12700" cap="flat" cmpd="sng" algn="ctr">
+                    <a:lnR w="9525" cap="flat" cmpd="sng" algn="ctr">
                       <a:solidFill>
-                        <a:schemeClr val="accent6"/>
+                        <a:srgbClr val="22252D"/>
                       </a:solidFill>
                       <a:prstDash val="solid"/>
                       <a:round/>
                       <a:headEnd type="none" w="med" len="med"/>
                       <a:tailEnd type="none" w="med" len="med"/>
                     </a:lnR>
-                    <a:lnT w="12700" cap="flat" cmpd="sng" algn="ctr">
+                    <a:lnT w="9525" cap="flat" cmpd="sng" algn="ctr">
                       <a:solidFill>
-                        <a:schemeClr val="accent6"/>
+                        <a:srgbClr val="22252D"/>
                       </a:solidFill>
                       <a:prstDash val="solid"/>
                       <a:round/>
                       <a:headEnd type="none" w="med" len="med"/>
                       <a:tailEnd type="none" w="med" len="med"/>
                     </a:lnT>
-                    <a:lnB w="12700" cap="flat" cmpd="sng" algn="ctr">
+                    <a:lnB w="9525" cap="flat" cmpd="sng" algn="ctr">
                       <a:solidFill>
-                        <a:schemeClr val="accent6"/>
+                        <a:srgbClr val="22252D"/>
                       </a:solidFill>
                       <a:prstDash val="solid"/>
                       <a:round/>
@@ -3412,7 +3532,7 @@
                       <a:tailEnd type="none" w="med" len="med"/>
                     </a:lnB>
                     <a:solidFill>
-                      <a:schemeClr val="accent6"/>
+                      <a:srgbClr val="1D1D1F"/>
                     </a:solidFill>
                   </a:tcPr>
                 </a:tc>
@@ -3425,47 +3545,54 @@
                         <a:buNone/>
                       </a:pPr>
                       <a:r>
-                        <a:rPr lang="en-US" sz="1600" b="1" dirty="0">
+                        <a:rPr lang="en-US" sz="1350" dirty="0">
                           <a:solidFill>
-                            <a:schemeClr val="bg1"/>
+                            <a:srgbClr val="5FFA74"/>
                           </a:solidFill>
+                          <a:latin typeface="Geist Mono" pitchFamily="34" charset="0"/>
+                          <a:ea typeface="Geist Mono" pitchFamily="34" charset="-122"/>
+                          <a:cs typeface="Geist Mono" pitchFamily="34" charset="-120"/>
                         </a:rPr>
-                        <a:t>Script</a:t>
+                        <a:t>SCRIPT</a:t>
                       </a:r>
-                      <a:endParaRPr lang="en-US" sz="1600" dirty="0"/>
+                      <a:endParaRPr lang="en-US" sz="1350" dirty="0">
+                        <a:latin typeface="Geist Mono" charset="0"/>
+                        <a:ea typeface="Geist Mono" charset="0"/>
+                        <a:cs typeface="Geist Mono" charset="0"/>
+                      </a:endParaRPr>
                     </a:p>
                   </a:txBody>
-                  <a:tcPr marL="91440" marR="91440" marT="45720" marB="45720" anchor="ctr">
-                    <a:lnL w="12700" cap="flat" cmpd="sng" algn="ctr">
+                  <a:tcPr marL="155448" marR="155448" marT="128016" marB="128016" anchor="ctr">
+                    <a:lnL w="9525" cap="flat" cmpd="sng" algn="ctr">
                       <a:solidFill>
-                        <a:schemeClr val="accent6"/>
+                        <a:srgbClr val="22252D"/>
                       </a:solidFill>
                       <a:prstDash val="solid"/>
                       <a:round/>
                       <a:headEnd type="none" w="med" len="med"/>
                       <a:tailEnd type="none" w="med" len="med"/>
                     </a:lnL>
-                    <a:lnR w="12700" cap="flat" cmpd="sng" algn="ctr">
+                    <a:lnR w="9525" cap="flat" cmpd="sng" algn="ctr">
                       <a:solidFill>
-                        <a:schemeClr val="accent6"/>
+                        <a:srgbClr val="22252D"/>
                       </a:solidFill>
                       <a:prstDash val="solid"/>
                       <a:round/>
                       <a:headEnd type="none" w="med" len="med"/>
                       <a:tailEnd type="none" w="med" len="med"/>
                     </a:lnR>
-                    <a:lnT w="12700" cap="flat" cmpd="sng" algn="ctr">
+                    <a:lnT w="9525" cap="flat" cmpd="sng" algn="ctr">
                       <a:solidFill>
-                        <a:schemeClr val="accent6"/>
+                        <a:srgbClr val="22252D"/>
                       </a:solidFill>
                       <a:prstDash val="solid"/>
                       <a:round/>
                       <a:headEnd type="none" w="med" len="med"/>
                       <a:tailEnd type="none" w="med" len="med"/>
                     </a:lnT>
-                    <a:lnB w="12700" cap="flat" cmpd="sng" algn="ctr">
+                    <a:lnB w="9525" cap="flat" cmpd="sng" algn="ctr">
                       <a:solidFill>
-                        <a:schemeClr val="accent6"/>
+                        <a:srgbClr val="22252D"/>
                       </a:solidFill>
                       <a:prstDash val="solid"/>
                       <a:round/>
@@ -3473,12 +3600,12 @@
                       <a:tailEnd type="none" w="med" len="med"/>
                     </a:lnB>
                     <a:solidFill>
-                      <a:schemeClr val="accent6"/>
+                      <a:srgbClr val="1D1D1F"/>
                     </a:solidFill>
                   </a:tcPr>
                 </a:tc>
               </a:tr>
-              <a:tr h="502920">
+              <a:tr h="444500">
                 <a:tc>
                   <a:txBody>
                     <a:bodyPr/>
@@ -3488,53 +3615,63 @@
                         <a:buNone/>
                       </a:pPr>
                       <a:r>
-                        <a:rPr lang="en-US" sz="1600" dirty="0">
+                        <a:rPr lang="en-US" sz="1500" b="1" dirty="0">
                           <a:solidFill>
-                            <a:schemeClr val="bg1"/>
+                            <a:srgbClr val="FFFFFF"/>
                           </a:solidFill>
+                          <a:latin typeface="Inter" pitchFamily="34" charset="0"/>
+                          <a:ea typeface="Inter" pitchFamily="34" charset="-122"/>
+                          <a:cs typeface="Inter" pitchFamily="34" charset="-120"/>
                         </a:rPr>
                         <a:t>Once, 25 groups</a:t>
                       </a:r>
-                      <a:endParaRPr lang="en-US" sz="1600" dirty="0"/>
+                      <a:endParaRPr lang="en-US" sz="1500" dirty="0">
+                        <a:latin typeface="Inter" charset="0"/>
+                        <a:ea typeface="Inter" charset="0"/>
+                        <a:cs typeface="Inter" charset="0"/>
+                      </a:endParaRPr>
                     </a:p>
                   </a:txBody>
-                  <a:tcPr marL="91440" marR="91440" marT="45720" marB="45720" anchor="ctr">
-                    <a:lnL w="12700" cap="flat" cmpd="sng" algn="ctr">
+                  <a:tcPr marL="155448" marR="155448" marT="128016" marB="128016" anchor="ctr">
+                    <a:lnL w="9525" cap="flat" cmpd="sng" algn="ctr">
                       <a:solidFill>
-                        <a:schemeClr val="accent6"/>
+                        <a:srgbClr val="22252D"/>
                       </a:solidFill>
                       <a:prstDash val="solid"/>
                       <a:round/>
                       <a:headEnd type="none" w="med" len="med"/>
                       <a:tailEnd type="none" w="med" len="med"/>
                     </a:lnL>
-                    <a:lnR w="12700" cap="flat" cmpd="sng" algn="ctr">
+                    <a:lnR w="9525" cap="flat" cmpd="sng" algn="ctr">
                       <a:solidFill>
-                        <a:schemeClr val="accent6"/>
+                        <a:srgbClr val="22252D"/>
                       </a:solidFill>
                       <a:prstDash val="solid"/>
                       <a:round/>
                       <a:headEnd type="none" w="med" len="med"/>
                       <a:tailEnd type="none" w="med" len="med"/>
                     </a:lnR>
-                    <a:lnT w="12700" cap="flat" cmpd="sng" algn="ctr">
+                    <a:lnT w="9525" cap="flat" cmpd="sng" algn="ctr">
                       <a:solidFill>
-                        <a:schemeClr val="accent6"/>
+                        <a:srgbClr val="22252D"/>
                       </a:solidFill>
                       <a:prstDash val="solid"/>
                       <a:round/>
                       <a:headEnd type="none" w="med" len="med"/>
                       <a:tailEnd type="none" w="med" len="med"/>
                     </a:lnT>
-                    <a:lnB w="12700" cap="flat" cmpd="sng" algn="ctr">
+                    <a:lnB w="9525" cap="flat" cmpd="sng" algn="ctr">
                       <a:solidFill>
-                        <a:schemeClr val="accent6"/>
+                        <a:srgbClr val="22252D"/>
                       </a:solidFill>
                       <a:prstDash val="solid"/>
                       <a:round/>
                       <a:headEnd type="none" w="med" len="med"/>
                       <a:tailEnd type="none" w="med" len="med"/>
                     </a:lnB>
+                    <a:solidFill>
+                      <a:srgbClr val="1D1D1F"/>
+                    </a:solidFill>
                   </a:tcPr>
                 </a:tc>
                 <a:tc>
@@ -3546,53 +3683,63 @@
                         <a:buNone/>
                       </a:pPr>
                       <a:r>
-                        <a:rPr lang="en-US" sz="1600" dirty="0">
+                        <a:rPr lang="en-US" sz="1500" dirty="0">
                           <a:solidFill>
-                            <a:schemeClr val="bg1"/>
+                            <a:srgbClr val="DADBDE"/>
                           </a:solidFill>
+                          <a:latin typeface="Inter" pitchFamily="34" charset="0"/>
+                          <a:ea typeface="Inter" pitchFamily="34" charset="-122"/>
+                          <a:cs typeface="Inter" pitchFamily="34" charset="-120"/>
                         </a:rPr>
                         <a:t>$0.07</a:t>
                       </a:r>
-                      <a:endParaRPr lang="en-US" sz="1600" dirty="0"/>
+                      <a:endParaRPr lang="en-US" sz="1500" dirty="0">
+                        <a:latin typeface="Inter" charset="0"/>
+                        <a:ea typeface="Inter" charset="0"/>
+                        <a:cs typeface="Inter" charset="0"/>
+                      </a:endParaRPr>
                     </a:p>
                   </a:txBody>
-                  <a:tcPr marL="91440" marR="91440" marT="45720" marB="45720" anchor="ctr">
-                    <a:lnL w="12700" cap="flat" cmpd="sng" algn="ctr">
+                  <a:tcPr marL="155448" marR="155448" marT="128016" marB="128016" anchor="ctr">
+                    <a:lnL w="9525" cap="flat" cmpd="sng" algn="ctr">
                       <a:solidFill>
-                        <a:schemeClr val="accent6"/>
+                        <a:srgbClr val="22252D"/>
                       </a:solidFill>
                       <a:prstDash val="solid"/>
                       <a:round/>
                       <a:headEnd type="none" w="med" len="med"/>
                       <a:tailEnd type="none" w="med" len="med"/>
                     </a:lnL>
-                    <a:lnR w="12700" cap="flat" cmpd="sng" algn="ctr">
+                    <a:lnR w="9525" cap="flat" cmpd="sng" algn="ctr">
                       <a:solidFill>
-                        <a:schemeClr val="accent6"/>
+                        <a:srgbClr val="22252D"/>
                       </a:solidFill>
                       <a:prstDash val="solid"/>
                       <a:round/>
                       <a:headEnd type="none" w="med" len="med"/>
                       <a:tailEnd type="none" w="med" len="med"/>
                     </a:lnR>
-                    <a:lnT w="12700" cap="flat" cmpd="sng" algn="ctr">
+                    <a:lnT w="9525" cap="flat" cmpd="sng" algn="ctr">
                       <a:solidFill>
-                        <a:schemeClr val="accent6"/>
+                        <a:srgbClr val="22252D"/>
                       </a:solidFill>
                       <a:prstDash val="solid"/>
                       <a:round/>
                       <a:headEnd type="none" w="med" len="med"/>
                       <a:tailEnd type="none" w="med" len="med"/>
                     </a:lnT>
-                    <a:lnB w="12700" cap="flat" cmpd="sng" algn="ctr">
+                    <a:lnB w="9525" cap="flat" cmpd="sng" algn="ctr">
                       <a:solidFill>
-                        <a:schemeClr val="accent6"/>
+                        <a:srgbClr val="22252D"/>
                       </a:solidFill>
                       <a:prstDash val="solid"/>
                       <a:round/>
                       <a:headEnd type="none" w="med" len="med"/>
                       <a:tailEnd type="none" w="med" len="med"/>
                     </a:lnB>
+                    <a:solidFill>
+                      <a:srgbClr val="1D1D1F"/>
+                    </a:solidFill>
                   </a:tcPr>
                 </a:tc>
                 <a:tc>
@@ -3604,57 +3751,67 @@
                         <a:buNone/>
                       </a:pPr>
                       <a:r>
-                        <a:rPr lang="en-US" sz="1600" dirty="0">
+                        <a:rPr lang="en-US" sz="1500" dirty="0">
                           <a:solidFill>
-                            <a:schemeClr val="bg1"/>
+                            <a:srgbClr val="DADBDE"/>
                           </a:solidFill>
+                          <a:latin typeface="Inter" pitchFamily="34" charset="0"/>
+                          <a:ea typeface="Inter" pitchFamily="34" charset="-122"/>
+                          <a:cs typeface="Inter" pitchFamily="34" charset="-120"/>
                         </a:rPr>
                         <a:t>$0</a:t>
                       </a:r>
-                      <a:endParaRPr lang="en-US" sz="1600" dirty="0"/>
+                      <a:endParaRPr lang="en-US" sz="1500" dirty="0">
+                        <a:latin typeface="Inter" charset="0"/>
+                        <a:ea typeface="Inter" charset="0"/>
+                        <a:cs typeface="Inter" charset="0"/>
+                      </a:endParaRPr>
                     </a:p>
                   </a:txBody>
-                  <a:tcPr marL="91440" marR="91440" marT="45720" marB="45720" anchor="ctr">
-                    <a:lnL w="12700" cap="flat" cmpd="sng" algn="ctr">
+                  <a:tcPr marL="155448" marR="155448" marT="128016" marB="128016" anchor="ctr">
+                    <a:lnL w="9525" cap="flat" cmpd="sng" algn="ctr">
                       <a:solidFill>
-                        <a:schemeClr val="accent6"/>
+                        <a:srgbClr val="22252D"/>
                       </a:solidFill>
                       <a:prstDash val="solid"/>
                       <a:round/>
                       <a:headEnd type="none" w="med" len="med"/>
                       <a:tailEnd type="none" w="med" len="med"/>
                     </a:lnL>
-                    <a:lnR w="12700" cap="flat" cmpd="sng" algn="ctr">
+                    <a:lnR w="9525" cap="flat" cmpd="sng" algn="ctr">
                       <a:solidFill>
-                        <a:schemeClr val="accent6"/>
+                        <a:srgbClr val="22252D"/>
                       </a:solidFill>
                       <a:prstDash val="solid"/>
                       <a:round/>
                       <a:headEnd type="none" w="med" len="med"/>
                       <a:tailEnd type="none" w="med" len="med"/>
                     </a:lnR>
-                    <a:lnT w="12700" cap="flat" cmpd="sng" algn="ctr">
+                    <a:lnT w="9525" cap="flat" cmpd="sng" algn="ctr">
                       <a:solidFill>
-                        <a:schemeClr val="accent6"/>
+                        <a:srgbClr val="22252D"/>
                       </a:solidFill>
                       <a:prstDash val="solid"/>
                       <a:round/>
                       <a:headEnd type="none" w="med" len="med"/>
                       <a:tailEnd type="none" w="med" len="med"/>
                     </a:lnT>
-                    <a:lnB w="12700" cap="flat" cmpd="sng" algn="ctr">
+                    <a:lnB w="9525" cap="flat" cmpd="sng" algn="ctr">
                       <a:solidFill>
-                        <a:schemeClr val="accent6"/>
+                        <a:srgbClr val="22252D"/>
                       </a:solidFill>
                       <a:prstDash val="solid"/>
                       <a:round/>
                       <a:headEnd type="none" w="med" len="med"/>
                       <a:tailEnd type="none" w="med" len="med"/>
                     </a:lnB>
+                    <a:solidFill>
+                      <a:srgbClr val="1D1D1F"/>
+                    </a:solidFill>
                   </a:tcPr>
                 </a:tc>
               </a:tr>
-              <a:tr h="502920">
+              <a:tr h="444500">
                 <a:tc>
                   <a:txBody>
                     <a:bodyPr/>
@@ -3664,53 +3821,63 @@
                         <a:buNone/>
                       </a:pPr>
                       <a:r>
-                        <a:rPr lang="en-US" sz="1600" dirty="0">
+                        <a:rPr lang="en-US" sz="1500" b="1" dirty="0">
                           <a:solidFill>
-                            <a:schemeClr val="bg1"/>
+                            <a:srgbClr val="FFFFFF"/>
                           </a:solidFill>
+                          <a:latin typeface="Inter" pitchFamily="34" charset="0"/>
+                          <a:ea typeface="Inter" pitchFamily="34" charset="-122"/>
+                          <a:cs typeface="Inter" pitchFamily="34" charset="-120"/>
                         </a:rPr>
                         <a:t>1,000 runs of 25</a:t>
                       </a:r>
-                      <a:endParaRPr lang="en-US" sz="1600" dirty="0"/>
+                      <a:endParaRPr lang="en-US" sz="1500" dirty="0">
+                        <a:latin typeface="Inter" charset="0"/>
+                        <a:ea typeface="Inter" charset="0"/>
+                        <a:cs typeface="Inter" charset="0"/>
+                      </a:endParaRPr>
                     </a:p>
                   </a:txBody>
-                  <a:tcPr marL="91440" marR="91440" marT="45720" marB="45720" anchor="ctr">
-                    <a:lnL w="12700" cap="flat" cmpd="sng" algn="ctr">
+                  <a:tcPr marL="155448" marR="155448" marT="128016" marB="128016" anchor="ctr">
+                    <a:lnL w="9525" cap="flat" cmpd="sng" algn="ctr">
                       <a:solidFill>
-                        <a:schemeClr val="accent6"/>
+                        <a:srgbClr val="22252D"/>
                       </a:solidFill>
                       <a:prstDash val="solid"/>
                       <a:round/>
                       <a:headEnd type="none" w="med" len="med"/>
                       <a:tailEnd type="none" w="med" len="med"/>
                     </a:lnL>
-                    <a:lnR w="12700" cap="flat" cmpd="sng" algn="ctr">
+                    <a:lnR w="9525" cap="flat" cmpd="sng" algn="ctr">
                       <a:solidFill>
-                        <a:schemeClr val="accent6"/>
+                        <a:srgbClr val="22252D"/>
                       </a:solidFill>
                       <a:prstDash val="solid"/>
                       <a:round/>
                       <a:headEnd type="none" w="med" len="med"/>
                       <a:tailEnd type="none" w="med" len="med"/>
                     </a:lnR>
-                    <a:lnT w="12700" cap="flat" cmpd="sng" algn="ctr">
+                    <a:lnT w="9525" cap="flat" cmpd="sng" algn="ctr">
                       <a:solidFill>
-                        <a:schemeClr val="accent6"/>
+                        <a:srgbClr val="22252D"/>
                       </a:solidFill>
                       <a:prstDash val="solid"/>
                       <a:round/>
                       <a:headEnd type="none" w="med" len="med"/>
                       <a:tailEnd type="none" w="med" len="med"/>
                     </a:lnT>
-                    <a:lnB w="12700" cap="flat" cmpd="sng" algn="ctr">
+                    <a:lnB w="9525" cap="flat" cmpd="sng" algn="ctr">
                       <a:solidFill>
-                        <a:schemeClr val="accent6"/>
+                        <a:srgbClr val="22252D"/>
                       </a:solidFill>
                       <a:prstDash val="solid"/>
                       <a:round/>
                       <a:headEnd type="none" w="med" len="med"/>
                       <a:tailEnd type="none" w="med" len="med"/>
                     </a:lnB>
+                    <a:solidFill>
+                      <a:srgbClr val="1D1D1F"/>
+                    </a:solidFill>
                   </a:tcPr>
                 </a:tc>
                 <a:tc>
@@ -3722,53 +3889,63 @@
                         <a:buNone/>
                       </a:pPr>
                       <a:r>
-                        <a:rPr lang="en-US" sz="1600" dirty="0">
+                        <a:rPr lang="en-US" sz="1500" dirty="0">
                           <a:solidFill>
-                            <a:schemeClr val="bg1"/>
+                            <a:srgbClr val="DADBDE"/>
                           </a:solidFill>
+                          <a:latin typeface="Inter" pitchFamily="34" charset="0"/>
+                          <a:ea typeface="Inter" pitchFamily="34" charset="-122"/>
+                          <a:cs typeface="Inter" pitchFamily="34" charset="-120"/>
                         </a:rPr>
                         <a:t>about $74</a:t>
                       </a:r>
-                      <a:endParaRPr lang="en-US" sz="1600" dirty="0"/>
+                      <a:endParaRPr lang="en-US" sz="1500" dirty="0">
+                        <a:latin typeface="Inter" charset="0"/>
+                        <a:ea typeface="Inter" charset="0"/>
+                        <a:cs typeface="Inter" charset="0"/>
+                      </a:endParaRPr>
                     </a:p>
                   </a:txBody>
-                  <a:tcPr marL="91440" marR="91440" marT="45720" marB="45720" anchor="ctr">
-                    <a:lnL w="12700" cap="flat" cmpd="sng" algn="ctr">
+                  <a:tcPr marL="155448" marR="155448" marT="128016" marB="128016" anchor="ctr">
+                    <a:lnL w="9525" cap="flat" cmpd="sng" algn="ctr">
                       <a:solidFill>
-                        <a:schemeClr val="accent6"/>
+                        <a:srgbClr val="22252D"/>
                       </a:solidFill>
                       <a:prstDash val="solid"/>
                       <a:round/>
                       <a:headEnd type="none" w="med" len="med"/>
                       <a:tailEnd type="none" w="med" len="med"/>
                     </a:lnL>
-                    <a:lnR w="12700" cap="flat" cmpd="sng" algn="ctr">
+                    <a:lnR w="9525" cap="flat" cmpd="sng" algn="ctr">
                       <a:solidFill>
-                        <a:schemeClr val="accent6"/>
+                        <a:srgbClr val="22252D"/>
                       </a:solidFill>
                       <a:prstDash val="solid"/>
                       <a:round/>
                       <a:headEnd type="none" w="med" len="med"/>
                       <a:tailEnd type="none" w="med" len="med"/>
                     </a:lnR>
-                    <a:lnT w="12700" cap="flat" cmpd="sng" algn="ctr">
+                    <a:lnT w="9525" cap="flat" cmpd="sng" algn="ctr">
                       <a:solidFill>
-                        <a:schemeClr val="accent6"/>
+                        <a:srgbClr val="22252D"/>
                       </a:solidFill>
                       <a:prstDash val="solid"/>
                       <a:round/>
                       <a:headEnd type="none" w="med" len="med"/>
                       <a:tailEnd type="none" w="med" len="med"/>
                     </a:lnT>
-                    <a:lnB w="12700" cap="flat" cmpd="sng" algn="ctr">
+                    <a:lnB w="9525" cap="flat" cmpd="sng" algn="ctr">
                       <a:solidFill>
-                        <a:schemeClr val="accent6"/>
+                        <a:srgbClr val="22252D"/>
                       </a:solidFill>
                       <a:prstDash val="solid"/>
                       <a:round/>
                       <a:headEnd type="none" w="med" len="med"/>
                       <a:tailEnd type="none" w="med" len="med"/>
                     </a:lnB>
+                    <a:solidFill>
+                      <a:srgbClr val="1D1D1F"/>
+                    </a:solidFill>
                   </a:tcPr>
                 </a:tc>
                 <a:tc>
@@ -3780,57 +3957,67 @@
                         <a:buNone/>
                       </a:pPr>
                       <a:r>
-                        <a:rPr lang="en-US" sz="1600" dirty="0">
+                        <a:rPr lang="en-US" sz="1500" dirty="0">
                           <a:solidFill>
-                            <a:schemeClr val="bg1"/>
+                            <a:srgbClr val="DADBDE"/>
                           </a:solidFill>
+                          <a:latin typeface="Inter" pitchFamily="34" charset="0"/>
+                          <a:ea typeface="Inter" pitchFamily="34" charset="-122"/>
+                          <a:cs typeface="Inter" pitchFamily="34" charset="-120"/>
                         </a:rPr>
                         <a:t>$0</a:t>
                       </a:r>
-                      <a:endParaRPr lang="en-US" sz="1600" dirty="0"/>
+                      <a:endParaRPr lang="en-US" sz="1500" dirty="0">
+                        <a:latin typeface="Inter" charset="0"/>
+                        <a:ea typeface="Inter" charset="0"/>
+                        <a:cs typeface="Inter" charset="0"/>
+                      </a:endParaRPr>
                     </a:p>
                   </a:txBody>
-                  <a:tcPr marL="91440" marR="91440" marT="45720" marB="45720" anchor="ctr">
-                    <a:lnL w="12700" cap="flat" cmpd="sng" algn="ctr">
+                  <a:tcPr marL="155448" marR="155448" marT="128016" marB="128016" anchor="ctr">
+                    <a:lnL w="9525" cap="flat" cmpd="sng" algn="ctr">
                       <a:solidFill>
-                        <a:schemeClr val="accent6"/>
+                        <a:srgbClr val="22252D"/>
                       </a:solidFill>
                       <a:prstDash val="solid"/>
                       <a:round/>
                       <a:headEnd type="none" w="med" len="med"/>
                       <a:tailEnd type="none" w="med" len="med"/>
                     </a:lnL>
-                    <a:lnR w="12700" cap="flat" cmpd="sng" algn="ctr">
+                    <a:lnR w="9525" cap="flat" cmpd="sng" algn="ctr">
                       <a:solidFill>
-                        <a:schemeClr val="accent6"/>
+                        <a:srgbClr val="22252D"/>
                       </a:solidFill>
                       <a:prstDash val="solid"/>
                       <a:round/>
                       <a:headEnd type="none" w="med" len="med"/>
                       <a:tailEnd type="none" w="med" len="med"/>
                     </a:lnR>
-                    <a:lnT w="12700" cap="flat" cmpd="sng" algn="ctr">
+                    <a:lnT w="9525" cap="flat" cmpd="sng" algn="ctr">
                       <a:solidFill>
-                        <a:schemeClr val="accent6"/>
+                        <a:srgbClr val="22252D"/>
                       </a:solidFill>
                       <a:prstDash val="solid"/>
                       <a:round/>
                       <a:headEnd type="none" w="med" len="med"/>
                       <a:tailEnd type="none" w="med" len="med"/>
                     </a:lnT>
-                    <a:lnB w="12700" cap="flat" cmpd="sng" algn="ctr">
+                    <a:lnB w="9525" cap="flat" cmpd="sng" algn="ctr">
                       <a:solidFill>
-                        <a:schemeClr val="accent6"/>
+                        <a:srgbClr val="22252D"/>
                       </a:solidFill>
                       <a:prstDash val="solid"/>
                       <a:round/>
                       <a:headEnd type="none" w="med" len="med"/>
                       <a:tailEnd type="none" w="med" len="med"/>
                     </a:lnB>
+                    <a:solidFill>
+                      <a:srgbClr val="1D1D1F"/>
+                    </a:solidFill>
                   </a:tcPr>
                 </a:tc>
               </a:tr>
-              <a:tr h="502920">
+              <a:tr h="444500">
                 <a:tc>
                   <a:txBody>
                     <a:bodyPr/>
@@ -3840,53 +4027,63 @@
                         <a:buNone/>
                       </a:pPr>
                       <a:r>
-                        <a:rPr lang="en-US" sz="1600" dirty="0">
+                        <a:rPr lang="en-US" sz="1500" b="1" dirty="0">
                           <a:solidFill>
-                            <a:schemeClr val="bg1"/>
+                            <a:srgbClr val="FFFFFF"/>
                           </a:solidFill>
+                          <a:latin typeface="Inter" pitchFamily="34" charset="0"/>
+                          <a:ea typeface="Inter" pitchFamily="34" charset="-122"/>
+                          <a:cs typeface="Inter" pitchFamily="34" charset="-120"/>
                         </a:rPr>
                         <a:t>Whole backlog, 27,981 groups</a:t>
                       </a:r>
-                      <a:endParaRPr lang="en-US" sz="1600" dirty="0"/>
+                      <a:endParaRPr lang="en-US" sz="1500" dirty="0">
+                        <a:latin typeface="Inter" charset="0"/>
+                        <a:ea typeface="Inter" charset="0"/>
+                        <a:cs typeface="Inter" charset="0"/>
+                      </a:endParaRPr>
                     </a:p>
                   </a:txBody>
-                  <a:tcPr marL="91440" marR="91440" marT="45720" marB="45720" anchor="ctr">
-                    <a:lnL w="12700" cap="flat" cmpd="sng" algn="ctr">
+                  <a:tcPr marL="155448" marR="155448" marT="128016" marB="128016" anchor="ctr">
+                    <a:lnL w="9525" cap="flat" cmpd="sng" algn="ctr">
                       <a:solidFill>
-                        <a:schemeClr val="accent6"/>
+                        <a:srgbClr val="22252D"/>
                       </a:solidFill>
                       <a:prstDash val="solid"/>
                       <a:round/>
                       <a:headEnd type="none" w="med" len="med"/>
                       <a:tailEnd type="none" w="med" len="med"/>
                     </a:lnL>
-                    <a:lnR w="12700" cap="flat" cmpd="sng" algn="ctr">
+                    <a:lnR w="9525" cap="flat" cmpd="sng" algn="ctr">
                       <a:solidFill>
-                        <a:schemeClr val="accent6"/>
+                        <a:srgbClr val="22252D"/>
                       </a:solidFill>
                       <a:prstDash val="solid"/>
                       <a:round/>
                       <a:headEnd type="none" w="med" len="med"/>
                       <a:tailEnd type="none" w="med" len="med"/>
                     </a:lnR>
-                    <a:lnT w="12700" cap="flat" cmpd="sng" algn="ctr">
+                    <a:lnT w="9525" cap="flat" cmpd="sng" algn="ctr">
                       <a:solidFill>
-                        <a:schemeClr val="accent6"/>
+                        <a:srgbClr val="22252D"/>
                       </a:solidFill>
                       <a:prstDash val="solid"/>
                       <a:round/>
                       <a:headEnd type="none" w="med" len="med"/>
                       <a:tailEnd type="none" w="med" len="med"/>
                     </a:lnT>
-                    <a:lnB w="12700" cap="flat" cmpd="sng" algn="ctr">
+                    <a:lnB w="9525" cap="flat" cmpd="sng" algn="ctr">
                       <a:solidFill>
-                        <a:schemeClr val="accent6"/>
+                        <a:srgbClr val="22252D"/>
                       </a:solidFill>
                       <a:prstDash val="solid"/>
                       <a:round/>
                       <a:headEnd type="none" w="med" len="med"/>
                       <a:tailEnd type="none" w="med" len="med"/>
                     </a:lnB>
+                    <a:solidFill>
+                      <a:srgbClr val="1D1D1F"/>
+                    </a:solidFill>
                   </a:tcPr>
                 </a:tc>
                 <a:tc>
@@ -3898,53 +4095,63 @@
                         <a:buNone/>
                       </a:pPr>
                       <a:r>
-                        <a:rPr lang="en-US" sz="1600" dirty="0">
+                        <a:rPr lang="en-US" sz="1500" dirty="0">
                           <a:solidFill>
-                            <a:schemeClr val="bg1"/>
+                            <a:srgbClr val="DADBDE"/>
                           </a:solidFill>
+                          <a:latin typeface="Inter" pitchFamily="34" charset="0"/>
+                          <a:ea typeface="Inter" pitchFamily="34" charset="-122"/>
+                          <a:cs typeface="Inter" pitchFamily="34" charset="-120"/>
                         </a:rPr>
                         <a:t>about $82</a:t>
                       </a:r>
-                      <a:endParaRPr lang="en-US" sz="1600" dirty="0"/>
+                      <a:endParaRPr lang="en-US" sz="1500" dirty="0">
+                        <a:latin typeface="Inter" charset="0"/>
+                        <a:ea typeface="Inter" charset="0"/>
+                        <a:cs typeface="Inter" charset="0"/>
+                      </a:endParaRPr>
                     </a:p>
                   </a:txBody>
-                  <a:tcPr marL="91440" marR="91440" marT="45720" marB="45720" anchor="ctr">
-                    <a:lnL w="12700" cap="flat" cmpd="sng" algn="ctr">
+                  <a:tcPr marL="155448" marR="155448" marT="128016" marB="128016" anchor="ctr">
+                    <a:lnL w="9525" cap="flat" cmpd="sng" algn="ctr">
                       <a:solidFill>
-                        <a:schemeClr val="accent6"/>
+                        <a:srgbClr val="22252D"/>
                       </a:solidFill>
                       <a:prstDash val="solid"/>
                       <a:round/>
                       <a:headEnd type="none" w="med" len="med"/>
                       <a:tailEnd type="none" w="med" len="med"/>
                     </a:lnL>
-                    <a:lnR w="12700" cap="flat" cmpd="sng" algn="ctr">
+                    <a:lnR w="9525" cap="flat" cmpd="sng" algn="ctr">
                       <a:solidFill>
-                        <a:schemeClr val="accent6"/>
+                        <a:srgbClr val="22252D"/>
                       </a:solidFill>
                       <a:prstDash val="solid"/>
                       <a:round/>
                       <a:headEnd type="none" w="med" len="med"/>
                       <a:tailEnd type="none" w="med" len="med"/>
                     </a:lnR>
-                    <a:lnT w="12700" cap="flat" cmpd="sng" algn="ctr">
+                    <a:lnT w="9525" cap="flat" cmpd="sng" algn="ctr">
                       <a:solidFill>
-                        <a:schemeClr val="accent6"/>
+                        <a:srgbClr val="22252D"/>
                       </a:solidFill>
                       <a:prstDash val="solid"/>
                       <a:round/>
                       <a:headEnd type="none" w="med" len="med"/>
                       <a:tailEnd type="none" w="med" len="med"/>
                     </a:lnT>
-                    <a:lnB w="12700" cap="flat" cmpd="sng" algn="ctr">
+                    <a:lnB w="9525" cap="flat" cmpd="sng" algn="ctr">
                       <a:solidFill>
-                        <a:schemeClr val="accent6"/>
+                        <a:srgbClr val="22252D"/>
                       </a:solidFill>
                       <a:prstDash val="solid"/>
                       <a:round/>
                       <a:headEnd type="none" w="med" len="med"/>
                       <a:tailEnd type="none" w="med" len="med"/>
                     </a:lnB>
+                    <a:solidFill>
+                      <a:srgbClr val="1D1D1F"/>
+                    </a:solidFill>
                   </a:tcPr>
                 </a:tc>
                 <a:tc>
@@ -3956,53 +4163,63 @@
                         <a:buNone/>
                       </a:pPr>
                       <a:r>
-                        <a:rPr lang="en-US" sz="1600" dirty="0">
+                        <a:rPr lang="en-US" sz="1500" dirty="0">
                           <a:solidFill>
-                            <a:schemeClr val="bg1"/>
+                            <a:srgbClr val="DADBDE"/>
                           </a:solidFill>
+                          <a:latin typeface="Inter" pitchFamily="34" charset="0"/>
+                          <a:ea typeface="Inter" pitchFamily="34" charset="-122"/>
+                          <a:cs typeface="Inter" pitchFamily="34" charset="-120"/>
                         </a:rPr>
                         <a:t>$0</a:t>
                       </a:r>
-                      <a:endParaRPr lang="en-US" sz="1600" dirty="0"/>
+                      <a:endParaRPr lang="en-US" sz="1500" dirty="0">
+                        <a:latin typeface="Inter" charset="0"/>
+                        <a:ea typeface="Inter" charset="0"/>
+                        <a:cs typeface="Inter" charset="0"/>
+                      </a:endParaRPr>
                     </a:p>
                   </a:txBody>
-                  <a:tcPr marL="91440" marR="91440" marT="45720" marB="45720" anchor="ctr">
-                    <a:lnL w="12700" cap="flat" cmpd="sng" algn="ctr">
+                  <a:tcPr marL="155448" marR="155448" marT="128016" marB="128016" anchor="ctr">
+                    <a:lnL w="9525" cap="flat" cmpd="sng" algn="ctr">
                       <a:solidFill>
-                        <a:schemeClr val="accent6"/>
+                        <a:srgbClr val="22252D"/>
                       </a:solidFill>
                       <a:prstDash val="solid"/>
                       <a:round/>
                       <a:headEnd type="none" w="med" len="med"/>
                       <a:tailEnd type="none" w="med" len="med"/>
                     </a:lnL>
-                    <a:lnR w="12700" cap="flat" cmpd="sng" algn="ctr">
+                    <a:lnR w="9525" cap="flat" cmpd="sng" algn="ctr">
                       <a:solidFill>
-                        <a:schemeClr val="accent6"/>
+                        <a:srgbClr val="22252D"/>
                       </a:solidFill>
                       <a:prstDash val="solid"/>
                       <a:round/>
                       <a:headEnd type="none" w="med" len="med"/>
                       <a:tailEnd type="none" w="med" len="med"/>
                     </a:lnR>
-                    <a:lnT w="12700" cap="flat" cmpd="sng" algn="ctr">
+                    <a:lnT w="9525" cap="flat" cmpd="sng" algn="ctr">
                       <a:solidFill>
-                        <a:schemeClr val="accent6"/>
+                        <a:srgbClr val="22252D"/>
                       </a:solidFill>
                       <a:prstDash val="solid"/>
                       <a:round/>
                       <a:headEnd type="none" w="med" len="med"/>
                       <a:tailEnd type="none" w="med" len="med"/>
                     </a:lnT>
-                    <a:lnB w="12700" cap="flat" cmpd="sng" algn="ctr">
+                    <a:lnB w="9525" cap="flat" cmpd="sng" algn="ctr">
                       <a:solidFill>
-                        <a:schemeClr val="accent6"/>
+                        <a:srgbClr val="22252D"/>
                       </a:solidFill>
                       <a:prstDash val="solid"/>
                       <a:round/>
                       <a:headEnd type="none" w="med" len="med"/>
                       <a:tailEnd type="none" w="med" len="med"/>
                     </a:lnB>
+                    <a:solidFill>
+                      <a:srgbClr val="1D1D1F"/>
+                    </a:solidFill>
                   </a:tcPr>
                 </a:tc>
               </a:tr>
@@ -4012,14 +4229,14 @@
       </p:graphicFrame>
       <p:sp>
         <p:nvSpPr>
-          <p:cNvPr id="4" name="Text 1"/>
+          <p:cNvPr id="5" name="Text 2"/>
           <p:cNvSpPr txBox="1"/>
           <p:nvPr/>
         </p:nvSpPr>
         <p:spPr>
           <a:xfrm>
-            <a:off x="457200" y="3840480"/>
-            <a:ext cx="8229600" cy="640080"/>
+            <a:off x="635000" y="3683000"/>
+            <a:ext cx="10922000" cy="228600"/>
           </a:xfrm>
           <a:prstGeom prst="rect">
             <a:avLst/>
@@ -4035,59 +4252,17 @@
               <a:buNone/>
             </a:pPr>
             <a:r>
-              <a:rPr lang="en-US" sz="1400" dirty="0">
+              <a:rPr lang="en-US" sz="1650" dirty="0">
                 <a:solidFill>
-                  <a:schemeClr val="bg2"/>
+                  <a:srgbClr val="8D9098"/>
                 </a:solidFill>
+                <a:latin typeface="Inter" pitchFamily="34" charset="0"/>
+                <a:ea typeface="Inter" pitchFamily="34" charset="-122"/>
+                <a:cs typeface="Inter" pitchFamily="34" charset="-120"/>
               </a:rPr>
-              <a:t>Haiku 4.5 list price, measured on 25 groups and extrapolated. The Aiven gateway meters the exact figure per key.</a:t>
-            </a:r>
-            <a:endParaRPr lang="en-US" sz="1400" dirty="0"/>
-          </a:p>
-        </p:txBody>
-      </p:sp>
-      <p:sp>
-        <p:nvSpPr>
-          <p:cNvPr id="25" name="Slide Number Placeholder 0"/>
-          <p:cNvSpPr>
-            <a:spLocks noGrp="1"/>
-          </p:cNvSpPr>
-          <p:nvPr>
-            <p:ph type="sldNum" sz="quarter" idx="4294967295"/>
-          </p:nvPr>
-        </p:nvSpPr>
-        <p:spPr>
-          <a:xfrm>
-            <a:off x="8412480" y="4754880"/>
-            <a:ext cx="457200" cy="274320"/>
-          </a:xfrm>
-          <a:prstGeom prst="rect">
-            <a:avLst/>
-          </a:prstGeom>
-          <a:extLst>
-            <a:ext uri="{C572A759-6A51-4108-AA02-DFA0A04FC94B}">
-              <ma14:wrappingTextBoxFlag xmlns:ma14="http://schemas.microsoft.com/office/mac/drawingml/2011/main" val="0"/>
-            </a:ext>
-          </a:extLst>
-        </p:spPr>
-        <p:txBody>
-          <a:bodyPr/>
-          <a:lstStyle>
-            <a:lvl1pPr>
-              <a:defRPr sz="1000">
-                <a:solidFill>
-                  <a:schemeClr val="accent6"/>
-                </a:solidFill>
-              </a:defRPr>
-            </a:lvl1pPr>
-          </a:lstStyle>
-          <a:p>
-            <a:pPr algn="l"/>
-            <a:fld id="{F7021451-1387-4CA6-816F-3879F97B5CBC}" type="slidenum">
-              <a:rPr b="0" lang="en-US"/>
-              <a:t>6</a:t>
-            </a:fld>
-            <a:endParaRPr lang="en-US"/>
+              <a:t>Haiku 4.5 list price, measured on 25 groups and extrapolated. The Aiven AI gateway meters the exact figure per key.</a:t>
+            </a:r>
+            <a:endParaRPr lang="en-US" sz="1650" dirty="0"/>
           </a:p>
         </p:txBody>
       </p:sp>
@@ -4102,6 +4277,20 @@
 <file path=ppt/slides/slide7.xml><?xml version="1.0" encoding="utf-8"?>
 <p:sld xmlns:a="http://schemas.openxmlformats.org/drawingml/2006/main" xmlns:r="http://schemas.openxmlformats.org/officeDocument/2006/relationships" xmlns:p="http://schemas.openxmlformats.org/presentationml/2006/main">
   <p:cSld name="Slide 7">
+    <p:bg>
+      <p:bgPr>
+        <a:blipFill dpi="0" rotWithShape="1">
+          <a:blip r:embed="rId1">
+            <a:lum/>
+          </a:blip>
+          <a:srcRect/>
+          <a:stretch>
+            <a:fillRect/>
+          </a:stretch>
+        </a:blipFill>
+        <a:effectLst/>
+      </p:bgPr>
+    </p:bg>
     <p:spTree>
       <p:nvGrpSpPr>
         <p:cNvPr id="1" name=""/>
@@ -4119,15 +4308,13 @@
       <p:sp>
         <p:nvSpPr>
           <p:cNvPr id="2" name="Text 0"/>
-          <p:cNvSpPr/>
-          <p:nvPr>
-            <p:ph idx="100" type="title" hasCustomPrompt="1"/>
-          </p:nvPr>
-        </p:nvSpPr>
-        <p:spPr>
-          <a:xfrm>
-            <a:off x="457200" y="274320"/>
-            <a:ext cx="8229600" cy="822960"/>
+          <p:cNvSpPr txBox="1"/>
+          <p:nvPr/>
+        </p:nvSpPr>
+        <p:spPr>
+          <a:xfrm>
+            <a:off x="635000" y="635000"/>
+            <a:ext cx="10922000" cy="165100"/>
           </a:xfrm>
           <a:prstGeom prst="rect">
             <a:avLst/>
@@ -4143,43 +4330,85 @@
               <a:buNone/>
             </a:pPr>
             <a:r>
-              <a:rPr lang="en-US" sz="3000" b="1" dirty="0">
+              <a:rPr lang="en-US" sz="1350" spc="200" kern="0" dirty="0">
                 <a:solidFill>
-                  <a:schemeClr val="bg1"/>
+                  <a:srgbClr val="5FFA74"/>
                 </a:solidFill>
+                <a:latin typeface="Geist Mono" pitchFamily="34" charset="0"/>
+                <a:ea typeface="Geist Mono" pitchFamily="34" charset="-122"/>
+                <a:cs typeface="Geist Mono" pitchFamily="34" charset="-120"/>
               </a:rPr>
-              <a:t>17k to 42k groups in 24 hours</a:t>
-            </a:r>
-            <a:endParaRPr lang="en-US" sz="3000" dirty="0"/>
+              <a:t>// DEPLOYED ON AIVEN</a:t>
+            </a:r>
+            <a:endParaRPr lang="en-US" sz="1350" dirty="0"/>
+          </a:p>
+        </p:txBody>
+      </p:sp>
+      <p:sp>
+        <p:nvSpPr>
+          <p:cNvPr id="3" name="Text 1"/>
+          <p:cNvSpPr txBox="1"/>
+          <p:nvPr/>
+        </p:nvSpPr>
+        <p:spPr>
+          <a:xfrm>
+            <a:off x="635000" y="927100"/>
+            <a:ext cx="10922000" cy="391160"/>
+          </a:xfrm>
+          <a:prstGeom prst="rect">
+            <a:avLst/>
+          </a:prstGeom>
+          <a:noFill/>
+          <a:ln/>
+        </p:spPr>
+        <p:txBody>
+          <a:bodyPr wrap="square" lIns="0" tIns="0" rIns="0" bIns="0" rtlCol="0" anchor="t"/>
+          <a:lstStyle/>
+          <a:p>
+            <a:pPr indent="0" marL="0">
+              <a:buNone/>
+            </a:pPr>
+            <a:r>
+              <a:rPr lang="en-US" sz="4200" dirty="0">
+                <a:solidFill>
+                  <a:srgbClr val="FFFFFF"/>
+                </a:solidFill>
+                <a:latin typeface="Funnel Display ExtraBold" pitchFamily="34" charset="0"/>
+                <a:ea typeface="Funnel Display ExtraBold" pitchFamily="34" charset="-122"/>
+                <a:cs typeface="Funnel Display ExtraBold" pitchFamily="34" charset="-120"/>
+              </a:rPr>
+              <a:t>17K TO 42K GROUPS IN 24 HOURS</a:t>
+            </a:r>
+            <a:endParaRPr lang="en-US" sz="4200" dirty="0"/>
           </a:p>
         </p:txBody>
       </p:sp>
       <p:graphicFrame>
         <p:nvGraphicFramePr>
-          <p:cNvPr id="3" name="Chart 0" descr=""/>
+          <p:cNvPr id="4" name="Chart 0" descr=""/>
           <p:cNvGraphicFramePr/>
           <p:nvPr/>
         </p:nvGraphicFramePr>
         <p:xfrm>
-          <a:off x="457200" y="1280160"/>
-          <a:ext cx="8229600" cy="3017520"/>
+          <a:off x="635000" y="1435100"/>
+          <a:ext cx="10922000" cy="3302000"/>
         </p:xfrm>
         <a:graphic xmlns:a="http://schemas.openxmlformats.org/drawingml/2006/main">
           <a:graphicData uri="http://schemas.openxmlformats.org/drawingml/2006/chart">
-            <c:chart xmlns:c="http://schemas.openxmlformats.org/drawingml/2006/chart" r:id="rId1"/>
+            <c:chart xmlns:c="http://schemas.openxmlformats.org/drawingml/2006/chart" r:id="rId2"/>
           </a:graphicData>
         </a:graphic>
       </p:graphicFrame>
       <p:sp>
         <p:nvSpPr>
-          <p:cNvPr id="4" name="Text 1"/>
+          <p:cNvPr id="5" name="Text 2"/>
           <p:cNvSpPr txBox="1"/>
           <p:nvPr/>
         </p:nvSpPr>
         <p:spPr>
           <a:xfrm>
-            <a:off x="457200" y="4389120"/>
-            <a:ext cx="8229600" cy="365760"/>
+            <a:off x="635000" y="4813300"/>
+            <a:ext cx="10922000" cy="228600"/>
           </a:xfrm>
           <a:prstGeom prst="rect">
             <a:avLst/>
@@ -4188,66 +4417,24 @@
           <a:ln/>
         </p:spPr>
         <p:txBody>
-          <a:bodyPr wrap="square" lIns="0" tIns="0" rIns="0" bIns="0" rtlCol="0" anchor="ctr"/>
+          <a:bodyPr wrap="square" lIns="0" tIns="0" rIns="0" bIns="0" rtlCol="0" anchor="t"/>
           <a:lstStyle/>
           <a:p>
             <a:pPr indent="0" marL="0">
               <a:buNone/>
             </a:pPr>
             <a:r>
-              <a:rPr lang="en-US" sz="1400" dirty="0">
+              <a:rPr lang="en-US" sz="1650" dirty="0">
                 <a:solidFill>
-                  <a:schemeClr val="bg2"/>
+                  <a:srgbClr val="8D9098"/>
                 </a:solidFill>
+                <a:latin typeface="Inter" pitchFamily="34" charset="0"/>
+                <a:ea typeface="Inter" pitchFamily="34" charset="-122"/>
+                <a:cs typeface="Inter" pitchFamily="34" charset="-120"/>
               </a:rPr>
-              <a:t>New groups scraped per hour after the fix: steady at about 1,150.</a:t>
-            </a:r>
-            <a:endParaRPr lang="en-US" sz="1400" dirty="0"/>
-          </a:p>
-        </p:txBody>
-      </p:sp>
-      <p:sp>
-        <p:nvSpPr>
-          <p:cNvPr id="25" name="Slide Number Placeholder 0"/>
-          <p:cNvSpPr>
-            <a:spLocks noGrp="1"/>
-          </p:cNvSpPr>
-          <p:nvPr>
-            <p:ph type="sldNum" sz="quarter" idx="4294967295"/>
-          </p:nvPr>
-        </p:nvSpPr>
-        <p:spPr>
-          <a:xfrm>
-            <a:off x="8412480" y="4754880"/>
-            <a:ext cx="457200" cy="274320"/>
-          </a:xfrm>
-          <a:prstGeom prst="rect">
-            <a:avLst/>
-          </a:prstGeom>
-          <a:extLst>
-            <a:ext uri="{C572A759-6A51-4108-AA02-DFA0A04FC94B}">
-              <ma14:wrappingTextBoxFlag xmlns:ma14="http://schemas.microsoft.com/office/mac/drawingml/2011/main" val="0"/>
-            </a:ext>
-          </a:extLst>
-        </p:spPr>
-        <p:txBody>
-          <a:bodyPr/>
-          <a:lstStyle>
-            <a:lvl1pPr>
-              <a:defRPr sz="1000">
-                <a:solidFill>
-                  <a:schemeClr val="accent6"/>
-                </a:solidFill>
-              </a:defRPr>
-            </a:lvl1pPr>
-          </a:lstStyle>
-          <a:p>
-            <a:pPr algn="l"/>
-            <a:fld id="{F7021451-1387-4CA6-816F-3879F97B5CBC}" type="slidenum">
-              <a:rPr b="0" lang="en-US"/>
-              <a:t>7</a:t>
-            </a:fld>
-            <a:endParaRPr lang="en-US"/>
+              <a:t>New groups scraped per hour (UTC), 7 Oct 11:00 to 8 Oct 09:00. Steady at about 1,150 an hour.</a:t>
+            </a:r>
+            <a:endParaRPr lang="en-US" sz="1650" dirty="0"/>
           </a:p>
         </p:txBody>
       </p:sp>
@@ -4262,6 +4449,20 @@
 <file path=ppt/slides/slide8.xml><?xml version="1.0" encoding="utf-8"?>
 <p:sld xmlns:a="http://schemas.openxmlformats.org/drawingml/2006/main" xmlns:r="http://schemas.openxmlformats.org/officeDocument/2006/relationships" xmlns:p="http://schemas.openxmlformats.org/presentationml/2006/main">
   <p:cSld name="Slide 8">
+    <p:bg>
+      <p:bgPr>
+        <a:blipFill dpi="0" rotWithShape="1">
+          <a:blip r:embed="rId1">
+            <a:lum/>
+          </a:blip>
+          <a:srcRect/>
+          <a:stretch>
+            <a:fillRect/>
+          </a:stretch>
+        </a:blipFill>
+        <a:effectLst/>
+      </p:bgPr>
+    </p:bg>
     <p:spTree>
       <p:nvGrpSpPr>
         <p:cNvPr id="1" name=""/>
@@ -4279,15 +4480,13 @@
       <p:sp>
         <p:nvSpPr>
           <p:cNvPr id="2" name="Text 0"/>
-          <p:cNvSpPr/>
-          <p:nvPr>
-            <p:ph idx="100" type="title" hasCustomPrompt="1"/>
-          </p:nvPr>
-        </p:nvSpPr>
-        <p:spPr>
-          <a:xfrm>
-            <a:off x="457200" y="274320"/>
-            <a:ext cx="8229600" cy="822960"/>
+          <p:cNvSpPr txBox="1"/>
+          <p:nvPr/>
+        </p:nvSpPr>
+        <p:spPr>
+          <a:xfrm>
+            <a:off x="635000" y="635000"/>
+            <a:ext cx="10922000" cy="165100"/>
           </a:xfrm>
           <a:prstGeom prst="rect">
             <a:avLst/>
@@ -4303,51 +4502,62 @@
               <a:buNone/>
             </a:pPr>
             <a:r>
-              <a:rPr lang="en-US" sz="3000" b="1" dirty="0">
+              <a:rPr lang="en-US" sz="1350" spc="200" kern="0" dirty="0">
                 <a:solidFill>
-                  <a:schemeClr val="bg1"/>
+                  <a:srgbClr val="5FFA74"/>
                 </a:solidFill>
+                <a:latin typeface="Geist Mono" pitchFamily="34" charset="0"/>
+                <a:ea typeface="Geist Mono" pitchFamily="34" charset="-122"/>
+                <a:cs typeface="Geist Mono" pitchFamily="34" charset="-120"/>
               </a:rPr>
-              <a:t>Same search, 2.6x more groups</a:t>
-            </a:r>
-            <a:endParaRPr lang="en-US" sz="3000" dirty="0"/>
+              <a:t>// THE RESULT</a:t>
+            </a:r>
+            <a:endParaRPr lang="en-US" sz="1350" dirty="0"/>
+          </a:p>
+        </p:txBody>
+      </p:sp>
+      <p:sp>
+        <p:nvSpPr>
+          <p:cNvPr id="3" name="Text 1"/>
+          <p:cNvSpPr txBox="1"/>
+          <p:nvPr/>
+        </p:nvSpPr>
+        <p:spPr>
+          <a:xfrm>
+            <a:off x="635000" y="927100"/>
+            <a:ext cx="10922000" cy="391160"/>
+          </a:xfrm>
+          <a:prstGeom prst="rect">
+            <a:avLst/>
+          </a:prstGeom>
+          <a:noFill/>
+          <a:ln/>
+        </p:spPr>
+        <p:txBody>
+          <a:bodyPr wrap="square" lIns="0" tIns="0" rIns="0" bIns="0" rtlCol="0" anchor="t"/>
+          <a:lstStyle/>
+          <a:p>
+            <a:pPr indent="0" marL="0">
+              <a:buNone/>
+            </a:pPr>
+            <a:r>
+              <a:rPr lang="en-US" sz="4200" dirty="0">
+                <a:solidFill>
+                  <a:srgbClr val="FFFFFF"/>
+                </a:solidFill>
+                <a:latin typeface="Funnel Display ExtraBold" pitchFamily="34" charset="0"/>
+                <a:ea typeface="Funnel Display ExtraBold" pitchFamily="34" charset="-122"/>
+                <a:cs typeface="Funnel Display ExtraBold" pitchFamily="34" charset="-120"/>
+              </a:rPr>
+              <a:t>SAME SEARCH, 2.6X MORE GROUPS</a:t>
+            </a:r>
+            <a:endParaRPr lang="en-US" sz="4200" dirty="0"/>
           </a:p>
         </p:txBody>
       </p:sp>
       <p:pic>
         <p:nvPicPr>
-          <p:cNvPr id="3" name="Image 0" descr="/Users/hugh/repos/meetup-map/demo/out/before-search-3.png">    </p:cNvPr>
-          <p:cNvPicPr>
-            <a:picLocks noChangeAspect="1"/>
-          </p:cNvPicPr>
-          <p:nvPr/>
-        </p:nvPicPr>
-        <p:blipFill>
-          <a:blip r:embed="rId1"/>
-          <a:stretch>
-            <a:fillRect/>
-          </a:stretch>
-        </p:blipFill>
-        <p:spPr>
-          <a:xfrm>
-            <a:off x="457200" y="1371600"/>
-            <a:ext cx="3931920" cy="2459736"/>
-          </a:xfrm>
-          <a:prstGeom prst="rect">
-            <a:avLst/>
-          </a:prstGeom>
-          <a:effectLst>
-            <a:outerShdw sx="100000" sy="100000" kx="0" ky="0" algn="bl" rotWithShape="0" blurRad="101600" dist="38100" dir="5400000">
-              <a:srgbClr val="000000">
-                <a:alpha val="40000"/>
-              </a:srgbClr>
-            </a:outerShdw>
-          </a:effectLst>
-        </p:spPr>
-      </p:pic>
-      <p:pic>
-        <p:nvPicPr>
-          <p:cNvPr id="4" name="Image 1" descr="/Users/hugh/repos/meetup-map/demo/out/after-search-3.png">    </p:cNvPr>
+          <p:cNvPr id="4" name="Image 0" descr="/Users/hugh/repos/meetup-map/demo/out/before-search-3.png">    </p:cNvPr>
           <p:cNvPicPr>
             <a:picLocks noChangeAspect="1"/>
           </p:cNvPicPr>
@@ -4361,31 +4571,48 @@
         </p:blipFill>
         <p:spPr>
           <a:xfrm>
-            <a:off x="4754880" y="1371600"/>
-            <a:ext cx="3931920" cy="2459736"/>
-          </a:xfrm>
-          <a:prstGeom prst="rect">
-            <a:avLst/>
-          </a:prstGeom>
-          <a:effectLst>
-            <a:outerShdw sx="100000" sy="100000" kx="0" ky="0" algn="bl" rotWithShape="0" blurRad="101600" dist="38100" dir="5400000">
-              <a:srgbClr val="000000">
-                <a:alpha val="40000"/>
-              </a:srgbClr>
-            </a:outerShdw>
-          </a:effectLst>
+            <a:off x="635000" y="1587500"/>
+            <a:ext cx="5270500" cy="3295650"/>
+          </a:xfrm>
+          <a:prstGeom prst="rect">
+            <a:avLst/>
+          </a:prstGeom>
         </p:spPr>
       </p:pic>
-      <p:sp>
-        <p:nvSpPr>
-          <p:cNvPr id="5" name="Text 1"/>
+      <p:pic>
+        <p:nvPicPr>
+          <p:cNvPr id="5" name="Image 1" descr="/Users/hugh/repos/meetup-map/demo/out/after-search-3.png">    </p:cNvPr>
+          <p:cNvPicPr>
+            <a:picLocks noChangeAspect="1"/>
+          </p:cNvPicPr>
+          <p:nvPr/>
+        </p:nvPicPr>
+        <p:blipFill>
+          <a:blip r:embed="rId3"/>
+          <a:stretch>
+            <a:fillRect/>
+          </a:stretch>
+        </p:blipFill>
+        <p:spPr>
+          <a:xfrm>
+            <a:off x="6286500" y="1587500"/>
+            <a:ext cx="5270500" cy="3295650"/>
+          </a:xfrm>
+          <a:prstGeom prst="rect">
+            <a:avLst/>
+          </a:prstGeom>
+        </p:spPr>
+      </p:pic>
+      <p:sp>
+        <p:nvSpPr>
+          <p:cNvPr id="6" name="Text 2"/>
           <p:cNvSpPr txBox="1"/>
           <p:nvPr/>
         </p:nvSpPr>
         <p:spPr>
           <a:xfrm>
-            <a:off x="457200" y="3931920"/>
-            <a:ext cx="3931920" cy="640080"/>
+            <a:off x="635000" y="5010150"/>
+            <a:ext cx="5270500" cy="381000"/>
           </a:xfrm>
           <a:prstGeom prst="rect">
             <a:avLst/>
@@ -4401,95 +4628,84 @@
               <a:buNone/>
             </a:pPr>
             <a:r>
-              <a:rPr lang="en-US" sz="1400" dirty="0">
+              <a:rPr lang="en-US" sz="1650" b="1" dirty="0">
                 <a:solidFill>
-                  <a:schemeClr val="bg2"/>
+                  <a:srgbClr val="FFFFFF"/>
                 </a:solidFill>
+                <a:latin typeface="Inter" pitchFamily="34" charset="0"/>
+                <a:ea typeface="Inter" pitchFamily="34" charset="-122"/>
+                <a:cs typeface="Inter" pitchFamily="34" charset="-120"/>
               </a:rPr>
-              <a:t>Before: 15,442 groups. 'data engineering': 10 results</a:t>
-            </a:r>
-            <a:endParaRPr lang="en-US" sz="1400" dirty="0"/>
-          </a:p>
-        </p:txBody>
-      </p:sp>
-      <p:sp>
-        <p:nvSpPr>
-          <p:cNvPr id="6" name="Text 2"/>
-          <p:cNvSpPr txBox="1"/>
-          <p:nvPr/>
-        </p:nvSpPr>
-        <p:spPr>
-          <a:xfrm>
-            <a:off x="4754880" y="3931920"/>
-            <a:ext cx="3931920" cy="640080"/>
-          </a:xfrm>
-          <a:prstGeom prst="rect">
-            <a:avLst/>
-          </a:prstGeom>
-          <a:noFill/>
-          <a:ln/>
-        </p:spPr>
-        <p:txBody>
-          <a:bodyPr wrap="square" lIns="0" tIns="0" rIns="0" bIns="0" rtlCol="0" anchor="t"/>
-          <a:lstStyle/>
-          <a:p>
+              <a:t>Before: </a:t>
+            </a:r>
             <a:pPr indent="0" marL="0">
               <a:buNone/>
             </a:pPr>
             <a:r>
-              <a:rPr lang="en-US" sz="1400" b="1" dirty="0">
+              <a:rPr lang="en-US" sz="1650" dirty="0">
                 <a:solidFill>
-                  <a:schemeClr val="accent1"/>
+                  <a:srgbClr val="8D9098"/>
                 </a:solidFill>
+                <a:latin typeface="Inter" pitchFamily="34" charset="0"/>
+                <a:ea typeface="Inter" pitchFamily="34" charset="-122"/>
+                <a:cs typeface="Inter" pitchFamily="34" charset="-120"/>
               </a:rPr>
-              <a:t>After: 40,550 groups. 'data engineering': 33 results</a:t>
-            </a:r>
-            <a:endParaRPr lang="en-US" sz="1400" dirty="0"/>
-          </a:p>
-        </p:txBody>
-      </p:sp>
-      <p:sp>
-        <p:nvSpPr>
-          <p:cNvPr id="25" name="Slide Number Placeholder 0"/>
-          <p:cNvSpPr>
-            <a:spLocks noGrp="1"/>
-          </p:cNvSpPr>
-          <p:nvPr>
-            <p:ph type="sldNum" sz="quarter" idx="4294967295"/>
-          </p:nvPr>
-        </p:nvSpPr>
-        <p:spPr>
-          <a:xfrm>
-            <a:off x="8412480" y="4754880"/>
-            <a:ext cx="457200" cy="274320"/>
-          </a:xfrm>
-          <a:prstGeom prst="rect">
-            <a:avLst/>
-          </a:prstGeom>
-          <a:extLst>
-            <a:ext uri="{C572A759-6A51-4108-AA02-DFA0A04FC94B}">
-              <ma14:wrappingTextBoxFlag xmlns:ma14="http://schemas.microsoft.com/office/mac/drawingml/2011/main" val="0"/>
-            </a:ext>
-          </a:extLst>
-        </p:spPr>
-        <p:txBody>
-          <a:bodyPr/>
-          <a:lstStyle>
-            <a:lvl1pPr>
-              <a:defRPr sz="1000">
+              <a:t>15,442 groups. "data engineering": 10 results.</a:t>
+            </a:r>
+            <a:endParaRPr lang="en-US" sz="1650" dirty="0"/>
+          </a:p>
+        </p:txBody>
+      </p:sp>
+      <p:sp>
+        <p:nvSpPr>
+          <p:cNvPr id="7" name="Text 3"/>
+          <p:cNvSpPr txBox="1"/>
+          <p:nvPr/>
+        </p:nvSpPr>
+        <p:spPr>
+          <a:xfrm>
+            <a:off x="6286500" y="5010150"/>
+            <a:ext cx="5270500" cy="381000"/>
+          </a:xfrm>
+          <a:prstGeom prst="rect">
+            <a:avLst/>
+          </a:prstGeom>
+          <a:noFill/>
+          <a:ln/>
+        </p:spPr>
+        <p:txBody>
+          <a:bodyPr wrap="square" lIns="0" tIns="0" rIns="0" bIns="0" rtlCol="0" anchor="t"/>
+          <a:lstStyle/>
+          <a:p>
+            <a:pPr indent="0" marL="0">
+              <a:buNone/>
+            </a:pPr>
+            <a:r>
+              <a:rPr lang="en-US" sz="1650" b="1" dirty="0">
                 <a:solidFill>
-                  <a:schemeClr val="accent6"/>
+                  <a:srgbClr val="5FFA74"/>
                 </a:solidFill>
-              </a:defRPr>
-            </a:lvl1pPr>
-          </a:lstStyle>
-          <a:p>
-            <a:pPr algn="l"/>
-            <a:fld id="{F7021451-1387-4CA6-816F-3879F97B5CBC}" type="slidenum">
-              <a:rPr b="0" lang="en-US"/>
-              <a:t>8</a:t>
-            </a:fld>
-            <a:endParaRPr lang="en-US"/>
+                <a:latin typeface="Inter" pitchFamily="34" charset="0"/>
+                <a:ea typeface="Inter" pitchFamily="34" charset="-122"/>
+                <a:cs typeface="Inter" pitchFamily="34" charset="-120"/>
+              </a:rPr>
+              <a:t>After: </a:t>
+            </a:r>
+            <a:pPr indent="0" marL="0">
+              <a:buNone/>
+            </a:pPr>
+            <a:r>
+              <a:rPr lang="en-US" sz="1650" dirty="0">
+                <a:solidFill>
+                  <a:srgbClr val="5FFA74"/>
+                </a:solidFill>
+                <a:latin typeface="Inter" pitchFamily="34" charset="0"/>
+                <a:ea typeface="Inter" pitchFamily="34" charset="-122"/>
+                <a:cs typeface="Inter" pitchFamily="34" charset="-120"/>
+              </a:rPr>
+              <a:t>40,550 groups. "data engineering": 33 results.</a:t>
+            </a:r>
+            <a:endParaRPr lang="en-US" sz="1650" dirty="0"/>
           </a:p>
         </p:txBody>
       </p:sp>
@@ -4504,6 +4720,20 @@
 <file path=ppt/slides/slide9.xml><?xml version="1.0" encoding="utf-8"?>
 <p:sld xmlns:a="http://schemas.openxmlformats.org/drawingml/2006/main" xmlns:r="http://schemas.openxmlformats.org/officeDocument/2006/relationships" xmlns:p="http://schemas.openxmlformats.org/presentationml/2006/main">
   <p:cSld name="Slide 9">
+    <p:bg>
+      <p:bgPr>
+        <a:blipFill dpi="0" rotWithShape="1">
+          <a:blip r:embed="rId1">
+            <a:lum/>
+          </a:blip>
+          <a:srcRect/>
+          <a:stretch>
+            <a:fillRect/>
+          </a:stretch>
+        </a:blipFill>
+        <a:effectLst/>
+      </p:bgPr>
+    </p:bg>
     <p:spTree>
       <p:nvGrpSpPr>
         <p:cNvPr id="1" name=""/>
@@ -4521,15 +4751,13 @@
       <p:sp>
         <p:nvSpPr>
           <p:cNvPr id="2" name="Text 0"/>
-          <p:cNvSpPr/>
-          <p:nvPr>
-            <p:ph idx="100" type="title" hasCustomPrompt="1"/>
-          </p:nvPr>
-        </p:nvSpPr>
-        <p:spPr>
-          <a:xfrm>
-            <a:off x="457200" y="274320"/>
-            <a:ext cx="8229600" cy="822960"/>
+          <p:cNvSpPr txBox="1"/>
+          <p:nvPr/>
+        </p:nvSpPr>
+        <p:spPr>
+          <a:xfrm>
+            <a:off x="635000" y="635000"/>
+            <a:ext cx="10922000" cy="165100"/>
           </a:xfrm>
           <a:prstGeom prst="rect">
             <a:avLst/>
@@ -4545,14 +4773,17 @@
               <a:buNone/>
             </a:pPr>
             <a:r>
-              <a:rPr lang="en-US" sz="3000" b="1" dirty="0">
+              <a:rPr lang="en-US" sz="1350" spc="200" kern="0" dirty="0">
                 <a:solidFill>
-                  <a:schemeClr val="bg1"/>
+                  <a:srgbClr val="5FFA74"/>
                 </a:solidFill>
+                <a:latin typeface="Geist Mono" pitchFamily="34" charset="0"/>
+                <a:ea typeface="Geist Mono" pitchFamily="34" charset="-122"/>
+                <a:cs typeface="Geist Mono" pitchFamily="34" charset="-120"/>
               </a:rPr>
-              <a:t>What we did not measure</a:t>
-            </a:r>
-            <a:endParaRPr lang="en-US" sz="3000" dirty="0"/>
+              <a:t>// THE HONEST BIT</a:t>
+            </a:r>
+            <a:endParaRPr lang="en-US" sz="1350" dirty="0"/>
           </a:p>
         </p:txBody>
       </p:sp>
@@ -4564,8 +4795,8 @@
         </p:nvSpPr>
         <p:spPr>
           <a:xfrm>
-            <a:off x="457200" y="1371600"/>
-            <a:ext cx="8229600" cy="2560320"/>
+            <a:off x="635000" y="927100"/>
+            <a:ext cx="10922000" cy="391160"/>
           </a:xfrm>
           <a:prstGeom prst="rect">
             <a:avLst/>
@@ -4575,94 +4806,100 @@
         </p:spPr>
         <p:txBody>
           <a:bodyPr wrap="square" lIns="0" tIns="0" rIns="0" bIns="0" rtlCol="0" anchor="t"/>
-          <a:lstStyle/>
-          <a:p>
-            <a:pPr marL="342900" indent="-342900">
-              <a:spcAft>
-                <a:spcPts val="1400"/>
-              </a:spcAft>
-              <a:buSzPct val="100000"/>
-              <a:buChar char="•"/>
-            </a:pPr>
-            <a:r>
-              <a:rPr lang="en-US" sz="2200" dirty="0">
-                <a:solidFill>
-                  <a:schemeClr val="bg1"/>
-                </a:solidFill>
-              </a:rPr>
-              <a:t>Quality of the agent's picks: unchecked</a:t>
-            </a:r>
-            <a:endParaRPr lang="en-US" sz="2200" dirty="0"/>
-          </a:p>
-          <a:p>
-            <a:pPr marL="342900" indent="-342900">
-              <a:spcAft>
-                <a:spcPts val="1400"/>
-              </a:spcAft>
-              <a:buSzPct val="100000"/>
-              <a:buChar char="•"/>
-            </a:pPr>
-            <a:r>
-              <a:rPr lang="en-US" sz="2200" dirty="0">
-                <a:solidFill>
-                  <a:schemeClr val="bg1"/>
-                </a:solidFill>
-              </a:rPr>
-              <a:t>Cost: a 25-group sample at list price, extrapolated</a:t>
-            </a:r>
-            <a:endParaRPr lang="en-US" sz="2200" dirty="0"/>
-          </a:p>
-          <a:p>
-            <a:pPr marL="342900" indent="-342900">
-              <a:spcAft>
-                <a:spcPts val="1400"/>
-              </a:spcAft>
-              <a:buSzPct val="100000"/>
-              <a:buChar char="•"/>
-            </a:pPr>
-            <a:r>
-              <a:rPr lang="en-US" sz="2200" dirty="0">
-                <a:solidFill>
-                  <a:schemeClr val="bg1"/>
-                </a:solidFill>
-              </a:rPr>
-              <a:t>Our first fix for the Luma scraper was wrong. We found out by checking dates, not labels</a:t>
-            </a:r>
-            <a:endParaRPr lang="en-US" sz="2200" dirty="0"/>
-          </a:p>
-        </p:txBody>
-      </p:sp>
-      <p:sp>
-        <p:nvSpPr>
-          <p:cNvPr id="4" name="Text 2"/>
-          <p:cNvSpPr txBox="1"/>
-          <p:nvPr/>
-        </p:nvSpPr>
-        <p:spPr>
-          <a:xfrm>
-            <a:off x="457200" y="4114800"/>
-            <a:ext cx="8229600" cy="457200"/>
-          </a:xfrm>
-          <a:prstGeom prst="rect">
-            <a:avLst/>
-          </a:prstGeom>
-          <a:noFill/>
-          <a:ln/>
-        </p:spPr>
-        <p:txBody>
-          <a:bodyPr wrap="square" lIns="0" tIns="0" rIns="0" bIns="0" rtlCol="0" anchor="ctr"/>
           <a:lstStyle/>
           <a:p>
             <a:pPr indent="0" marL="0">
               <a:buNone/>
             </a:pPr>
             <a:r>
+              <a:rPr lang="en-US" sz="4200" dirty="0">
+                <a:solidFill>
+                  <a:srgbClr val="FFFFFF"/>
+                </a:solidFill>
+                <a:latin typeface="Funnel Display ExtraBold" pitchFamily="34" charset="0"/>
+                <a:ea typeface="Funnel Display ExtraBold" pitchFamily="34" charset="-122"/>
+                <a:cs typeface="Funnel Display ExtraBold" pitchFamily="34" charset="-120"/>
+              </a:rPr>
+              <a:t>WHAT WE DID NOT MEASURE</a:t>
+            </a:r>
+            <a:endParaRPr lang="en-US" sz="4200" dirty="0"/>
+          </a:p>
+        </p:txBody>
+      </p:sp>
+      <p:sp>
+        <p:nvSpPr>
+          <p:cNvPr id="4" name="Shape 2"/>
+          <p:cNvSpPr/>
+          <p:nvPr/>
+        </p:nvSpPr>
+        <p:spPr>
+          <a:xfrm>
+            <a:off x="635000" y="1587500"/>
+            <a:ext cx="10922000" cy="698500"/>
+          </a:xfrm>
+          <a:prstGeom prst="rect">
+            <a:avLst/>
+          </a:prstGeom>
+          <a:solidFill>
+            <a:srgbClr val="1D1D1F"/>
+          </a:solidFill>
+          <a:ln/>
+        </p:spPr>
+      </p:sp>
+      <p:sp>
+        <p:nvSpPr>
+          <p:cNvPr id="5" name="Shape 3"/>
+          <p:cNvSpPr/>
+          <p:nvPr/>
+        </p:nvSpPr>
+        <p:spPr>
+          <a:xfrm>
+            <a:off x="838200" y="1803400"/>
+            <a:ext cx="63500" cy="63500"/>
+          </a:xfrm>
+          <a:prstGeom prst="ellipse">
+            <a:avLst/>
+          </a:prstGeom>
+          <a:solidFill>
+            <a:srgbClr val="5FFA74"/>
+          </a:solidFill>
+          <a:ln/>
+        </p:spPr>
+      </p:sp>
+      <p:sp>
+        <p:nvSpPr>
+          <p:cNvPr id="6" name="Text 4"/>
+          <p:cNvSpPr txBox="1"/>
+          <p:nvPr/>
+        </p:nvSpPr>
+        <p:spPr>
+          <a:xfrm>
+            <a:off x="1549400" y="1739900"/>
+            <a:ext cx="9525000" cy="203200"/>
+          </a:xfrm>
+          <a:prstGeom prst="rect">
+            <a:avLst/>
+          </a:prstGeom>
+          <a:noFill/>
+          <a:ln/>
+        </p:spPr>
+        <p:txBody>
+          <a:bodyPr wrap="square" lIns="0" tIns="0" rIns="0" bIns="0" rtlCol="0" anchor="t"/>
+          <a:lstStyle/>
+          <a:p>
+            <a:pPr indent="0" marL="0">
+              <a:buNone/>
+            </a:pPr>
+            <a:r>
               <a:rPr lang="en-US" sz="1800" b="1" dirty="0">
                 <a:solidFill>
-                  <a:schemeClr val="accent2"/>
+                  <a:srgbClr val="FFFFFF"/>
                 </a:solidFill>
+                <a:latin typeface="Inter" pitchFamily="34" charset="0"/>
+                <a:ea typeface="Inter" pitchFamily="34" charset="-122"/>
+                <a:cs typeface="Inter" pitchFamily="34" charset="-120"/>
               </a:rPr>
-              <a:t>Measure cost and quality, or you will pay for retries.</a:t>
+              <a:t>Quality of the agent's picks</a:t>
             </a:r>
             <a:endParaRPr lang="en-US" sz="1800" dirty="0"/>
           </a:p>
@@ -4670,46 +4907,315 @@
       </p:sp>
       <p:sp>
         <p:nvSpPr>
-          <p:cNvPr id="25" name="Slide Number Placeholder 0"/>
-          <p:cNvSpPr>
-            <a:spLocks noGrp="1"/>
-          </p:cNvSpPr>
-          <p:nvPr>
-            <p:ph type="sldNum" sz="quarter" idx="4294967295"/>
-          </p:nvPr>
-        </p:nvSpPr>
-        <p:spPr>
-          <a:xfrm>
-            <a:off x="8412480" y="4754880"/>
-            <a:ext cx="457200" cy="274320"/>
-          </a:xfrm>
-          <a:prstGeom prst="rect">
-            <a:avLst/>
-          </a:prstGeom>
-          <a:extLst>
-            <a:ext uri="{C572A759-6A51-4108-AA02-DFA0A04FC94B}">
-              <ma14:wrappingTextBoxFlag xmlns:ma14="http://schemas.microsoft.com/office/mac/drawingml/2011/main" val="0"/>
-            </a:ext>
-          </a:extLst>
-        </p:spPr>
-        <p:txBody>
-          <a:bodyPr/>
-          <a:lstStyle>
-            <a:lvl1pPr>
-              <a:defRPr sz="1000">
+          <p:cNvPr id="7" name="Text 5"/>
+          <p:cNvSpPr txBox="1"/>
+          <p:nvPr/>
+        </p:nvSpPr>
+        <p:spPr>
+          <a:xfrm>
+            <a:off x="1549400" y="1968500"/>
+            <a:ext cx="9525000" cy="177800"/>
+          </a:xfrm>
+          <a:prstGeom prst="rect">
+            <a:avLst/>
+          </a:prstGeom>
+          <a:noFill/>
+          <a:ln/>
+        </p:spPr>
+        <p:txBody>
+          <a:bodyPr wrap="square" lIns="0" tIns="0" rIns="0" bIns="0" rtlCol="0" anchor="t"/>
+          <a:lstStyle/>
+          <a:p>
+            <a:pPr indent="0" marL="0">
+              <a:buNone/>
+            </a:pPr>
+            <a:r>
+              <a:rPr lang="en-US" sz="1350" dirty="0">
                 <a:solidFill>
-                  <a:schemeClr val="accent6"/>
+                  <a:srgbClr val="8D9098"/>
                 </a:solidFill>
-              </a:defRPr>
-            </a:lvl1pPr>
-          </a:lstStyle>
-          <a:p>
-            <a:pPr algn="l"/>
-            <a:fld id="{F7021451-1387-4CA6-816F-3879F97B5CBC}" type="slidenum">
-              <a:rPr b="0" lang="en-US"/>
-              <a:t>9</a:t>
-            </a:fld>
-            <a:endParaRPr lang="en-US"/>
+                <a:latin typeface="Inter" pitchFamily="34" charset="0"/>
+                <a:ea typeface="Inter" pitchFamily="34" charset="-122"/>
+                <a:cs typeface="Inter" pitchFamily="34" charset="-120"/>
+              </a:rPr>
+              <a:t>Unchecked. Treat the four priority 1 groups as examples, not a result.</a:t>
+            </a:r>
+            <a:endParaRPr lang="en-US" sz="1350" dirty="0"/>
+          </a:p>
+        </p:txBody>
+      </p:sp>
+      <p:sp>
+        <p:nvSpPr>
+          <p:cNvPr id="8" name="Shape 6"/>
+          <p:cNvSpPr/>
+          <p:nvPr/>
+        </p:nvSpPr>
+        <p:spPr>
+          <a:xfrm>
+            <a:off x="635000" y="2387600"/>
+            <a:ext cx="10922000" cy="698500"/>
+          </a:xfrm>
+          <a:prstGeom prst="rect">
+            <a:avLst/>
+          </a:prstGeom>
+          <a:solidFill>
+            <a:srgbClr val="1D1D1F"/>
+          </a:solidFill>
+          <a:ln/>
+        </p:spPr>
+      </p:sp>
+      <p:sp>
+        <p:nvSpPr>
+          <p:cNvPr id="9" name="Shape 7"/>
+          <p:cNvSpPr/>
+          <p:nvPr/>
+        </p:nvSpPr>
+        <p:spPr>
+          <a:xfrm>
+            <a:off x="838200" y="2603500"/>
+            <a:ext cx="63500" cy="63500"/>
+          </a:xfrm>
+          <a:prstGeom prst="ellipse">
+            <a:avLst/>
+          </a:prstGeom>
+          <a:solidFill>
+            <a:srgbClr val="5FFA74"/>
+          </a:solidFill>
+          <a:ln/>
+        </p:spPr>
+      </p:sp>
+      <p:sp>
+        <p:nvSpPr>
+          <p:cNvPr id="10" name="Text 8"/>
+          <p:cNvSpPr txBox="1"/>
+          <p:nvPr/>
+        </p:nvSpPr>
+        <p:spPr>
+          <a:xfrm>
+            <a:off x="1549400" y="2540000"/>
+            <a:ext cx="9525000" cy="203200"/>
+          </a:xfrm>
+          <a:prstGeom prst="rect">
+            <a:avLst/>
+          </a:prstGeom>
+          <a:noFill/>
+          <a:ln/>
+        </p:spPr>
+        <p:txBody>
+          <a:bodyPr wrap="square" lIns="0" tIns="0" rIns="0" bIns="0" rtlCol="0" anchor="t"/>
+          <a:lstStyle/>
+          <a:p>
+            <a:pPr indent="0" marL="0">
+              <a:buNone/>
+            </a:pPr>
+            <a:r>
+              <a:rPr lang="en-US" sz="1800" b="1" dirty="0">
+                <a:solidFill>
+                  <a:srgbClr val="FFFFFF"/>
+                </a:solidFill>
+                <a:latin typeface="Inter" pitchFamily="34" charset="0"/>
+                <a:ea typeface="Inter" pitchFamily="34" charset="-122"/>
+                <a:cs typeface="Inter" pitchFamily="34" charset="-120"/>
+              </a:rPr>
+              <a:t>Cost</a:t>
+            </a:r>
+            <a:endParaRPr lang="en-US" sz="1800" dirty="0"/>
+          </a:p>
+        </p:txBody>
+      </p:sp>
+      <p:sp>
+        <p:nvSpPr>
+          <p:cNvPr id="11" name="Text 9"/>
+          <p:cNvSpPr txBox="1"/>
+          <p:nvPr/>
+        </p:nvSpPr>
+        <p:spPr>
+          <a:xfrm>
+            <a:off x="1549400" y="2768600"/>
+            <a:ext cx="9525000" cy="177800"/>
+          </a:xfrm>
+          <a:prstGeom prst="rect">
+            <a:avLst/>
+          </a:prstGeom>
+          <a:noFill/>
+          <a:ln/>
+        </p:spPr>
+        <p:txBody>
+          <a:bodyPr wrap="square" lIns="0" tIns="0" rIns="0" bIns="0" rtlCol="0" anchor="t"/>
+          <a:lstStyle/>
+          <a:p>
+            <a:pPr indent="0" marL="0">
+              <a:buNone/>
+            </a:pPr>
+            <a:r>
+              <a:rPr lang="en-US" sz="1350" dirty="0">
+                <a:solidFill>
+                  <a:srgbClr val="8D9098"/>
+                </a:solidFill>
+                <a:latin typeface="Inter" pitchFamily="34" charset="0"/>
+                <a:ea typeface="Inter" pitchFamily="34" charset="-122"/>
+                <a:cs typeface="Inter" pitchFamily="34" charset="-120"/>
+              </a:rPr>
+              <a:t>A 25-group sample at list price, extrapolated to the backlog.</a:t>
+            </a:r>
+            <a:endParaRPr lang="en-US" sz="1350" dirty="0"/>
+          </a:p>
+        </p:txBody>
+      </p:sp>
+      <p:sp>
+        <p:nvSpPr>
+          <p:cNvPr id="12" name="Shape 10"/>
+          <p:cNvSpPr/>
+          <p:nvPr/>
+        </p:nvSpPr>
+        <p:spPr>
+          <a:xfrm>
+            <a:off x="635000" y="3187700"/>
+            <a:ext cx="10922000" cy="698500"/>
+          </a:xfrm>
+          <a:prstGeom prst="rect">
+            <a:avLst/>
+          </a:prstGeom>
+          <a:solidFill>
+            <a:srgbClr val="1D1D1F"/>
+          </a:solidFill>
+          <a:ln/>
+        </p:spPr>
+      </p:sp>
+      <p:sp>
+        <p:nvSpPr>
+          <p:cNvPr id="13" name="Shape 11"/>
+          <p:cNvSpPr/>
+          <p:nvPr/>
+        </p:nvSpPr>
+        <p:spPr>
+          <a:xfrm>
+            <a:off x="838200" y="3403600"/>
+            <a:ext cx="63500" cy="63500"/>
+          </a:xfrm>
+          <a:prstGeom prst="ellipse">
+            <a:avLst/>
+          </a:prstGeom>
+          <a:solidFill>
+            <a:srgbClr val="5FFA74"/>
+          </a:solidFill>
+          <a:ln/>
+        </p:spPr>
+      </p:sp>
+      <p:sp>
+        <p:nvSpPr>
+          <p:cNvPr id="14" name="Text 12"/>
+          <p:cNvSpPr txBox="1"/>
+          <p:nvPr/>
+        </p:nvSpPr>
+        <p:spPr>
+          <a:xfrm>
+            <a:off x="1549400" y="3340100"/>
+            <a:ext cx="9525000" cy="203200"/>
+          </a:xfrm>
+          <a:prstGeom prst="rect">
+            <a:avLst/>
+          </a:prstGeom>
+          <a:noFill/>
+          <a:ln/>
+        </p:spPr>
+        <p:txBody>
+          <a:bodyPr wrap="square" lIns="0" tIns="0" rIns="0" bIns="0" rtlCol="0" anchor="t"/>
+          <a:lstStyle/>
+          <a:p>
+            <a:pPr indent="0" marL="0">
+              <a:buNone/>
+            </a:pPr>
+            <a:r>
+              <a:rPr lang="en-US" sz="1800" b="1" dirty="0">
+                <a:solidFill>
+                  <a:srgbClr val="FFFFFF"/>
+                </a:solidFill>
+                <a:latin typeface="Inter" pitchFamily="34" charset="0"/>
+                <a:ea typeface="Inter" pitchFamily="34" charset="-122"/>
+                <a:cs typeface="Inter" pitchFamily="34" charset="-120"/>
+              </a:rPr>
+              <a:t>Our first Luma fix</a:t>
+            </a:r>
+            <a:endParaRPr lang="en-US" sz="1800" dirty="0"/>
+          </a:p>
+        </p:txBody>
+      </p:sp>
+      <p:sp>
+        <p:nvSpPr>
+          <p:cNvPr id="15" name="Text 13"/>
+          <p:cNvSpPr txBox="1"/>
+          <p:nvPr/>
+        </p:nvSpPr>
+        <p:spPr>
+          <a:xfrm>
+            <a:off x="1549400" y="3568700"/>
+            <a:ext cx="9525000" cy="177800"/>
+          </a:xfrm>
+          <a:prstGeom prst="rect">
+            <a:avLst/>
+          </a:prstGeom>
+          <a:noFill/>
+          <a:ln/>
+        </p:spPr>
+        <p:txBody>
+          <a:bodyPr wrap="square" lIns="0" tIns="0" rIns="0" bIns="0" rtlCol="0" anchor="t"/>
+          <a:lstStyle/>
+          <a:p>
+            <a:pPr indent="0" marL="0">
+              <a:buNone/>
+            </a:pPr>
+            <a:r>
+              <a:rPr lang="en-US" sz="1350" dirty="0">
+                <a:solidFill>
+                  <a:srgbClr val="8D9098"/>
+                </a:solidFill>
+                <a:latin typeface="Inter" pitchFamily="34" charset="0"/>
+                <a:ea typeface="Inter" pitchFamily="34" charset="-122"/>
+                <a:cs typeface="Inter" pitchFamily="34" charset="-120"/>
+              </a:rPr>
+              <a:t>It was wrong. We caught it by checking dates, not labels.</a:t>
+            </a:r>
+            <a:endParaRPr lang="en-US" sz="1350" dirty="0"/>
+          </a:p>
+        </p:txBody>
+      </p:sp>
+      <p:sp>
+        <p:nvSpPr>
+          <p:cNvPr id="16" name="Text 14"/>
+          <p:cNvSpPr txBox="1"/>
+          <p:nvPr/>
+        </p:nvSpPr>
+        <p:spPr>
+          <a:xfrm>
+            <a:off x="635000" y="4191000"/>
+            <a:ext cx="10922000" cy="279400"/>
+          </a:xfrm>
+          <a:prstGeom prst="rect">
+            <a:avLst/>
+          </a:prstGeom>
+          <a:noFill/>
+          <a:ln/>
+        </p:spPr>
+        <p:txBody>
+          <a:bodyPr wrap="square" lIns="0" tIns="0" rIns="0" bIns="0" rtlCol="0" anchor="t"/>
+          <a:lstStyle/>
+          <a:p>
+            <a:pPr indent="0" marL="0">
+              <a:buNone/>
+            </a:pPr>
+            <a:r>
+              <a:rPr lang="en-US" sz="2250" b="1" dirty="0">
+                <a:solidFill>
+                  <a:srgbClr val="FFFFFF"/>
+                </a:solidFill>
+                <a:latin typeface="Inter" pitchFamily="34" charset="0"/>
+                <a:ea typeface="Inter" pitchFamily="34" charset="-122"/>
+                <a:cs typeface="Inter" pitchFamily="34" charset="-120"/>
+              </a:rPr>
+              <a:t>Measure cost + quality, or pay for retries.</a:t>
+            </a:r>
+            <a:endParaRPr lang="en-US" sz="2250" dirty="0"/>
           </a:p>
         </p:txBody>
       </p:sp>
@@ -4722,49 +5228,49 @@
 </file>
 
 <file path=ppt/theme/theme1.xml><?xml version="1.0" encoding="utf-8"?>
-<a:theme xmlns:a="http://schemas.openxmlformats.org/drawingml/2006/main" name="Aiven case study (dark)">
+<a:theme xmlns:a="http://schemas.openxmlformats.org/drawingml/2006/main" name="Office Theme">
   <a:themeElements>
-    <a:clrScheme name="Aiven case study (dark)">
+    <a:clrScheme name="Office">
       <a:dk1>
-        <a:srgbClr val="16171A"/>
+        <a:sysClr val="windowText" lastClr="000000"/>
       </a:dk1>
       <a:lt1>
-        <a:srgbClr val="F4F4F4"/>
+        <a:sysClr val="window" lastClr="FFFFFF"/>
       </a:lt1>
       <a:dk2>
-        <a:srgbClr val="1F2021"/>
+        <a:srgbClr val="44546A"/>
       </a:dk2>
       <a:lt2>
-        <a:srgbClr val="B5B5B7"/>
+        <a:srgbClr val="E7E6E6"/>
       </a:lt2>
       <a:accent1>
-        <a:srgbClr val="1BB2B0"/>
+        <a:srgbClr val="4472C4"/>
       </a:accent1>
       <a:accent2>
-        <a:srgbClr val="FFC21A"/>
+        <a:srgbClr val="ED7D31"/>
       </a:accent2>
       <a:accent3>
-        <a:srgbClr val="6F64FF"/>
+        <a:srgbClr val="A5A5A5"/>
       </a:accent3>
       <a:accent4>
-        <a:srgbClr val="21D16B"/>
+        <a:srgbClr val="FFC000"/>
       </a:accent4>
       <a:accent5>
-        <a:srgbClr val="C224D5"/>
+        <a:srgbClr val="5B9BD5"/>
       </a:accent5>
       <a:accent6>
-        <a:srgbClr val="444547"/>
+        <a:srgbClr val="70AD47"/>
       </a:accent6>
       <a:hlink>
-        <a:srgbClr val="2ED0CD"/>
+        <a:srgbClr val="0563C1"/>
       </a:hlink>
       <a:folHlink>
-        <a:srgbClr val="B5B5B7"/>
+        <a:srgbClr val="954F72"/>
       </a:folHlink>
     </a:clrScheme>
-    <a:fontScheme name="Aiven case study (dark)">
+    <a:fontScheme name="Office">
       <a:majorFont>
-        <a:latin typeface="Calibri"/>
+        <a:latin typeface="Calibri Light" panose="020F0302020204030204"/>
         <a:ea typeface=""/>
         <a:cs typeface=""/>
         <a:font script="Jpan" typeface="游ゴシック Light"/>
@@ -4816,7 +5322,7 @@
         <a:font script="Tfng" typeface="Ebrima"/>
       </a:majorFont>
       <a:minorFont>
-        <a:latin typeface="Calibri"/>
+        <a:latin typeface="Calibri" panose="020F0502020204030204"/>
         <a:ea typeface=""/>
         <a:cs typeface=""/>
         <a:font script="Jpan" typeface="游ゴシック"/>

</xml_diff>